<commit_message>
Update presentation to Hebrew version
Co-Authored-By: Claude <noreply@anthropic.com>
</commit_message>
<xml_diff>
--- a/University_Tour_Presentation.pptx
+++ b/University_Tour_Presentation.pptx
@@ -3107,8 +3107,162 @@
         </p:nvSpPr>
         <p:spPr>
           <a:xfrm>
-            <a:off x="8046720" y="1280160"/>
-            <a:ext cx="3749039" cy="5303520"/>
+            <a:off x="0" y="0"/>
+            <a:ext cx="12188952" cy="1188720"/>
+          </a:xfrm>
+          <a:prstGeom prst="rect">
+            <a:avLst/>
+          </a:prstGeom>
+          <a:solidFill>
+            <a:srgbClr val="1B6CA8"/>
+          </a:solidFill>
+          <a:ln>
+            <a:noFill/>
+          </a:ln>
+        </p:spPr>
+        <p:style>
+          <a:lnRef idx="1">
+            <a:schemeClr val="accent1"/>
+          </a:lnRef>
+          <a:fillRef idx="3">
+            <a:schemeClr val="accent1"/>
+          </a:fillRef>
+          <a:effectRef idx="2">
+            <a:schemeClr val="accent1"/>
+          </a:effectRef>
+          <a:fontRef idx="minor">
+            <a:schemeClr val="lt1"/>
+          </a:fontRef>
+        </p:style>
+        <p:txBody>
+          <a:bodyPr rtlCol="0" anchor="ctr"/>
+          <a:lstStyle/>
+          <a:p>
+            <a:pPr algn="ctr"/>
+          </a:p>
+        </p:txBody>
+      </p:sp>
+      <p:sp>
+        <p:nvSpPr>
+          <p:cNvPr id="3" name="Rectangle 2"/>
+          <p:cNvSpPr/>
+          <p:nvPr/>
+        </p:nvSpPr>
+        <p:spPr>
+          <a:xfrm>
+            <a:off x="0" y="1188720"/>
+            <a:ext cx="12188952" cy="45720"/>
+          </a:xfrm>
+          <a:prstGeom prst="rect">
+            <a:avLst/>
+          </a:prstGeom>
+          <a:solidFill>
+            <a:srgbClr val="F5C518"/>
+          </a:solidFill>
+          <a:ln>
+            <a:noFill/>
+          </a:ln>
+        </p:spPr>
+        <p:style>
+          <a:lnRef idx="1">
+            <a:schemeClr val="accent1"/>
+          </a:lnRef>
+          <a:fillRef idx="3">
+            <a:schemeClr val="accent1"/>
+          </a:fillRef>
+          <a:effectRef idx="2">
+            <a:schemeClr val="accent1"/>
+          </a:effectRef>
+          <a:fontRef idx="minor">
+            <a:schemeClr val="lt1"/>
+          </a:fontRef>
+        </p:style>
+        <p:txBody>
+          <a:bodyPr rtlCol="0" anchor="ctr"/>
+          <a:lstStyle/>
+          <a:p>
+            <a:pPr algn="ctr"/>
+          </a:p>
+        </p:txBody>
+      </p:sp>
+      <p:sp>
+        <p:nvSpPr>
+          <p:cNvPr id="4" name="TextBox 3"/>
+          <p:cNvSpPr txBox="1"/>
+          <p:nvPr/>
+        </p:nvSpPr>
+        <p:spPr>
+          <a:xfrm>
+            <a:off x="365760" y="91440"/>
+            <a:ext cx="11430000" cy="685800"/>
+          </a:xfrm>
+          <a:prstGeom prst="rect">
+            <a:avLst/>
+          </a:prstGeom>
+          <a:noFill/>
+        </p:spPr>
+        <p:txBody>
+          <a:bodyPr wrap="square">
+            <a:spAutoFit/>
+          </a:bodyPr>
+          <a:lstStyle/>
+          <a:p>
+            <a:pPr algn="r"/>
+            <a:r>
+              <a:rPr sz="3200" b="1" i="0">
+                <a:solidFill>
+                  <a:srgbClr val="FFFFFF"/>
+                </a:solidFill>
+              </a:rPr>
+              <a:t>סיור באוניברסיטה</a:t>
+            </a:r>
+          </a:p>
+        </p:txBody>
+      </p:sp>
+      <p:sp>
+        <p:nvSpPr>
+          <p:cNvPr id="5" name="TextBox 4"/>
+          <p:cNvSpPr txBox="1"/>
+          <p:nvPr/>
+        </p:nvSpPr>
+        <p:spPr>
+          <a:xfrm>
+            <a:off x="365760" y="749808"/>
+            <a:ext cx="11430000" cy="384048"/>
+          </a:xfrm>
+          <a:prstGeom prst="rect">
+            <a:avLst/>
+          </a:prstGeom>
+          <a:noFill/>
+        </p:spPr>
+        <p:txBody>
+          <a:bodyPr wrap="square">
+            <a:spAutoFit/>
+          </a:bodyPr>
+          <a:lstStyle/>
+          <a:p>
+            <a:pPr algn="r"/>
+            <a:r>
+              <a:rPr sz="1500" b="0" i="1">
+                <a:solidFill>
+                  <a:srgbClr val="F5C518"/>
+                </a:solidFill>
+              </a:rPr>
+              <a:t>שקופית 1 — תיאור המערכת</a:t>
+            </a:r>
+          </a:p>
+        </p:txBody>
+      </p:sp>
+      <p:sp>
+        <p:nvSpPr>
+          <p:cNvPr id="6" name="Rectangle 5"/>
+          <p:cNvSpPr/>
+          <p:nvPr/>
+        </p:nvSpPr>
+        <p:spPr>
+          <a:xfrm>
+            <a:off x="274320" y="1325880"/>
+            <a:ext cx="3657600" cy="5303520"/>
           </a:xfrm>
           <a:prstGeom prst="rect">
             <a:avLst/>
@@ -3144,14 +3298,319 @@
       </p:sp>
       <p:sp>
         <p:nvSpPr>
-          <p:cNvPr id="3" name="Rectangle 2"/>
+          <p:cNvPr id="7" name="TextBox 6"/>
+          <p:cNvSpPr txBox="1"/>
+          <p:nvPr/>
+        </p:nvSpPr>
+        <p:spPr>
+          <a:xfrm>
+            <a:off x="4114800" y="1417320"/>
+            <a:ext cx="7772400" cy="457200"/>
+          </a:xfrm>
+          <a:prstGeom prst="rect">
+            <a:avLst/>
+          </a:prstGeom>
+          <a:noFill/>
+        </p:spPr>
+        <p:txBody>
+          <a:bodyPr wrap="square">
+            <a:spAutoFit/>
+          </a:bodyPr>
+          <a:lstStyle/>
+          <a:p>
+            <a:pPr algn="r"/>
+            <a:r>
+              <a:rPr sz="2000" b="1" i="0">
+                <a:solidFill>
+                  <a:srgbClr val="F5C518"/>
+                </a:solidFill>
+              </a:rPr>
+              <a:t>מה זה?</a:t>
+            </a:r>
+          </a:p>
+        </p:txBody>
+      </p:sp>
+      <p:sp>
+        <p:nvSpPr>
+          <p:cNvPr id="8" name="TextBox 7"/>
+          <p:cNvSpPr txBox="1"/>
+          <p:nvPr/>
+        </p:nvSpPr>
+        <p:spPr>
+          <a:xfrm>
+            <a:off x="4114800" y="1874519"/>
+            <a:ext cx="7772400" cy="1828800"/>
+          </a:xfrm>
+          <a:prstGeom prst="rect">
+            <a:avLst/>
+          </a:prstGeom>
+          <a:noFill/>
+        </p:spPr>
+        <p:txBody>
+          <a:bodyPr wrap="square">
+            <a:spAutoFit/>
+          </a:bodyPr>
+          <a:lstStyle/>
+          <a:p>
+            <a:pPr algn="r"/>
+            <a:r>
+              <a:rPr sz="1700">
+                <a:solidFill>
+                  <a:srgbClr val="FFFFFF"/>
+                </a:solidFill>
+              </a:rPr>
+              <a:t>● משחק לוח בסגנון מונופולי בנושא קורסי אוניברסיטה</a:t>
+            </a:r>
+          </a:p>
+          <a:p>
+            <a:pPr algn="r"/>
+            <a:r>
+              <a:rPr sz="1700">
+                <a:solidFill>
+                  <a:srgbClr val="FFFFFF"/>
+                </a:solidFill>
+              </a:rPr>
+              <a:t>● 2–4 שחקנים: אנושיים או בוטים</a:t>
+            </a:r>
+          </a:p>
+          <a:p>
+            <a:pPr algn="r"/>
+            <a:r>
+              <a:rPr sz="1700">
+                <a:solidFill>
+                  <a:srgbClr val="FFFFFF"/>
+                </a:solidFill>
+              </a:rPr>
+              <a:t>● לוח של 36 ריבועים: נכסים, תחנות וריבועים מיוחדים</a:t>
+            </a:r>
+          </a:p>
+          <a:p>
+            <a:pPr algn="r"/>
+            <a:r>
+              <a:rPr sz="1700">
+                <a:solidFill>
+                  <a:srgbClr val="FFFFFF"/>
+                </a:solidFill>
+              </a:rPr>
+              <a:t>● שתי גרסאות: קונסול (JOptionPane) וממשק גרפי מלא (Swing GUI)</a:t>
+            </a:r>
+          </a:p>
+        </p:txBody>
+      </p:sp>
+      <p:sp>
+        <p:nvSpPr>
+          <p:cNvPr id="9" name="TextBox 8"/>
+          <p:cNvSpPr txBox="1"/>
+          <p:nvPr/>
+        </p:nvSpPr>
+        <p:spPr>
+          <a:xfrm>
+            <a:off x="4114800" y="3794760"/>
+            <a:ext cx="7772400" cy="457200"/>
+          </a:xfrm>
+          <a:prstGeom prst="rect">
+            <a:avLst/>
+          </a:prstGeom>
+          <a:noFill/>
+        </p:spPr>
+        <p:txBody>
+          <a:bodyPr wrap="square">
+            <a:spAutoFit/>
+          </a:bodyPr>
+          <a:lstStyle/>
+          <a:p>
+            <a:pPr algn="r"/>
+            <a:r>
+              <a:rPr sz="2000" b="1" i="0">
+                <a:solidFill>
+                  <a:srgbClr val="F5C518"/>
+                </a:solidFill>
+              </a:rPr>
+              <a:t>תכונות עיקריות</a:t>
+            </a:r>
+          </a:p>
+        </p:txBody>
+      </p:sp>
+      <p:sp>
+        <p:nvSpPr>
+          <p:cNvPr id="10" name="TextBox 9"/>
+          <p:cNvSpPr txBox="1"/>
+          <p:nvPr/>
+        </p:nvSpPr>
+        <p:spPr>
+          <a:xfrm>
+            <a:off x="4114800" y="4251960"/>
+            <a:ext cx="7772400" cy="2103120"/>
+          </a:xfrm>
+          <a:prstGeom prst="rect">
+            <a:avLst/>
+          </a:prstGeom>
+          <a:noFill/>
+        </p:spPr>
+        <p:txBody>
+          <a:bodyPr wrap="square">
+            <a:spAutoFit/>
+          </a:bodyPr>
+          <a:lstStyle/>
+          <a:p>
+            <a:pPr algn="r"/>
+            <a:r>
+              <a:rPr sz="1700">
+                <a:solidFill>
+                  <a:srgbClr val="FFFFFF"/>
+                </a:solidFill>
+              </a:rPr>
+              <a:t>● קנייה ושדרוג נכסים: קרקע ← בית 1 ← בית 2 ← בית 3 ← מלון</a:t>
+            </a:r>
+          </a:p>
+          <a:p>
+            <a:pPr algn="r"/>
+            <a:r>
+              <a:rPr sz="1700">
+                <a:solidFill>
+                  <a:srgbClr val="FFFFFF"/>
+                </a:solidFill>
+              </a:rPr>
+              <a:t>● מיני-גיים רולטה בריבוע התחלה — 10 סוגי הימור, עד 35:1</a:t>
+            </a:r>
+          </a:p>
+          <a:p>
+            <a:pPr algn="r"/>
+            <a:r>
+              <a:rPr sz="1700">
+                <a:solidFill>
+                  <a:srgbClr val="FFFFFF"/>
+                </a:solidFill>
+              </a:rPr>
+              <a:t>● שדה תעופה (טלפורט), כלא, מכפיל אליפות עולמית</a:t>
+            </a:r>
+          </a:p>
+          <a:p>
+            <a:pPr algn="r"/>
+            <a:r>
+              <a:rPr sz="1700">
+                <a:solidFill>
+                  <a:srgbClr val="FFFFFF"/>
+                </a:solidFill>
+              </a:rPr>
+              <a:t>● 3 תנאי ניצחון: 4 תחנות | 3 מונופולים | שורה מלאה</a:t>
+            </a:r>
+          </a:p>
+        </p:txBody>
+      </p:sp>
+      <p:sp>
+        <p:nvSpPr>
+          <p:cNvPr id="11" name="TextBox 10"/>
+          <p:cNvSpPr txBox="1"/>
+          <p:nvPr/>
+        </p:nvSpPr>
+        <p:spPr>
+          <a:xfrm>
+            <a:off x="457200" y="1645920"/>
+            <a:ext cx="3200400" cy="1280160"/>
+          </a:xfrm>
+          <a:prstGeom prst="rect">
+            <a:avLst/>
+          </a:prstGeom>
+          <a:noFill/>
+        </p:spPr>
+        <p:txBody>
+          <a:bodyPr wrap="square">
+            <a:spAutoFit/>
+          </a:bodyPr>
+          <a:lstStyle/>
+          <a:p>
+            <a:pPr algn="ctr"/>
+            <a:r>
+              <a:rPr sz="7200" b="0" i="0">
+                <a:solidFill>
+                  <a:srgbClr val="FFFFFF"/>
+                </a:solidFill>
+              </a:rPr>
+              <a:t>🎓</a:t>
+            </a:r>
+          </a:p>
+        </p:txBody>
+      </p:sp>
+      <p:sp>
+        <p:nvSpPr>
+          <p:cNvPr id="12" name="TextBox 11"/>
+          <p:cNvSpPr txBox="1"/>
+          <p:nvPr/>
+        </p:nvSpPr>
+        <p:spPr>
+          <a:xfrm>
+            <a:off x="365760" y="2926080"/>
+            <a:ext cx="3383280" cy="1280160"/>
+          </a:xfrm>
+          <a:prstGeom prst="rect">
+            <a:avLst/>
+          </a:prstGeom>
+          <a:noFill/>
+        </p:spPr>
+        <p:txBody>
+          <a:bodyPr wrap="square">
+            <a:spAutoFit/>
+          </a:bodyPr>
+          <a:lstStyle/>
+          <a:p>
+            <a:pPr algn="ctr"/>
+            <a:r>
+              <a:rPr sz="2400" b="1" i="0">
+                <a:solidFill>
+                  <a:srgbClr val="F5C518"/>
+                </a:solidFill>
+              </a:rPr>
+              <a:t>סיור
+באוניברסיטה</a:t>
+            </a:r>
+          </a:p>
+        </p:txBody>
+      </p:sp>
+      <p:sp>
+        <p:nvSpPr>
+          <p:cNvPr id="13" name="TextBox 12"/>
+          <p:cNvSpPr txBox="1"/>
+          <p:nvPr/>
+        </p:nvSpPr>
+        <p:spPr>
+          <a:xfrm>
+            <a:off x="365760" y="4251960"/>
+            <a:ext cx="3383280" cy="548640"/>
+          </a:xfrm>
+          <a:prstGeom prst="rect">
+            <a:avLst/>
+          </a:prstGeom>
+          <a:noFill/>
+        </p:spPr>
+        <p:txBody>
+          <a:bodyPr wrap="square">
+            <a:spAutoFit/>
+          </a:bodyPr>
+          <a:lstStyle/>
+          <a:p>
+            <a:pPr algn="ctr"/>
+            <a:r>
+              <a:rPr sz="1200" b="0" i="1">
+                <a:solidFill>
+                  <a:srgbClr val="D0E4F7"/>
+                </a:solidFill>
+              </a:rPr>
+              <a:t>משחק לוח בסגנון מונופולי</a:t>
+            </a:r>
+          </a:p>
+        </p:txBody>
+      </p:sp>
+      <p:sp>
+        <p:nvSpPr>
+          <p:cNvPr id="14" name="Rectangle 13"/>
           <p:cNvSpPr/>
           <p:nvPr/>
         </p:nvSpPr>
         <p:spPr>
           <a:xfrm>
-            <a:off x="0" y="0"/>
-            <a:ext cx="12188952" cy="1188720"/>
+            <a:off x="365760" y="6217920"/>
+            <a:ext cx="2560320" cy="502920"/>
           </a:xfrm>
           <a:prstGeom prst="rect">
             <a:avLst/>
@@ -3187,57 +3646,14 @@
       </p:sp>
       <p:sp>
         <p:nvSpPr>
-          <p:cNvPr id="4" name="Rectangle 3"/>
-          <p:cNvSpPr/>
-          <p:nvPr/>
-        </p:nvSpPr>
-        <p:spPr>
-          <a:xfrm>
-            <a:off x="0" y="1188720"/>
-            <a:ext cx="12188952" cy="45720"/>
-          </a:xfrm>
-          <a:prstGeom prst="rect">
-            <a:avLst/>
-          </a:prstGeom>
-          <a:solidFill>
-            <a:srgbClr val="F5C518"/>
-          </a:solidFill>
-          <a:ln>
-            <a:noFill/>
-          </a:ln>
-        </p:spPr>
-        <p:style>
-          <a:lnRef idx="1">
-            <a:schemeClr val="accent1"/>
-          </a:lnRef>
-          <a:fillRef idx="3">
-            <a:schemeClr val="accent1"/>
-          </a:fillRef>
-          <a:effectRef idx="2">
-            <a:schemeClr val="accent1"/>
-          </a:effectRef>
-          <a:fontRef idx="minor">
-            <a:schemeClr val="lt1"/>
-          </a:fontRef>
-        </p:style>
-        <p:txBody>
-          <a:bodyPr rtlCol="0" anchor="ctr"/>
-          <a:lstStyle/>
-          <a:p>
-            <a:pPr algn="ctr"/>
-          </a:p>
-        </p:txBody>
-      </p:sp>
-      <p:sp>
-        <p:nvSpPr>
-          <p:cNvPr id="5" name="TextBox 4"/>
+          <p:cNvPr id="15" name="TextBox 14"/>
           <p:cNvSpPr txBox="1"/>
           <p:nvPr/>
         </p:nvSpPr>
         <p:spPr>
           <a:xfrm>
-            <a:off x="365760" y="91440"/>
-            <a:ext cx="9144000" cy="685800"/>
+            <a:off x="365760" y="6236208"/>
+            <a:ext cx="2560320" cy="256032"/>
           </a:xfrm>
           <a:prstGeom prst="rect">
             <a:avLst/>
@@ -3250,28 +3666,28 @@
           </a:bodyPr>
           <a:lstStyle/>
           <a:p>
-            <a:pPr algn="l"/>
-            <a:r>
-              <a:rPr sz="3200" b="1" i="0">
-                <a:solidFill>
-                  <a:srgbClr val="FFFFFF"/>
-                </a:solidFill>
-              </a:rPr>
-              <a:t>University Tour</a:t>
-            </a:r>
-          </a:p>
-        </p:txBody>
-      </p:sp>
-      <p:sp>
-        <p:nvSpPr>
-          <p:cNvPr id="6" name="TextBox 5"/>
+            <a:pPr algn="ctr"/>
+            <a:r>
+              <a:rPr sz="1800" b="1" i="0">
+                <a:solidFill>
+                  <a:srgbClr val="F5C518"/>
+                </a:solidFill>
+              </a:rPr>
+              <a:t>36</a:t>
+            </a:r>
+          </a:p>
+        </p:txBody>
+      </p:sp>
+      <p:sp>
+        <p:nvSpPr>
+          <p:cNvPr id="16" name="TextBox 15"/>
           <p:cNvSpPr txBox="1"/>
           <p:nvPr/>
         </p:nvSpPr>
         <p:spPr>
           <a:xfrm>
-            <a:off x="365760" y="731520"/>
-            <a:ext cx="9144000" cy="411480"/>
+            <a:off x="365760" y="6492240"/>
+            <a:ext cx="2560320" cy="256032"/>
           </a:xfrm>
           <a:prstGeom prst="rect">
             <a:avLst/>
@@ -3284,326 +3700,28 @@
           </a:bodyPr>
           <a:lstStyle/>
           <a:p>
-            <a:pPr algn="l"/>
-            <a:r>
-              <a:rPr sz="1600" b="0" i="1">
-                <a:solidFill>
-                  <a:srgbClr val="F5C518"/>
-                </a:solidFill>
-              </a:rPr>
-              <a:t>Slide 1 — System Description</a:t>
-            </a:r>
-          </a:p>
-        </p:txBody>
-      </p:sp>
-      <p:sp>
-        <p:nvSpPr>
-          <p:cNvPr id="7" name="TextBox 6"/>
-          <p:cNvSpPr txBox="1"/>
-          <p:nvPr/>
-        </p:nvSpPr>
-        <p:spPr>
-          <a:xfrm>
-            <a:off x="365760" y="1417320"/>
-            <a:ext cx="7315200" cy="457200"/>
-          </a:xfrm>
-          <a:prstGeom prst="rect">
-            <a:avLst/>
-          </a:prstGeom>
-          <a:noFill/>
-        </p:spPr>
-        <p:txBody>
-          <a:bodyPr wrap="square">
-            <a:spAutoFit/>
-          </a:bodyPr>
-          <a:lstStyle/>
-          <a:p>
-            <a:pPr algn="l"/>
-            <a:r>
-              <a:rPr sz="2000" b="1" i="0">
-                <a:solidFill>
-                  <a:srgbClr val="F5C518"/>
-                </a:solidFill>
-              </a:rPr>
-              <a:t>What is it?</a:t>
-            </a:r>
-          </a:p>
-        </p:txBody>
-      </p:sp>
-      <p:sp>
-        <p:nvSpPr>
-          <p:cNvPr id="8" name="TextBox 7"/>
-          <p:cNvSpPr txBox="1"/>
-          <p:nvPr/>
-        </p:nvSpPr>
-        <p:spPr>
-          <a:xfrm>
-            <a:off x="365760" y="1874519"/>
-            <a:ext cx="7406640" cy="1828800"/>
-          </a:xfrm>
-          <a:prstGeom prst="rect">
-            <a:avLst/>
-          </a:prstGeom>
-          <a:noFill/>
-        </p:spPr>
-        <p:txBody>
-          <a:bodyPr wrap="square">
-            <a:spAutoFit/>
-          </a:bodyPr>
-          <a:lstStyle/>
-          <a:p>
-            <a:r>
-              <a:rPr sz="1700">
-                <a:solidFill>
-                  <a:srgbClr val="FFFFFF"/>
-                </a:solidFill>
-              </a:rPr>
-              <a:t>●  A Monopoly-style board game themed around university courses</a:t>
-            </a:r>
-          </a:p>
-          <a:p>
-            <a:r>
-              <a:rPr sz="1700">
-                <a:solidFill>
-                  <a:srgbClr val="FFFFFF"/>
-                </a:solidFill>
-              </a:rPr>
-              <a:t>●  2–4 players: Human or Bot</a:t>
-            </a:r>
-          </a:p>
-          <a:p>
-            <a:r>
-              <a:rPr sz="1700">
-                <a:solidFill>
-                  <a:srgbClr val="FFFFFF"/>
-                </a:solidFill>
-              </a:rPr>
-              <a:t>●  36-tile board with properties, stations &amp; special squares</a:t>
-            </a:r>
-          </a:p>
-          <a:p>
-            <a:r>
-              <a:rPr sz="1700">
-                <a:solidFill>
-                  <a:srgbClr val="FFFFFF"/>
-                </a:solidFill>
-              </a:rPr>
-              <a:t>●  Two versions: Console (JOptionPane) and full Swing GUI</a:t>
-            </a:r>
-          </a:p>
-        </p:txBody>
-      </p:sp>
-      <p:sp>
-        <p:nvSpPr>
-          <p:cNvPr id="9" name="TextBox 8"/>
-          <p:cNvSpPr txBox="1"/>
-          <p:nvPr/>
-        </p:nvSpPr>
-        <p:spPr>
-          <a:xfrm>
-            <a:off x="365760" y="3794760"/>
-            <a:ext cx="7315200" cy="457200"/>
-          </a:xfrm>
-          <a:prstGeom prst="rect">
-            <a:avLst/>
-          </a:prstGeom>
-          <a:noFill/>
-        </p:spPr>
-        <p:txBody>
-          <a:bodyPr wrap="square">
-            <a:spAutoFit/>
-          </a:bodyPr>
-          <a:lstStyle/>
-          <a:p>
-            <a:pPr algn="l"/>
-            <a:r>
-              <a:rPr sz="2000" b="1" i="0">
-                <a:solidFill>
-                  <a:srgbClr val="F5C518"/>
-                </a:solidFill>
-              </a:rPr>
-              <a:t>Key Features</a:t>
-            </a:r>
-          </a:p>
-        </p:txBody>
-      </p:sp>
-      <p:sp>
-        <p:nvSpPr>
-          <p:cNvPr id="10" name="TextBox 9"/>
-          <p:cNvSpPr txBox="1"/>
-          <p:nvPr/>
-        </p:nvSpPr>
-        <p:spPr>
-          <a:xfrm>
-            <a:off x="365760" y="4251960"/>
-            <a:ext cx="7406640" cy="2103120"/>
-          </a:xfrm>
-          <a:prstGeom prst="rect">
-            <a:avLst/>
-          </a:prstGeom>
-          <a:noFill/>
-        </p:spPr>
-        <p:txBody>
-          <a:bodyPr wrap="square">
-            <a:spAutoFit/>
-          </a:bodyPr>
-          <a:lstStyle/>
-          <a:p>
-            <a:r>
-              <a:rPr sz="1700">
-                <a:solidFill>
-                  <a:srgbClr val="FFFFFF"/>
-                </a:solidFill>
-              </a:rPr>
-              <a:t>●  Buy &amp; upgrade properties (Land → 1-3 Houses → Hotel)</a:t>
-            </a:r>
-          </a:p>
-          <a:p>
-            <a:r>
-              <a:rPr sz="1700">
-                <a:solidFill>
-                  <a:srgbClr val="FFFFFF"/>
-                </a:solidFill>
-              </a:rPr>
-              <a:t>●  Casino Roulette mini-game on Start tile  (10 bet types, up to 35:1)</a:t>
-            </a:r>
-          </a:p>
-          <a:p>
-            <a:r>
-              <a:rPr sz="1700">
-                <a:solidFill>
-                  <a:srgbClr val="FFFFFF"/>
-                </a:solidFill>
-              </a:rPr>
-              <a:t>●  Airport teleport, Jail mechanic, World Championships multiplier</a:t>
-            </a:r>
-          </a:p>
-          <a:p>
-            <a:r>
-              <a:rPr sz="1700">
-                <a:solidFill>
-                  <a:srgbClr val="FFFFFF"/>
-                </a:solidFill>
-              </a:rPr>
-              <a:t>●  3 win conditions: 4 Stations | 3 Monopolies | Full board side</a:t>
-            </a:r>
-          </a:p>
-        </p:txBody>
-      </p:sp>
-      <p:sp>
-        <p:nvSpPr>
-          <p:cNvPr id="11" name="TextBox 10"/>
-          <p:cNvSpPr txBox="1"/>
-          <p:nvPr/>
-        </p:nvSpPr>
-        <p:spPr>
-          <a:xfrm>
-            <a:off x="8229600" y="1554480"/>
-            <a:ext cx="3200400" cy="1371600"/>
-          </a:xfrm>
-          <a:prstGeom prst="rect">
-            <a:avLst/>
-          </a:prstGeom>
-          <a:noFill/>
-        </p:spPr>
-        <p:txBody>
-          <a:bodyPr wrap="square">
-            <a:spAutoFit/>
-          </a:bodyPr>
-          <a:lstStyle/>
-          <a:p>
-            <a:pPr algn="ctr"/>
-            <a:r>
-              <a:rPr sz="7200" b="0" i="0">
-                <a:solidFill>
-                  <a:srgbClr val="FFFFFF"/>
-                </a:solidFill>
-              </a:rPr>
-              <a:t>🎓</a:t>
-            </a:r>
-          </a:p>
-        </p:txBody>
-      </p:sp>
-      <p:sp>
-        <p:nvSpPr>
-          <p:cNvPr id="12" name="TextBox 11"/>
-          <p:cNvSpPr txBox="1"/>
-          <p:nvPr/>
-        </p:nvSpPr>
-        <p:spPr>
-          <a:xfrm>
-            <a:off x="8138160" y="2926080"/>
-            <a:ext cx="3200400" cy="1371600"/>
-          </a:xfrm>
-          <a:prstGeom prst="rect">
-            <a:avLst/>
-          </a:prstGeom>
-          <a:noFill/>
-        </p:spPr>
-        <p:txBody>
-          <a:bodyPr wrap="square">
-            <a:spAutoFit/>
-          </a:bodyPr>
-          <a:lstStyle/>
-          <a:p>
-            <a:pPr algn="ctr"/>
-            <a:r>
-              <a:rPr sz="2600" b="1" i="0">
-                <a:solidFill>
-                  <a:srgbClr val="F5C518"/>
-                </a:solidFill>
-              </a:rPr>
-              <a:t>UNIVERSITY
-TOUR</a:t>
-            </a:r>
-          </a:p>
-        </p:txBody>
-      </p:sp>
-      <p:sp>
-        <p:nvSpPr>
-          <p:cNvPr id="13" name="TextBox 12"/>
-          <p:cNvSpPr txBox="1"/>
-          <p:nvPr/>
-        </p:nvSpPr>
-        <p:spPr>
-          <a:xfrm>
-            <a:off x="8138160" y="4297680"/>
-            <a:ext cx="3200400" cy="731520"/>
-          </a:xfrm>
-          <a:prstGeom prst="rect">
-            <a:avLst/>
-          </a:prstGeom>
-          <a:noFill/>
-        </p:spPr>
-        <p:txBody>
-          <a:bodyPr wrap="square">
-            <a:spAutoFit/>
-          </a:bodyPr>
-          <a:lstStyle/>
-          <a:p>
-            <a:pPr algn="ctr"/>
-            <a:r>
-              <a:rPr sz="1400" b="0" i="1">
+            <a:pPr algn="ctr"/>
+            <a:r>
+              <a:rPr sz="1100" b="0" i="0">
                 <a:solidFill>
                   <a:srgbClr val="D0E4F7"/>
                 </a:solidFill>
               </a:rPr>
-              <a:t>A Monopoly-Style
-Board Game</a:t>
-            </a:r>
-          </a:p>
-        </p:txBody>
-      </p:sp>
-      <p:sp>
-        <p:nvSpPr>
-          <p:cNvPr id="14" name="Rectangle 13"/>
+              <a:t>ריבועים</a:t>
+            </a:r>
+          </a:p>
+        </p:txBody>
+      </p:sp>
+      <p:sp>
+        <p:nvSpPr>
+          <p:cNvPr id="17" name="Rectangle 16"/>
           <p:cNvSpPr/>
           <p:nvPr/>
         </p:nvSpPr>
         <p:spPr>
           <a:xfrm>
-            <a:off x="365760" y="6217920"/>
-            <a:ext cx="1554480" cy="502920"/>
+            <a:off x="3200400" y="6217920"/>
+            <a:ext cx="2560320" cy="502920"/>
           </a:xfrm>
           <a:prstGeom prst="rect">
             <a:avLst/>
@@ -3639,14 +3757,14 @@
       </p:sp>
       <p:sp>
         <p:nvSpPr>
-          <p:cNvPr id="15" name="TextBox 14"/>
+          <p:cNvPr id="18" name="TextBox 17"/>
           <p:cNvSpPr txBox="1"/>
           <p:nvPr/>
         </p:nvSpPr>
         <p:spPr>
           <a:xfrm>
-            <a:off x="365760" y="6236208"/>
-            <a:ext cx="1554480" cy="274320"/>
+            <a:off x="3200400" y="6236208"/>
+            <a:ext cx="2560320" cy="256032"/>
           </a:xfrm>
           <a:prstGeom prst="rect">
             <a:avLst/>
@@ -3666,21 +3784,21 @@
                   <a:srgbClr val="F5C518"/>
                 </a:solidFill>
               </a:rPr>
-              <a:t>36</a:t>
-            </a:r>
-          </a:p>
-        </p:txBody>
-      </p:sp>
-      <p:sp>
-        <p:nvSpPr>
-          <p:cNvPr id="16" name="TextBox 15"/>
+              <a:t>24</a:t>
+            </a:r>
+          </a:p>
+        </p:txBody>
+      </p:sp>
+      <p:sp>
+        <p:nvSpPr>
+          <p:cNvPr id="19" name="TextBox 18"/>
           <p:cNvSpPr txBox="1"/>
           <p:nvPr/>
         </p:nvSpPr>
         <p:spPr>
           <a:xfrm>
-            <a:off x="365760" y="6492240"/>
-            <a:ext cx="1554480" cy="274320"/>
+            <a:off x="3200400" y="6492240"/>
+            <a:ext cx="2560320" cy="256032"/>
           </a:xfrm>
           <a:prstGeom prst="rect">
             <a:avLst/>
@@ -3700,21 +3818,21 @@
                   <a:srgbClr val="D0E4F7"/>
                 </a:solidFill>
               </a:rPr>
-              <a:t>Tiles</a:t>
-            </a:r>
-          </a:p>
-        </p:txBody>
-      </p:sp>
-      <p:sp>
-        <p:nvSpPr>
-          <p:cNvPr id="17" name="Rectangle 16"/>
+              <a:t>נכסים</a:t>
+            </a:r>
+          </a:p>
+        </p:txBody>
+      </p:sp>
+      <p:sp>
+        <p:nvSpPr>
+          <p:cNvPr id="20" name="Rectangle 19"/>
           <p:cNvSpPr/>
           <p:nvPr/>
         </p:nvSpPr>
         <p:spPr>
           <a:xfrm>
-            <a:off x="2194560" y="6217920"/>
-            <a:ext cx="1554480" cy="502920"/>
+            <a:off x="6035040" y="6217920"/>
+            <a:ext cx="2560320" cy="502920"/>
           </a:xfrm>
           <a:prstGeom prst="rect">
             <a:avLst/>
@@ -3750,14 +3868,14 @@
       </p:sp>
       <p:sp>
         <p:nvSpPr>
-          <p:cNvPr id="18" name="TextBox 17"/>
+          <p:cNvPr id="21" name="TextBox 20"/>
           <p:cNvSpPr txBox="1"/>
           <p:nvPr/>
         </p:nvSpPr>
         <p:spPr>
           <a:xfrm>
-            <a:off x="2194560" y="6236208"/>
-            <a:ext cx="1554480" cy="274320"/>
+            <a:off x="6035040" y="6236208"/>
+            <a:ext cx="2560320" cy="256032"/>
           </a:xfrm>
           <a:prstGeom prst="rect">
             <a:avLst/>
@@ -3777,21 +3895,21 @@
                   <a:srgbClr val="F5C518"/>
                 </a:solidFill>
               </a:rPr>
-              <a:t>24</a:t>
-            </a:r>
-          </a:p>
-        </p:txBody>
-      </p:sp>
-      <p:sp>
-        <p:nvSpPr>
-          <p:cNvPr id="19" name="TextBox 18"/>
+              <a:t>4</a:t>
+            </a:r>
+          </a:p>
+        </p:txBody>
+      </p:sp>
+      <p:sp>
+        <p:nvSpPr>
+          <p:cNvPr id="22" name="TextBox 21"/>
           <p:cNvSpPr txBox="1"/>
           <p:nvPr/>
         </p:nvSpPr>
         <p:spPr>
           <a:xfrm>
-            <a:off x="2194560" y="6492240"/>
-            <a:ext cx="1554480" cy="274320"/>
+            <a:off x="6035040" y="6492240"/>
+            <a:ext cx="2560320" cy="256032"/>
           </a:xfrm>
           <a:prstGeom prst="rect">
             <a:avLst/>
@@ -3811,21 +3929,21 @@
                   <a:srgbClr val="D0E4F7"/>
                 </a:solidFill>
               </a:rPr>
-              <a:t>Properties</a:t>
-            </a:r>
-          </a:p>
-        </p:txBody>
-      </p:sp>
-      <p:sp>
-        <p:nvSpPr>
-          <p:cNvPr id="20" name="Rectangle 19"/>
+              <a:t>תחנות</a:t>
+            </a:r>
+          </a:p>
+        </p:txBody>
+      </p:sp>
+      <p:sp>
+        <p:nvSpPr>
+          <p:cNvPr id="23" name="Rectangle 22"/>
           <p:cNvSpPr/>
           <p:nvPr/>
         </p:nvSpPr>
         <p:spPr>
           <a:xfrm>
-            <a:off x="4023360" y="6217920"/>
-            <a:ext cx="1554480" cy="502920"/>
+            <a:off x="8869680" y="6217920"/>
+            <a:ext cx="2560320" cy="502920"/>
           </a:xfrm>
           <a:prstGeom prst="rect">
             <a:avLst/>
@@ -3861,14 +3979,14 @@
       </p:sp>
       <p:sp>
         <p:nvSpPr>
-          <p:cNvPr id="21" name="TextBox 20"/>
+          <p:cNvPr id="24" name="TextBox 23"/>
           <p:cNvSpPr txBox="1"/>
           <p:nvPr/>
         </p:nvSpPr>
         <p:spPr>
           <a:xfrm>
-            <a:off x="4023360" y="6236208"/>
-            <a:ext cx="1554480" cy="274320"/>
+            <a:off x="8869680" y="6236208"/>
+            <a:ext cx="2560320" cy="256032"/>
           </a:xfrm>
           <a:prstGeom prst="rect">
             <a:avLst/>
@@ -3888,21 +4006,21 @@
                   <a:srgbClr val="F5C518"/>
                 </a:solidFill>
               </a:rPr>
-              <a:t>4</a:t>
-            </a:r>
-          </a:p>
-        </p:txBody>
-      </p:sp>
-      <p:sp>
-        <p:nvSpPr>
-          <p:cNvPr id="22" name="TextBox 21"/>
+              <a:t>3</a:t>
+            </a:r>
+          </a:p>
+        </p:txBody>
+      </p:sp>
+      <p:sp>
+        <p:nvSpPr>
+          <p:cNvPr id="25" name="TextBox 24"/>
           <p:cNvSpPr txBox="1"/>
           <p:nvPr/>
         </p:nvSpPr>
         <p:spPr>
           <a:xfrm>
-            <a:off x="4023360" y="6492240"/>
-            <a:ext cx="1554480" cy="274320"/>
+            <a:off x="8869680" y="6492240"/>
+            <a:ext cx="2560320" cy="256032"/>
           </a:xfrm>
           <a:prstGeom prst="rect">
             <a:avLst/>
@@ -3922,118 +4040,7 @@
                   <a:srgbClr val="D0E4F7"/>
                 </a:solidFill>
               </a:rPr>
-              <a:t>Stations</a:t>
-            </a:r>
-          </a:p>
-        </p:txBody>
-      </p:sp>
-      <p:sp>
-        <p:nvSpPr>
-          <p:cNvPr id="23" name="Rectangle 22"/>
-          <p:cNvSpPr/>
-          <p:nvPr/>
-        </p:nvSpPr>
-        <p:spPr>
-          <a:xfrm>
-            <a:off x="5852160" y="6217920"/>
-            <a:ext cx="1554480" cy="502920"/>
-          </a:xfrm>
-          <a:prstGeom prst="rect">
-            <a:avLst/>
-          </a:prstGeom>
-          <a:solidFill>
-            <a:srgbClr val="1B6CA8"/>
-          </a:solidFill>
-          <a:ln>
-            <a:noFill/>
-          </a:ln>
-        </p:spPr>
-        <p:style>
-          <a:lnRef idx="1">
-            <a:schemeClr val="accent1"/>
-          </a:lnRef>
-          <a:fillRef idx="3">
-            <a:schemeClr val="accent1"/>
-          </a:fillRef>
-          <a:effectRef idx="2">
-            <a:schemeClr val="accent1"/>
-          </a:effectRef>
-          <a:fontRef idx="minor">
-            <a:schemeClr val="lt1"/>
-          </a:fontRef>
-        </p:style>
-        <p:txBody>
-          <a:bodyPr rtlCol="0" anchor="ctr"/>
-          <a:lstStyle/>
-          <a:p>
-            <a:pPr algn="ctr"/>
-          </a:p>
-        </p:txBody>
-      </p:sp>
-      <p:sp>
-        <p:nvSpPr>
-          <p:cNvPr id="24" name="TextBox 23"/>
-          <p:cNvSpPr txBox="1"/>
-          <p:nvPr/>
-        </p:nvSpPr>
-        <p:spPr>
-          <a:xfrm>
-            <a:off x="5852160" y="6236208"/>
-            <a:ext cx="1554480" cy="274320"/>
-          </a:xfrm>
-          <a:prstGeom prst="rect">
-            <a:avLst/>
-          </a:prstGeom>
-          <a:noFill/>
-        </p:spPr>
-        <p:txBody>
-          <a:bodyPr wrap="square">
-            <a:spAutoFit/>
-          </a:bodyPr>
-          <a:lstStyle/>
-          <a:p>
-            <a:pPr algn="ctr"/>
-            <a:r>
-              <a:rPr sz="1800" b="1" i="0">
-                <a:solidFill>
-                  <a:srgbClr val="F5C518"/>
-                </a:solidFill>
-              </a:rPr>
-              <a:t>3</a:t>
-            </a:r>
-          </a:p>
-        </p:txBody>
-      </p:sp>
-      <p:sp>
-        <p:nvSpPr>
-          <p:cNvPr id="25" name="TextBox 24"/>
-          <p:cNvSpPr txBox="1"/>
-          <p:nvPr/>
-        </p:nvSpPr>
-        <p:spPr>
-          <a:xfrm>
-            <a:off x="5852160" y="6492240"/>
-            <a:ext cx="1554480" cy="274320"/>
-          </a:xfrm>
-          <a:prstGeom prst="rect">
-            <a:avLst/>
-          </a:prstGeom>
-          <a:noFill/>
-        </p:spPr>
-        <p:txBody>
-          <a:bodyPr wrap="square">
-            <a:spAutoFit/>
-          </a:bodyPr>
-          <a:lstStyle/>
-          <a:p>
-            <a:pPr algn="ctr"/>
-            <a:r>
-              <a:rPr sz="1100" b="0" i="0">
-                <a:solidFill>
-                  <a:srgbClr val="D0E4F7"/>
-                </a:solidFill>
-              </a:rPr>
-              <a:t>Win Paths</a:t>
+              <a:t>ניצחון</a:t>
             </a:r>
           </a:p>
         </p:txBody>
@@ -4159,7 +4166,7 @@
         <p:spPr>
           <a:xfrm>
             <a:off x="365760" y="91440"/>
-            <a:ext cx="9144000" cy="685800"/>
+            <a:ext cx="11430000" cy="685800"/>
           </a:xfrm>
           <a:prstGeom prst="rect">
             <a:avLst/>
@@ -4172,14 +4179,14 @@
           </a:bodyPr>
           <a:lstStyle/>
           <a:p>
-            <a:pPr algn="l"/>
+            <a:pPr algn="r"/>
             <a:r>
               <a:rPr sz="3200" b="1" i="0">
                 <a:solidFill>
                   <a:srgbClr val="FFFFFF"/>
                 </a:solidFill>
               </a:rPr>
-              <a:t>Work Plan &amp; Constraints</a:t>
+              <a:t>תכנית עבודה ואילוצים</a:t>
             </a:r>
           </a:p>
         </p:txBody>
@@ -4192,8 +4199,8 @@
         </p:nvSpPr>
         <p:spPr>
           <a:xfrm>
-            <a:off x="365760" y="731520"/>
-            <a:ext cx="9144000" cy="411480"/>
+            <a:off x="365760" y="749808"/>
+            <a:ext cx="11430000" cy="384048"/>
           </a:xfrm>
           <a:prstGeom prst="rect">
             <a:avLst/>
@@ -4206,14 +4213,14 @@
           </a:bodyPr>
           <a:lstStyle/>
           <a:p>
-            <a:pPr algn="l"/>
-            <a:r>
-              <a:rPr sz="1600" b="0" i="1">
+            <a:pPr algn="r"/>
+            <a:r>
+              <a:rPr sz="1500" b="0" i="1">
                 <a:solidFill>
                   <a:srgbClr val="F5C518"/>
                 </a:solidFill>
               </a:rPr>
-              <a:t>Slide 2 — Milestones + Constraints</a:t>
+              <a:t>שקופית 2 — Milestones + אילוצים</a:t>
             </a:r>
           </a:p>
         </p:txBody>
@@ -4226,7 +4233,7 @@
         </p:nvSpPr>
         <p:spPr>
           <a:xfrm>
-            <a:off x="365760" y="1417320"/>
+            <a:off x="6309360" y="1417320"/>
             <a:ext cx="5486400" cy="457200"/>
           </a:xfrm>
           <a:prstGeom prst="rect">
@@ -4240,14 +4247,14 @@
           </a:bodyPr>
           <a:lstStyle/>
           <a:p>
-            <a:pPr algn="l"/>
+            <a:pPr algn="r"/>
             <a:r>
               <a:rPr sz="2000" b="1" i="0">
                 <a:solidFill>
                   <a:srgbClr val="F5C518"/>
                 </a:solidFill>
               </a:rPr>
-              <a:t>Milestones</a:t>
+              <a:t>אבני דרך</a:t>
             </a:r>
           </a:p>
         </p:txBody>
@@ -4260,8 +4267,8 @@
         </p:nvSpPr>
         <p:spPr>
           <a:xfrm>
-            <a:off x="365760" y="1920240"/>
-            <a:ext cx="411480" cy="411480"/>
+            <a:off x="8595360" y="1920240"/>
+            <a:ext cx="384048" cy="384048"/>
           </a:xfrm>
           <a:prstGeom prst="rect">
             <a:avLst/>
@@ -4303,8 +4310,8 @@
         </p:nvSpPr>
         <p:spPr>
           <a:xfrm>
-            <a:off x="365760" y="1920240"/>
-            <a:ext cx="411480" cy="411480"/>
+            <a:off x="8595360" y="1920240"/>
+            <a:ext cx="384048" cy="384048"/>
           </a:xfrm>
           <a:prstGeom prst="rect">
             <a:avLst/>
@@ -4337,8 +4344,8 @@
         </p:nvSpPr>
         <p:spPr>
           <a:xfrm>
-            <a:off x="868680" y="1938528"/>
-            <a:ext cx="5120640" cy="384048"/>
+            <a:off x="6309360" y="1938528"/>
+            <a:ext cx="2194560" cy="384048"/>
           </a:xfrm>
           <a:prstGeom prst="rect">
             <a:avLst/>
@@ -4351,14 +4358,14 @@
           </a:bodyPr>
           <a:lstStyle/>
           <a:p>
-            <a:pPr algn="l"/>
-            <a:r>
-              <a:rPr sz="1500" b="0" i="0">
+            <a:pPr algn="r"/>
+            <a:r>
+              <a:rPr sz="1400" b="0" i="0">
                 <a:solidFill>
                   <a:srgbClr val="FFFFFF"/>
                 </a:solidFill>
               </a:rPr>
-              <a:t>UML design &amp; class division</a:t>
+              <a:t>תכנון UML וחלוקת מחלקות</a:t>
             </a:r>
           </a:p>
         </p:txBody>
@@ -4371,8 +4378,8 @@
         </p:nvSpPr>
         <p:spPr>
           <a:xfrm>
-            <a:off x="365760" y="2587752"/>
-            <a:ext cx="411480" cy="411480"/>
+            <a:off x="8595360" y="2587752"/>
+            <a:ext cx="384048" cy="384048"/>
           </a:xfrm>
           <a:prstGeom prst="rect">
             <a:avLst/>
@@ -4414,8 +4421,8 @@
         </p:nvSpPr>
         <p:spPr>
           <a:xfrm>
-            <a:off x="365760" y="2587752"/>
-            <a:ext cx="411480" cy="411480"/>
+            <a:off x="8595360" y="2587752"/>
+            <a:ext cx="384048" cy="384048"/>
           </a:xfrm>
           <a:prstGeom prst="rect">
             <a:avLst/>
@@ -4448,8 +4455,8 @@
         </p:nvSpPr>
         <p:spPr>
           <a:xfrm>
-            <a:off x="868680" y="2606040"/>
-            <a:ext cx="5120640" cy="384048"/>
+            <a:off x="6309360" y="2606040"/>
+            <a:ext cx="2194560" cy="384048"/>
           </a:xfrm>
           <a:prstGeom prst="rect">
             <a:avLst/>
@@ -4462,14 +4469,14 @@
           </a:bodyPr>
           <a:lstStyle/>
           <a:p>
-            <a:pPr algn="l"/>
-            <a:r>
-              <a:rPr sz="1500" b="0" i="0">
+            <a:pPr algn="r"/>
+            <a:r>
+              <a:rPr sz="1400" b="0" i="0">
                 <a:solidFill>
                   <a:srgbClr val="FFFFFF"/>
                 </a:solidFill>
               </a:rPr>
-              <a:t>Base classes: Player, Tile, Board, Dice</a:t>
+              <a:t>מחלקות בסיס: Player, Tile, Board, Dice</a:t>
             </a:r>
           </a:p>
         </p:txBody>
@@ -4482,8 +4489,8 @@
         </p:nvSpPr>
         <p:spPr>
           <a:xfrm>
-            <a:off x="365760" y="3255264"/>
-            <a:ext cx="411480" cy="411480"/>
+            <a:off x="8595360" y="3255264"/>
+            <a:ext cx="384048" cy="384048"/>
           </a:xfrm>
           <a:prstGeom prst="rect">
             <a:avLst/>
@@ -4525,8 +4532,8 @@
         </p:nvSpPr>
         <p:spPr>
           <a:xfrm>
-            <a:off x="365760" y="3255264"/>
-            <a:ext cx="411480" cy="411480"/>
+            <a:off x="8595360" y="3255264"/>
+            <a:ext cx="384048" cy="384048"/>
           </a:xfrm>
           <a:prstGeom prst="rect">
             <a:avLst/>
@@ -4559,8 +4566,8 @@
         </p:nvSpPr>
         <p:spPr>
           <a:xfrm>
-            <a:off x="868680" y="3273552"/>
-            <a:ext cx="5120640" cy="384048"/>
+            <a:off x="6309360" y="3273552"/>
+            <a:ext cx="2194560" cy="384048"/>
           </a:xfrm>
           <a:prstGeom prst="rect">
             <a:avLst/>
@@ -4573,14 +4580,14 @@
           </a:bodyPr>
           <a:lstStyle/>
           <a:p>
-            <a:pPr algn="l"/>
-            <a:r>
-              <a:rPr sz="1500" b="0" i="0">
+            <a:pPr algn="r"/>
+            <a:r>
+              <a:rPr sz="1400" b="0" i="0">
                 <a:solidFill>
                   <a:srgbClr val="FFFFFF"/>
                 </a:solidFill>
               </a:rPr>
-              <a:t>Core game loop: turns, payments, jail</a:t>
+              <a:t>לולאת משחק: תורות, תשלומים, כלא</a:t>
             </a:r>
           </a:p>
         </p:txBody>
@@ -4593,8 +4600,8 @@
         </p:nvSpPr>
         <p:spPr>
           <a:xfrm>
-            <a:off x="365760" y="3922776"/>
-            <a:ext cx="411480" cy="411480"/>
+            <a:off x="8595360" y="3922776"/>
+            <a:ext cx="384048" cy="384048"/>
           </a:xfrm>
           <a:prstGeom prst="rect">
             <a:avLst/>
@@ -4636,8 +4643,8 @@
         </p:nvSpPr>
         <p:spPr>
           <a:xfrm>
-            <a:off x="365760" y="3922776"/>
-            <a:ext cx="411480" cy="411480"/>
+            <a:off x="8595360" y="3922776"/>
+            <a:ext cx="384048" cy="384048"/>
           </a:xfrm>
           <a:prstGeom prst="rect">
             <a:avLst/>
@@ -4670,8 +4677,8 @@
         </p:nvSpPr>
         <p:spPr>
           <a:xfrm>
-            <a:off x="868680" y="3941063"/>
-            <a:ext cx="5120640" cy="384048"/>
+            <a:off x="6309360" y="3941063"/>
+            <a:ext cx="2194560" cy="384048"/>
           </a:xfrm>
           <a:prstGeom prst="rect">
             <a:avLst/>
@@ -4684,14 +4691,14 @@
           </a:bodyPr>
           <a:lstStyle/>
           <a:p>
-            <a:pPr algn="l"/>
-            <a:r>
-              <a:rPr sz="1500" b="0" i="0">
+            <a:pPr algn="r"/>
+            <a:r>
+              <a:rPr sz="1400" b="0" i="0">
                 <a:solidFill>
                   <a:srgbClr val="FFFFFF"/>
                 </a:solidFill>
               </a:rPr>
-              <a:t>Special tiles: Airport, World Championships, Roulette</a:t>
+              <a:t>טיילים מיוחדים: Airport, WorldChampionships, Roulette</a:t>
             </a:r>
           </a:p>
         </p:txBody>
@@ -4704,8 +4711,8 @@
         </p:nvSpPr>
         <p:spPr>
           <a:xfrm>
-            <a:off x="365760" y="4590288"/>
-            <a:ext cx="411480" cy="411480"/>
+            <a:off x="8595360" y="4590288"/>
+            <a:ext cx="384048" cy="384048"/>
           </a:xfrm>
           <a:prstGeom prst="rect">
             <a:avLst/>
@@ -4747,8 +4754,8 @@
         </p:nvSpPr>
         <p:spPr>
           <a:xfrm>
-            <a:off x="365760" y="4590288"/>
-            <a:ext cx="411480" cy="411480"/>
+            <a:off x="8595360" y="4590288"/>
+            <a:ext cx="384048" cy="384048"/>
           </a:xfrm>
           <a:prstGeom prst="rect">
             <a:avLst/>
@@ -4781,8 +4788,8 @@
         </p:nvSpPr>
         <p:spPr>
           <a:xfrm>
-            <a:off x="868680" y="4608575"/>
-            <a:ext cx="5120640" cy="384048"/>
+            <a:off x="6309360" y="4608575"/>
+            <a:ext cx="2194560" cy="384048"/>
           </a:xfrm>
           <a:prstGeom prst="rect">
             <a:avLst/>
@@ -4795,14 +4802,14 @@
           </a:bodyPr>
           <a:lstStyle/>
           <a:p>
-            <a:pPr algn="l"/>
-            <a:r>
-              <a:rPr sz="1500" b="0" i="0">
+            <a:pPr algn="r"/>
+            <a:r>
+              <a:rPr sz="1400" b="0" i="0">
                 <a:solidFill>
                   <a:srgbClr val="FFFFFF"/>
                 </a:solidFill>
               </a:rPr>
-              <a:t>Full Swing GUI + BoardPanel + SidebarPanel</a:t>
+              <a:t>GUI מלא: BoardPanel, SidebarPanel, דיאלוגים</a:t>
             </a:r>
           </a:p>
         </p:txBody>
@@ -4815,8 +4822,8 @@
         </p:nvSpPr>
         <p:spPr>
           <a:xfrm>
-            <a:off x="365760" y="5257800"/>
-            <a:ext cx="411480" cy="411480"/>
+            <a:off x="8595360" y="5257800"/>
+            <a:ext cx="384048" cy="384048"/>
           </a:xfrm>
           <a:prstGeom prst="rect">
             <a:avLst/>
@@ -4858,8 +4865,8 @@
         </p:nvSpPr>
         <p:spPr>
           <a:xfrm>
-            <a:off x="365760" y="5257800"/>
-            <a:ext cx="411480" cy="411480"/>
+            <a:off x="8595360" y="5257800"/>
+            <a:ext cx="384048" cy="384048"/>
           </a:xfrm>
           <a:prstGeom prst="rect">
             <a:avLst/>
@@ -4892,8 +4899,8 @@
         </p:nvSpPr>
         <p:spPr>
           <a:xfrm>
-            <a:off x="868680" y="5276088"/>
-            <a:ext cx="5120640" cy="384048"/>
+            <a:off x="6309360" y="5276088"/>
+            <a:ext cx="2194560" cy="384048"/>
           </a:xfrm>
           <a:prstGeom prst="rect">
             <a:avLst/>
@@ -4906,14 +4913,14 @@
           </a:bodyPr>
           <a:lstStyle/>
           <a:p>
-            <a:pPr algn="l"/>
-            <a:r>
-              <a:rPr sz="1500" b="0" i="0">
+            <a:pPr algn="r"/>
+            <a:r>
+              <a:rPr sz="1400" b="0" i="0">
                 <a:solidFill>
                   <a:srgbClr val="FFFFFF"/>
                 </a:solidFill>
               </a:rPr>
-              <a:t>Testing, edge cases &amp; final polish</a:t>
+              <a:t>בדיקות, מקרי קצה ועדכון סופי</a:t>
             </a:r>
           </a:p>
         </p:txBody>
@@ -4969,8 +4976,8 @@
         </p:nvSpPr>
         <p:spPr>
           <a:xfrm>
-            <a:off x="6217920" y="1417320"/>
-            <a:ext cx="5577840" cy="457200"/>
+            <a:off x="365760" y="1417320"/>
+            <a:ext cx="5486400" cy="457200"/>
           </a:xfrm>
           <a:prstGeom prst="rect">
             <a:avLst/>
@@ -4983,14 +4990,14 @@
           </a:bodyPr>
           <a:lstStyle/>
           <a:p>
-            <a:pPr algn="l"/>
+            <a:pPr algn="r"/>
             <a:r>
               <a:rPr sz="2000" b="1" i="0">
                 <a:solidFill>
                   <a:srgbClr val="F5C518"/>
                 </a:solidFill>
               </a:rPr>
-              <a:t>Constraints</a:t>
+              <a:t>אילוצים</a:t>
             </a:r>
           </a:p>
         </p:txBody>
@@ -5003,8 +5010,8 @@
         </p:nvSpPr>
         <p:spPr>
           <a:xfrm>
-            <a:off x="6217920" y="1920240"/>
-            <a:ext cx="5577840" cy="4114800"/>
+            <a:off x="365760" y="1920240"/>
+            <a:ext cx="5486400" cy="4114800"/>
           </a:xfrm>
           <a:prstGeom prst="rect">
             <a:avLst/>
@@ -5017,63 +5024,69 @@
           </a:bodyPr>
           <a:lstStyle/>
           <a:p>
+            <a:pPr algn="r"/>
             <a:r>
               <a:rPr sz="1500">
                 <a:solidFill>
                   <a:srgbClr val="D0E4F7"/>
                 </a:solidFill>
               </a:rPr>
-              <a:t>⚠  Java only — standard libraries (javax.swing, java.util)</a:t>
-            </a:r>
-          </a:p>
-          <a:p>
+              <a:t>⚠  Java בלבד — ספריות סטנדרטיות (javax.swing, java.util)</a:t>
+            </a:r>
+          </a:p>
+          <a:p>
+            <a:pPr algn="r"/>
             <a:r>
               <a:rPr sz="1500">
                 <a:solidFill>
                   <a:srgbClr val="D0E4F7"/>
                 </a:solidFill>
               </a:rPr>
-              <a:t>⚠  Must run on any JDK without external dependencies</a:t>
-            </a:r>
-          </a:p>
-          <a:p>
+              <a:t>⚠  ללא תלויות חיצוניות — רץ על כל JDK</a:t>
+            </a:r>
+          </a:p>
+          <a:p>
+            <a:pPr algn="r"/>
             <a:r>
               <a:rPr sz="1500">
                 <a:solidFill>
                   <a:srgbClr val="D0E4F7"/>
                 </a:solidFill>
               </a:rPr>
-              <a:t>⚠  Console &amp; GUI versions must share the same game logic</a:t>
-            </a:r>
-          </a:p>
-          <a:p>
+              <a:t>⚠  גרסת קונסול וגרסת GUI חולקות אותה לוגיקת משחק</a:t>
+            </a:r>
+          </a:p>
+          <a:p>
+            <a:pPr algn="r"/>
             <a:r>
               <a:rPr sz="1500">
                 <a:solidFill>
                   <a:srgbClr val="D0E4F7"/>
                 </a:solidFill>
               </a:rPr>
-              <a:t>⚠  Edge cases: bankruptcy, jail fine, locked 3-Houses rule</a:t>
-            </a:r>
-          </a:p>
-          <a:p>
+              <a:t>⚠  מקרי קצה: פשיטת רגל, קנס כלא, נעילת בית 3</a:t>
+            </a:r>
+          </a:p>
+          <a:p>
+            <a:pPr algn="r"/>
             <a:r>
               <a:rPr sz="1500">
                 <a:solidFill>
                   <a:srgbClr val="D0E4F7"/>
                 </a:solidFill>
               </a:rPr>
-              <a:t>⚠  Bot player must never block the human UI thread</a:t>
-            </a:r>
-          </a:p>
-          <a:p>
+              <a:t>⚠  הבוט לא חוסם את ה-UI thread של השחקן האנושי</a:t>
+            </a:r>
+          </a:p>
+          <a:p>
+            <a:pPr algn="r"/>
             <a:r>
               <a:rPr sz="1500">
                 <a:solidFill>
                   <a:srgbClr val="D0E4F7"/>
                 </a:solidFill>
               </a:rPr>
-              <a:t>⚠  Submission deadline: 10.7</a:t>
+              <a:t>⚠  מועד הגשה: 10.7</a:t>
             </a:r>
           </a:p>
         </p:txBody>
@@ -5199,7 +5212,7 @@
         <p:spPr>
           <a:xfrm>
             <a:off x="365760" y="91440"/>
-            <a:ext cx="9144000" cy="685800"/>
+            <a:ext cx="11430000" cy="685800"/>
           </a:xfrm>
           <a:prstGeom prst="rect">
             <a:avLst/>
@@ -5212,14 +5225,14 @@
           </a:bodyPr>
           <a:lstStyle/>
           <a:p>
-            <a:pPr algn="l"/>
+            <a:pPr algn="r"/>
             <a:r>
               <a:rPr sz="3200" b="1" i="0">
                 <a:solidFill>
                   <a:srgbClr val="FFFFFF"/>
                 </a:solidFill>
               </a:rPr>
-              <a:t>Project Functionality</a:t>
+              <a:t>פונקציונליות הפרויקט</a:t>
             </a:r>
           </a:p>
         </p:txBody>
@@ -5232,8 +5245,8 @@
         </p:nvSpPr>
         <p:spPr>
           <a:xfrm>
-            <a:off x="365760" y="731520"/>
-            <a:ext cx="9144000" cy="411480"/>
+            <a:off x="365760" y="749808"/>
+            <a:ext cx="11430000" cy="384048"/>
           </a:xfrm>
           <a:prstGeom prst="rect">
             <a:avLst/>
@@ -5246,14 +5259,14 @@
           </a:bodyPr>
           <a:lstStyle/>
           <a:p>
-            <a:pPr algn="l"/>
-            <a:r>
-              <a:rPr sz="1600" b="0" i="1">
+            <a:pPr algn="r"/>
+            <a:r>
+              <a:rPr sz="1500" b="0" i="1">
                 <a:solidFill>
                   <a:srgbClr val="F5C518"/>
                 </a:solidFill>
               </a:rPr>
-              <a:t>Slide 3 — Features &amp; Game Flow</a:t>
+              <a:t>שקופית 3 — תכונות וזרימת משחק</a:t>
             </a:r>
           </a:p>
         </p:txBody>
@@ -5366,14 +5379,14 @@
           </a:bodyPr>
           <a:lstStyle/>
           <a:p>
-            <a:pPr algn="l"/>
+            <a:pPr algn="r"/>
             <a:r>
               <a:rPr sz="1600" b="1" i="0">
                 <a:solidFill>
                   <a:srgbClr val="F5C518"/>
                 </a:solidFill>
               </a:rPr>
-              <a:t>🏠  Properties</a:t>
+              <a:t>🏠  נכסים</a:t>
             </a:r>
           </a:p>
         </p:txBody>
@@ -5386,8 +5399,8 @@
         </p:nvSpPr>
         <p:spPr>
           <a:xfrm>
-            <a:off x="457200" y="1920240"/>
-            <a:ext cx="3383280" cy="4389120"/>
+            <a:off x="411479" y="1920240"/>
+            <a:ext cx="3474720" cy="4389120"/>
           </a:xfrm>
           <a:prstGeom prst="rect">
             <a:avLst/>
@@ -5400,53 +5413,58 @@
           </a:bodyPr>
           <a:lstStyle/>
           <a:p>
+            <a:pPr algn="r"/>
             <a:r>
               <a:rPr sz="1400">
                 <a:solidFill>
                   <a:srgbClr val="D0E4F7"/>
                 </a:solidFill>
               </a:rPr>
-              <a:t>✓  24 properties in 8 colour groups</a:t>
-            </a:r>
-          </a:p>
-          <a:p>
+              <a:t>✓  24 נכסים ב-8 קבוצות צבע</a:t>
+            </a:r>
+          </a:p>
+          <a:p>
+            <a:pPr algn="r"/>
             <a:r>
               <a:rPr sz="1400">
                 <a:solidFill>
                   <a:srgbClr val="D0E4F7"/>
                 </a:solidFill>
               </a:rPr>
-              <a:t>✓  Buy at Land / 1–3 Houses / Hotel</a:t>
-            </a:r>
-          </a:p>
-          <a:p>
+              <a:t>✓  קנייה ב-4 רמות: קרקע / 1-3 בתים / מלון</a:t>
+            </a:r>
+          </a:p>
+          <a:p>
+            <a:pPr algn="r"/>
             <a:r>
               <a:rPr sz="1400">
                 <a:solidFill>
                   <a:srgbClr val="D0E4F7"/>
                 </a:solidFill>
               </a:rPr>
-              <a:t>✓  Rent scales 1× → 3× → 6× → 10× → 16×</a:t>
-            </a:r>
-          </a:p>
-          <a:p>
+              <a:t>✓  שכירות: ×1 ← ×3 ← ×6 ← ×10 ← ×16</a:t>
+            </a:r>
+          </a:p>
+          <a:p>
+            <a:pPr algn="r"/>
             <a:r>
               <a:rPr sz="1400">
                 <a:solidFill>
                   <a:srgbClr val="D0E4F7"/>
                 </a:solidFill>
               </a:rPr>
-              <a:t>✓  Sell at 75% value in emergencies</a:t>
-            </a:r>
-          </a:p>
-          <a:p>
+              <a:t>✓  מכירה ב-75% מערך הרכישה</a:t>
+            </a:r>
+          </a:p>
+          <a:p>
+            <a:pPr algn="r"/>
             <a:r>
               <a:rPr sz="1400">
                 <a:solidFill>
                   <a:srgbClr val="D0E4F7"/>
                 </a:solidFill>
               </a:rPr>
-              <a:t>✓  3 Houses locked until lap 1 complete</a:t>
+              <a:t>✓  בית 3 נעול עד השלמת סיבוב ראשון</a:t>
             </a:r>
           </a:p>
         </p:txBody>
@@ -5559,14 +5577,14 @@
           </a:bodyPr>
           <a:lstStyle/>
           <a:p>
-            <a:pPr algn="l"/>
+            <a:pPr algn="r"/>
             <a:r>
               <a:rPr sz="1600" b="1" i="0">
                 <a:solidFill>
                   <a:srgbClr val="F5C518"/>
                 </a:solidFill>
               </a:rPr>
-              <a:t>🎲  Special Tiles</a:t>
+              <a:t>🎲  ריבועים מיוחדים</a:t>
             </a:r>
           </a:p>
         </p:txBody>
@@ -5579,8 +5597,8 @@
         </p:nvSpPr>
         <p:spPr>
           <a:xfrm>
-            <a:off x="4389120" y="1920240"/>
-            <a:ext cx="3383280" cy="4389120"/>
+            <a:off x="4343399" y="1920240"/>
+            <a:ext cx="3474720" cy="4389120"/>
           </a:xfrm>
           <a:prstGeom prst="rect">
             <a:avLst/>
@@ -5593,53 +5611,58 @@
           </a:bodyPr>
           <a:lstStyle/>
           <a:p>
+            <a:pPr algn="r"/>
             <a:r>
               <a:rPr sz="1400">
                 <a:solidFill>
                   <a:srgbClr val="D0E4F7"/>
                 </a:solidFill>
               </a:rPr>
-              <a:t>✓  Start: collect ₪200k + Roulette casino</a:t>
-            </a:r>
-          </a:p>
-          <a:p>
+              <a:t>✓  התחלה: ₪200k + קזינו רולטה</a:t>
+            </a:r>
+          </a:p>
+          <a:p>
+            <a:pPr algn="r"/>
             <a:r>
               <a:rPr sz="1400">
                 <a:solidFill>
                   <a:srgbClr val="D0E4F7"/>
                 </a:solidFill>
               </a:rPr>
-              <a:t>✓  Jail: 3-turn lock, escape by fine or doubles</a:t>
-            </a:r>
-          </a:p>
-          <a:p>
+              <a:t>✓  כלא: 3 תורות, בריחה בתשלום או doubles</a:t>
+            </a:r>
+          </a:p>
+          <a:p>
+            <a:pPr algn="r"/>
             <a:r>
               <a:rPr sz="1400">
                 <a:solidFill>
                   <a:srgbClr val="D0E4F7"/>
                 </a:solidFill>
               </a:rPr>
-              <a:t>✓  Airport: ₪100k teleport to any free property</a:t>
-            </a:r>
-          </a:p>
-          <a:p>
+              <a:t>✓  שדה תעופה: טלפורט ב-₪100k לנכס פנוי</a:t>
+            </a:r>
+          </a:p>
+          <a:p>
+            <a:pPr algn="r"/>
             <a:r>
               <a:rPr sz="1400">
                 <a:solidFill>
                   <a:srgbClr val="D0E4F7"/>
                 </a:solidFill>
               </a:rPr>
-              <a:t>✓  World Champ.: global rent multiplier (×2, ×3…)</a:t>
-            </a:r>
-          </a:p>
-          <a:p>
+              <a:t>✓  אליפות עולמית: מכפיל שכירות גלובלי (×2, ×3...)</a:t>
+            </a:r>
+          </a:p>
+          <a:p>
+            <a:pPr algn="r"/>
             <a:r>
               <a:rPr sz="1400">
                 <a:solidFill>
                   <a:srgbClr val="D0E4F7"/>
                 </a:solidFill>
               </a:rPr>
-              <a:t>✓  Chance: bonus &amp; penalty event cards</a:t>
+              <a:t>✓  כרטיסי מזל: בונוסים ועונשים</a:t>
             </a:r>
           </a:p>
         </p:txBody>
@@ -5752,14 +5775,14 @@
           </a:bodyPr>
           <a:lstStyle/>
           <a:p>
-            <a:pPr algn="l"/>
+            <a:pPr algn="r"/>
             <a:r>
               <a:rPr sz="1600" b="1" i="0">
                 <a:solidFill>
                   <a:srgbClr val="F5C518"/>
                 </a:solidFill>
               </a:rPr>
-              <a:t>🤖  Players &amp; Win</a:t>
+              <a:t>🤖  שחקנים וניצחון</a:t>
             </a:r>
           </a:p>
         </p:txBody>
@@ -5772,8 +5795,8 @@
         </p:nvSpPr>
         <p:spPr>
           <a:xfrm>
-            <a:off x="8321040" y="1920240"/>
-            <a:ext cx="3383280" cy="4389120"/>
+            <a:off x="8275319" y="1920240"/>
+            <a:ext cx="3474720" cy="4389120"/>
           </a:xfrm>
           <a:prstGeom prst="rect">
             <a:avLst/>
@@ -5786,53 +5809,58 @@
           </a:bodyPr>
           <a:lstStyle/>
           <a:p>
+            <a:pPr algn="r"/>
             <a:r>
               <a:rPr sz="1400">
                 <a:solidFill>
                   <a:srgbClr val="D0E4F7"/>
                 </a:solidFill>
               </a:rPr>
-              <a:t>✓  Human: full JOptionPane / GUI interaction</a:t>
-            </a:r>
-          </a:p>
-          <a:p>
+              <a:t>✓  אנושי: אינטראקציה מלאה — JOptionPane / GUI</a:t>
+            </a:r>
+          </a:p>
+          <a:p>
+            <a:pPr algn="r"/>
             <a:r>
               <a:rPr sz="1400">
                 <a:solidFill>
                   <a:srgbClr val="D0E4F7"/>
                 </a:solidFill>
               </a:rPr>
-              <a:t>✓  Bot: auto-buys if price &lt; 40% of cash</a:t>
-            </a:r>
-          </a:p>
-          <a:p>
+              <a:t>✓  בוט: קונה אוטומטי אם מחיר &lt; 40% מהכסף</a:t>
+            </a:r>
+          </a:p>
+          <a:p>
+            <a:pPr algn="r"/>
             <a:r>
               <a:rPr sz="1400">
                 <a:solidFill>
                   <a:srgbClr val="D0E4F7"/>
                 </a:solidFill>
               </a:rPr>
-              <a:t>✓  Win: own all 4 Shuttle Stations</a:t>
-            </a:r>
-          </a:p>
-          <a:p>
+              <a:t>✓  ניצחון: 4 תחנות שאטל</a:t>
+            </a:r>
+          </a:p>
+          <a:p>
+            <a:pPr algn="r"/>
             <a:r>
               <a:rPr sz="1400">
                 <a:solidFill>
                   <a:srgbClr val="D0E4F7"/>
                 </a:solidFill>
               </a:rPr>
-              <a:t>✓  Win: own 3 complete colour monopolies</a:t>
-            </a:r>
-          </a:p>
-          <a:p>
+              <a:t>✓  ניצחון: 3 מונופולים צבעוניים מלאים</a:t>
+            </a:r>
+          </a:p>
+          <a:p>
+            <a:pPr algn="r"/>
             <a:r>
               <a:rPr sz="1400">
                 <a:solidFill>
                   <a:srgbClr val="D0E4F7"/>
                 </a:solidFill>
               </a:rPr>
-              <a:t>✓  Win: own all properties on one board side</a:t>
+              <a:t>✓  ניצחון: כל הנכסים בצלע אחת של הלוח</a:t>
             </a:r>
           </a:p>
         </p:txBody>
@@ -5958,7 +5986,7 @@
         <p:spPr>
           <a:xfrm>
             <a:off x="365760" y="91440"/>
-            <a:ext cx="9144000" cy="685800"/>
+            <a:ext cx="11430000" cy="685800"/>
           </a:xfrm>
           <a:prstGeom prst="rect">
             <a:avLst/>
@@ -5971,14 +5999,14 @@
           </a:bodyPr>
           <a:lstStyle/>
           <a:p>
-            <a:pPr algn="l"/>
+            <a:pPr algn="r"/>
             <a:r>
               <a:rPr sz="3200" b="1" i="0">
                 <a:solidFill>
                   <a:srgbClr val="FFFFFF"/>
                 </a:solidFill>
               </a:rPr>
-              <a:t>UML — Class Diagram</a:t>
+              <a:t>דיאגרמת UML</a:t>
             </a:r>
           </a:p>
         </p:txBody>
@@ -5991,8 +6019,8 @@
         </p:nvSpPr>
         <p:spPr>
           <a:xfrm>
-            <a:off x="365760" y="731520"/>
-            <a:ext cx="9144000" cy="411480"/>
+            <a:off x="365760" y="749808"/>
+            <a:ext cx="11430000" cy="384048"/>
           </a:xfrm>
           <a:prstGeom prst="rect">
             <a:avLst/>
@@ -6005,14 +6033,14 @@
           </a:bodyPr>
           <a:lstStyle/>
           <a:p>
-            <a:pPr algn="l"/>
-            <a:r>
-              <a:rPr sz="1600" b="0" i="1">
+            <a:pPr algn="r"/>
+            <a:r>
+              <a:rPr sz="1500" b="0" i="1">
                 <a:solidFill>
                   <a:srgbClr val="F5C518"/>
                 </a:solidFill>
               </a:rPr>
-              <a:t>Slide 4 — Object-Oriented Design</a:t>
+              <a:t>שקופית 4 — עיצוב מונחה עצמים</a:t>
             </a:r>
           </a:p>
         </p:txBody>
@@ -6112,7 +6140,7 @@
         <p:spPr>
           <a:xfrm>
             <a:off x="274320" y="1380744"/>
-            <a:ext cx="1920240" cy="201168"/>
+            <a:ext cx="1920240" cy="182880"/>
           </a:xfrm>
           <a:prstGeom prst="rect">
             <a:avLst/>
@@ -6222,8 +6250,8 @@
         </p:nvSpPr>
         <p:spPr>
           <a:xfrm>
-            <a:off x="347472" y="1783080"/>
-            <a:ext cx="1773936" cy="731520"/>
+            <a:off x="338328" y="1773936"/>
+            <a:ext cx="1792224" cy="731520"/>
           </a:xfrm>
           <a:prstGeom prst="rect">
             <a:avLst/>
@@ -6352,7 +6380,7 @@
         <p:spPr>
           <a:xfrm>
             <a:off x="2834640" y="1380744"/>
-            <a:ext cx="2560320" cy="201168"/>
+            <a:ext cx="2560320" cy="182880"/>
           </a:xfrm>
           <a:prstGeom prst="rect">
             <a:avLst/>
@@ -6462,8 +6490,8 @@
         </p:nvSpPr>
         <p:spPr>
           <a:xfrm>
-            <a:off x="2907792" y="1783080"/>
-            <a:ext cx="2414015" cy="1005840"/>
+            <a:off x="2898648" y="1773936"/>
+            <a:ext cx="2432303" cy="1005840"/>
           </a:xfrm>
           <a:prstGeom prst="rect">
             <a:avLst/>
@@ -6482,7 +6510,7 @@
                   <a:srgbClr val="D0E4F7"/>
                 </a:solidFill>
               </a:rPr>
-              <a:t>+ takeTurn(Board, Dice)</a:t>
+              <a:t>+ takeTurn(Board,Dice)</a:t>
             </a:r>
           </a:p>
           <a:p>
@@ -6522,7 +6550,7 @@
                   <a:srgbClr val="D0E4F7"/>
                 </a:solidFill>
               </a:rPr>
-              <a:t>+ clone(): Player</a:t>
+              <a:t>+ clone()</a:t>
             </a:r>
           </a:p>
         </p:txBody>
@@ -6536,7 +6564,7 @@
         <p:spPr>
           <a:xfrm>
             <a:off x="6400800" y="1371600"/>
-            <a:ext cx="2286000" cy="1188720"/>
+            <a:ext cx="2194560" cy="1188720"/>
           </a:xfrm>
           <a:prstGeom prst="rect">
             <a:avLst/>
@@ -6579,7 +6607,7 @@
         <p:spPr>
           <a:xfrm>
             <a:off x="6400800" y="1371600"/>
-            <a:ext cx="2286000" cy="347472"/>
+            <a:ext cx="2194560" cy="347472"/>
           </a:xfrm>
           <a:prstGeom prst="rect">
             <a:avLst/>
@@ -6622,7 +6650,7 @@
         <p:spPr>
           <a:xfrm>
             <a:off x="6400800" y="1380744"/>
-            <a:ext cx="2286000" cy="201168"/>
+            <a:ext cx="2194560" cy="182880"/>
           </a:xfrm>
           <a:prstGeom prst="rect">
             <a:avLst/>
@@ -6656,7 +6684,7 @@
         <p:spPr>
           <a:xfrm>
             <a:off x="6400800" y="1536192"/>
-            <a:ext cx="2286000" cy="201168"/>
+            <a:ext cx="2194560" cy="201168"/>
           </a:xfrm>
           <a:prstGeom prst="rect">
             <a:avLst/>
@@ -6690,7 +6718,7 @@
         <p:spPr>
           <a:xfrm>
             <a:off x="6400800" y="1719072"/>
-            <a:ext cx="2286000" cy="18288"/>
+            <a:ext cx="2194560" cy="18288"/>
           </a:xfrm>
           <a:prstGeom prst="rect">
             <a:avLst/>
@@ -6732,8 +6760,8 @@
         </p:nvSpPr>
         <p:spPr>
           <a:xfrm>
-            <a:off x="6473952" y="1783080"/>
-            <a:ext cx="2139696" cy="731520"/>
+            <a:off x="6464808" y="1773936"/>
+            <a:ext cx="2066543" cy="731520"/>
           </a:xfrm>
           <a:prstGeom prst="rect">
             <a:avLst/>
@@ -6775,8 +6803,8 @@
         </p:nvSpPr>
         <p:spPr>
           <a:xfrm>
-            <a:off x="9326880" y="1371600"/>
-            <a:ext cx="2560320" cy="1417320"/>
+            <a:off x="9235440" y="1371600"/>
+            <a:ext cx="2651760" cy="1463040"/>
           </a:xfrm>
           <a:prstGeom prst="rect">
             <a:avLst/>
@@ -6818,8 +6846,8 @@
         </p:nvSpPr>
         <p:spPr>
           <a:xfrm>
-            <a:off x="9326880" y="1371600"/>
-            <a:ext cx="2560320" cy="292608"/>
+            <a:off x="9235440" y="1371600"/>
+            <a:ext cx="2651760" cy="292608"/>
           </a:xfrm>
           <a:prstGeom prst="rect">
             <a:avLst/>
@@ -6861,8 +6889,8 @@
         </p:nvSpPr>
         <p:spPr>
           <a:xfrm>
-            <a:off x="9326880" y="1426464"/>
-            <a:ext cx="2560320" cy="228600"/>
+            <a:off x="9235440" y="1426464"/>
+            <a:ext cx="2651760" cy="228600"/>
           </a:xfrm>
           <a:prstGeom prst="rect">
             <a:avLst/>
@@ -6895,8 +6923,8 @@
         </p:nvSpPr>
         <p:spPr>
           <a:xfrm>
-            <a:off x="9326880" y="1664208"/>
-            <a:ext cx="2560320" cy="18288"/>
+            <a:off x="9235440" y="1664208"/>
+            <a:ext cx="2651760" cy="18288"/>
           </a:xfrm>
           <a:prstGeom prst="rect">
             <a:avLst/>
@@ -6938,8 +6966,8 @@
         </p:nvSpPr>
         <p:spPr>
           <a:xfrm>
-            <a:off x="9400032" y="1783080"/>
-            <a:ext cx="2414015" cy="960120"/>
+            <a:off x="9299448" y="1773936"/>
+            <a:ext cx="2523744" cy="1005840"/>
           </a:xfrm>
           <a:prstGeom prst="rect">
             <a:avLst/>
@@ -7021,8 +7049,8 @@
         </p:nvSpPr>
         <p:spPr>
           <a:xfrm>
-            <a:off x="274320" y="3703320"/>
-            <a:ext cx="1920240" cy="1325880"/>
+            <a:off x="274320" y="3657600"/>
+            <a:ext cx="1920240" cy="1371600"/>
           </a:xfrm>
           <a:prstGeom prst="rect">
             <a:avLst/>
@@ -7064,7 +7092,7 @@
         </p:nvSpPr>
         <p:spPr>
           <a:xfrm>
-            <a:off x="274320" y="3703320"/>
+            <a:off x="274320" y="3657600"/>
             <a:ext cx="1920240" cy="292608"/>
           </a:xfrm>
           <a:prstGeom prst="rect">
@@ -7107,7 +7135,7 @@
         </p:nvSpPr>
         <p:spPr>
           <a:xfrm>
-            <a:off x="274320" y="3758183"/>
+            <a:off x="274320" y="3712463"/>
             <a:ext cx="1920240" cy="228600"/>
           </a:xfrm>
           <a:prstGeom prst="rect">
@@ -7141,7 +7169,7 @@
         </p:nvSpPr>
         <p:spPr>
           <a:xfrm>
-            <a:off x="274320" y="3995928"/>
+            <a:off x="274320" y="3950208"/>
             <a:ext cx="1920240" cy="18288"/>
           </a:xfrm>
           <a:prstGeom prst="rect">
@@ -7184,8 +7212,8 @@
         </p:nvSpPr>
         <p:spPr>
           <a:xfrm>
-            <a:off x="347472" y="4114800"/>
-            <a:ext cx="1773936" cy="868680"/>
+            <a:off x="338328" y="4059936"/>
+            <a:ext cx="1792224" cy="914400"/>
           </a:xfrm>
           <a:prstGeom prst="rect">
             <a:avLst/>
@@ -7204,7 +7232,7 @@
                   <a:srgbClr val="D0E4F7"/>
                 </a:solidFill>
               </a:rPr>
-              <a:t>owner, level, price</a:t>
+              <a:t>owner, level</a:t>
             </a:r>
           </a:p>
           <a:p>
@@ -7247,8 +7275,8 @@
         </p:nvSpPr>
         <p:spPr>
           <a:xfrm>
-            <a:off x="2331720" y="3703320"/>
-            <a:ext cx="1920240" cy="1325880"/>
+            <a:off x="2331720" y="3657600"/>
+            <a:ext cx="1920240" cy="1371600"/>
           </a:xfrm>
           <a:prstGeom prst="rect">
             <a:avLst/>
@@ -7290,7 +7318,7 @@
         </p:nvSpPr>
         <p:spPr>
           <a:xfrm>
-            <a:off x="2331720" y="3703320"/>
+            <a:off x="2331720" y="3657600"/>
             <a:ext cx="1920240" cy="292608"/>
           </a:xfrm>
           <a:prstGeom prst="rect">
@@ -7333,7 +7361,7 @@
         </p:nvSpPr>
         <p:spPr>
           <a:xfrm>
-            <a:off x="2331720" y="3758183"/>
+            <a:off x="2331720" y="3712463"/>
             <a:ext cx="1920240" cy="228600"/>
           </a:xfrm>
           <a:prstGeom prst="rect">
@@ -7367,7 +7395,7 @@
         </p:nvSpPr>
         <p:spPr>
           <a:xfrm>
-            <a:off x="2331720" y="3995928"/>
+            <a:off x="2331720" y="3950208"/>
             <a:ext cx="1920240" cy="18288"/>
           </a:xfrm>
           <a:prstGeom prst="rect">
@@ -7410,8 +7438,8 @@
         </p:nvSpPr>
         <p:spPr>
           <a:xfrm>
-            <a:off x="2404872" y="4114800"/>
-            <a:ext cx="1773936" cy="868680"/>
+            <a:off x="2395727" y="4059936"/>
+            <a:ext cx="1792224" cy="914400"/>
           </a:xfrm>
           <a:prstGeom prst="rect">
             <a:avLst/>
@@ -7463,8 +7491,8 @@
         </p:nvSpPr>
         <p:spPr>
           <a:xfrm>
-            <a:off x="4343400" y="3703320"/>
-            <a:ext cx="1920240" cy="1325880"/>
+            <a:off x="4343400" y="3657600"/>
+            <a:ext cx="1920240" cy="1371600"/>
           </a:xfrm>
           <a:prstGeom prst="rect">
             <a:avLst/>
@@ -7506,7 +7534,7 @@
         </p:nvSpPr>
         <p:spPr>
           <a:xfrm>
-            <a:off x="4343400" y="3703320"/>
+            <a:off x="4343400" y="3657600"/>
             <a:ext cx="1920240" cy="292608"/>
           </a:xfrm>
           <a:prstGeom prst="rect">
@@ -7549,7 +7577,7 @@
         </p:nvSpPr>
         <p:spPr>
           <a:xfrm>
-            <a:off x="4343400" y="3758183"/>
+            <a:off x="4343400" y="3712463"/>
             <a:ext cx="1920240" cy="228600"/>
           </a:xfrm>
           <a:prstGeom prst="rect">
@@ -7583,7 +7611,7 @@
         </p:nvSpPr>
         <p:spPr>
           <a:xfrm>
-            <a:off x="4343400" y="3995928"/>
+            <a:off x="4343400" y="3950208"/>
             <a:ext cx="1920240" cy="18288"/>
           </a:xfrm>
           <a:prstGeom prst="rect">
@@ -7626,8 +7654,8 @@
         </p:nvSpPr>
         <p:spPr>
           <a:xfrm>
-            <a:off x="4416552" y="4114800"/>
-            <a:ext cx="1773936" cy="868680"/>
+            <a:off x="4407408" y="4059936"/>
+            <a:ext cx="1792224" cy="914400"/>
           </a:xfrm>
           <a:prstGeom prst="rect">
             <a:avLst/>
@@ -7669,8 +7697,8 @@
         </p:nvSpPr>
         <p:spPr>
           <a:xfrm>
-            <a:off x="6263640" y="3703320"/>
-            <a:ext cx="1920240" cy="1325880"/>
+            <a:off x="6263640" y="3657600"/>
+            <a:ext cx="1920240" cy="1371600"/>
           </a:xfrm>
           <a:prstGeom prst="rect">
             <a:avLst/>
@@ -7712,7 +7740,7 @@
         </p:nvSpPr>
         <p:spPr>
           <a:xfrm>
-            <a:off x="6263640" y="3703320"/>
+            <a:off x="6263640" y="3657600"/>
             <a:ext cx="1920240" cy="292608"/>
           </a:xfrm>
           <a:prstGeom prst="rect">
@@ -7755,7 +7783,7 @@
         </p:nvSpPr>
         <p:spPr>
           <a:xfrm>
-            <a:off x="6263640" y="3758183"/>
+            <a:off x="6263640" y="3712463"/>
             <a:ext cx="1920240" cy="228600"/>
           </a:xfrm>
           <a:prstGeom prst="rect">
@@ -7789,7 +7817,7 @@
         </p:nvSpPr>
         <p:spPr>
           <a:xfrm>
-            <a:off x="6263640" y="3995928"/>
+            <a:off x="6263640" y="3950208"/>
             <a:ext cx="1920240" cy="18288"/>
           </a:xfrm>
           <a:prstGeom prst="rect">
@@ -7832,8 +7860,8 @@
         </p:nvSpPr>
         <p:spPr>
           <a:xfrm>
-            <a:off x="6336792" y="4114800"/>
-            <a:ext cx="1773936" cy="868680"/>
+            <a:off x="6327648" y="4059936"/>
+            <a:ext cx="1792224" cy="914400"/>
           </a:xfrm>
           <a:prstGeom prst="rect">
             <a:avLst/>
@@ -7865,8 +7893,8 @@
         </p:nvSpPr>
         <p:spPr>
           <a:xfrm>
-            <a:off x="8092440" y="3703320"/>
-            <a:ext cx="1920240" cy="1325880"/>
+            <a:off x="8092440" y="3657600"/>
+            <a:ext cx="1920240" cy="1371600"/>
           </a:xfrm>
           <a:prstGeom prst="rect">
             <a:avLst/>
@@ -7908,7 +7936,7 @@
         </p:nvSpPr>
         <p:spPr>
           <a:xfrm>
-            <a:off x="8092440" y="3703320"/>
+            <a:off x="8092440" y="3657600"/>
             <a:ext cx="1920240" cy="292608"/>
           </a:xfrm>
           <a:prstGeom prst="rect">
@@ -7951,7 +7979,7 @@
         </p:nvSpPr>
         <p:spPr>
           <a:xfrm>
-            <a:off x="8092440" y="3758183"/>
+            <a:off x="8092440" y="3712463"/>
             <a:ext cx="1920240" cy="228600"/>
           </a:xfrm>
           <a:prstGeom prst="rect">
@@ -7985,7 +8013,7 @@
         </p:nvSpPr>
         <p:spPr>
           <a:xfrm>
-            <a:off x="8092440" y="3995928"/>
+            <a:off x="8092440" y="3950208"/>
             <a:ext cx="1920240" cy="18288"/>
           </a:xfrm>
           <a:prstGeom prst="rect">
@@ -8028,8 +8056,8 @@
         </p:nvSpPr>
         <p:spPr>
           <a:xfrm>
-            <a:off x="8165592" y="4114800"/>
-            <a:ext cx="1773936" cy="868680"/>
+            <a:off x="8156448" y="4059936"/>
+            <a:ext cx="1792224" cy="914400"/>
           </a:xfrm>
           <a:prstGeom prst="rect">
             <a:avLst/>
@@ -8071,8 +8099,8 @@
         </p:nvSpPr>
         <p:spPr>
           <a:xfrm>
-            <a:off x="9921240" y="3703320"/>
-            <a:ext cx="1920240" cy="1325880"/>
+            <a:off x="9921240" y="3657600"/>
+            <a:ext cx="1920240" cy="1371600"/>
           </a:xfrm>
           <a:prstGeom prst="rect">
             <a:avLst/>
@@ -8114,7 +8142,7 @@
         </p:nvSpPr>
         <p:spPr>
           <a:xfrm>
-            <a:off x="9921240" y="3703320"/>
+            <a:off x="9921240" y="3657600"/>
             <a:ext cx="1920240" cy="292608"/>
           </a:xfrm>
           <a:prstGeom prst="rect">
@@ -8157,7 +8185,7 @@
         </p:nvSpPr>
         <p:spPr>
           <a:xfrm>
-            <a:off x="9921240" y="3758183"/>
+            <a:off x="9921240" y="3712463"/>
             <a:ext cx="1920240" cy="228600"/>
           </a:xfrm>
           <a:prstGeom prst="rect">
@@ -8191,7 +8219,7 @@
         </p:nvSpPr>
         <p:spPr>
           <a:xfrm>
-            <a:off x="9921240" y="3995928"/>
+            <a:off x="9921240" y="3950208"/>
             <a:ext cx="1920240" cy="18288"/>
           </a:xfrm>
           <a:prstGeom prst="rect">
@@ -8234,8 +8262,8 @@
         </p:nvSpPr>
         <p:spPr>
           <a:xfrm>
-            <a:off x="9994392" y="4114800"/>
-            <a:ext cx="1773936" cy="868680"/>
+            <a:off x="9985248" y="4059936"/>
+            <a:ext cx="1792224" cy="914400"/>
           </a:xfrm>
           <a:prstGeom prst="rect">
             <a:avLst/>
@@ -8254,7 +8282,7 @@
                   <a:srgbClr val="D0E4F7"/>
                 </a:solidFill>
               </a:rPr>
-              <a:t>multiplier</a:t>
+              <a:t>multiplier (static)</a:t>
             </a:r>
           </a:p>
           <a:p>
@@ -8277,7 +8305,7 @@
         </p:nvSpPr>
         <p:spPr>
           <a:xfrm>
-            <a:off x="2834640" y="3703320"/>
+            <a:off x="2834640" y="3657600"/>
             <a:ext cx="1645920" cy="1005840"/>
           </a:xfrm>
           <a:prstGeom prst="rect">
@@ -8320,7 +8348,7 @@
         </p:nvSpPr>
         <p:spPr>
           <a:xfrm>
-            <a:off x="2834640" y="3703320"/>
+            <a:off x="2834640" y="3657600"/>
             <a:ext cx="1645920" cy="292608"/>
           </a:xfrm>
           <a:prstGeom prst="rect">
@@ -8363,7 +8391,7 @@
         </p:nvSpPr>
         <p:spPr>
           <a:xfrm>
-            <a:off x="2834640" y="3758183"/>
+            <a:off x="2834640" y="3712463"/>
             <a:ext cx="1645920" cy="228600"/>
           </a:xfrm>
           <a:prstGeom prst="rect">
@@ -8397,7 +8425,7 @@
         </p:nvSpPr>
         <p:spPr>
           <a:xfrm>
-            <a:off x="2834640" y="3995928"/>
+            <a:off x="2834640" y="3950208"/>
             <a:ext cx="1645920" cy="18288"/>
           </a:xfrm>
           <a:prstGeom prst="rect">
@@ -8440,8 +8468,8 @@
         </p:nvSpPr>
         <p:spPr>
           <a:xfrm>
-            <a:off x="2907792" y="4114800"/>
-            <a:ext cx="1499616" cy="548640"/>
+            <a:off x="2898648" y="4059936"/>
+            <a:ext cx="1517904" cy="548640"/>
           </a:xfrm>
           <a:prstGeom prst="rect">
             <a:avLst/>
@@ -8483,7 +8511,7 @@
         </p:nvSpPr>
         <p:spPr>
           <a:xfrm>
-            <a:off x="4617720" y="3703320"/>
+            <a:off x="4617720" y="3657600"/>
             <a:ext cx="1645920" cy="914400"/>
           </a:xfrm>
           <a:prstGeom prst="rect">
@@ -8526,7 +8554,7 @@
         </p:nvSpPr>
         <p:spPr>
           <a:xfrm>
-            <a:off x="4617720" y="3703320"/>
+            <a:off x="4617720" y="3657600"/>
             <a:ext cx="1645920" cy="292608"/>
           </a:xfrm>
           <a:prstGeom prst="rect">
@@ -8569,7 +8597,7 @@
         </p:nvSpPr>
         <p:spPr>
           <a:xfrm>
-            <a:off x="4617720" y="3758183"/>
+            <a:off x="4617720" y="3712463"/>
             <a:ext cx="1645920" cy="228600"/>
           </a:xfrm>
           <a:prstGeom prst="rect">
@@ -8603,7 +8631,7 @@
         </p:nvSpPr>
         <p:spPr>
           <a:xfrm>
-            <a:off x="4617720" y="3995928"/>
+            <a:off x="4617720" y="3950208"/>
             <a:ext cx="1645920" cy="18288"/>
           </a:xfrm>
           <a:prstGeom prst="rect">
@@ -8646,8 +8674,8 @@
         </p:nvSpPr>
         <p:spPr>
           <a:xfrm>
-            <a:off x="4690872" y="4114800"/>
-            <a:ext cx="1499616" cy="457200"/>
+            <a:off x="4681728" y="4059936"/>
+            <a:ext cx="1517904" cy="457200"/>
           </a:xfrm>
           <a:prstGeom prst="rect">
             <a:avLst/>
@@ -8689,7 +8717,7 @@
         </p:nvSpPr>
         <p:spPr>
           <a:xfrm>
-            <a:off x="6537960" y="3703320"/>
+            <a:off x="6492240" y="3657600"/>
             <a:ext cx="1371600" cy="914400"/>
           </a:xfrm>
           <a:prstGeom prst="rect">
@@ -8732,7 +8760,7 @@
         </p:nvSpPr>
         <p:spPr>
           <a:xfrm>
-            <a:off x="6537960" y="3703320"/>
+            <a:off x="6492240" y="3657600"/>
             <a:ext cx="1371600" cy="292608"/>
           </a:xfrm>
           <a:prstGeom prst="rect">
@@ -8775,7 +8803,7 @@
         </p:nvSpPr>
         <p:spPr>
           <a:xfrm>
-            <a:off x="6537960" y="3758183"/>
+            <a:off x="6492240" y="3712463"/>
             <a:ext cx="1371600" cy="228600"/>
           </a:xfrm>
           <a:prstGeom prst="rect">
@@ -8809,7 +8837,7 @@
         </p:nvSpPr>
         <p:spPr>
           <a:xfrm>
-            <a:off x="6537960" y="3995928"/>
+            <a:off x="6492240" y="3950208"/>
             <a:ext cx="1371600" cy="18288"/>
           </a:xfrm>
           <a:prstGeom prst="rect">
@@ -8852,8 +8880,8 @@
         </p:nvSpPr>
         <p:spPr>
           <a:xfrm>
-            <a:off x="6611112" y="4114800"/>
-            <a:ext cx="1225296" cy="457200"/>
+            <a:off x="6556248" y="4059936"/>
+            <a:ext cx="1243584" cy="457200"/>
           </a:xfrm>
           <a:prstGeom prst="rect">
             <a:avLst/>
@@ -8895,7 +8923,7 @@
         </p:nvSpPr>
         <p:spPr>
           <a:xfrm>
-            <a:off x="8046720" y="3703320"/>
+            <a:off x="8001000" y="3657600"/>
             <a:ext cx="1371600" cy="914400"/>
           </a:xfrm>
           <a:prstGeom prst="rect">
@@ -8938,7 +8966,7 @@
         </p:nvSpPr>
         <p:spPr>
           <a:xfrm>
-            <a:off x="8046720" y="3703320"/>
+            <a:off x="8001000" y="3657600"/>
             <a:ext cx="1371600" cy="292608"/>
           </a:xfrm>
           <a:prstGeom prst="rect">
@@ -8981,7 +9009,7 @@
         </p:nvSpPr>
         <p:spPr>
           <a:xfrm>
-            <a:off x="8046720" y="3758183"/>
+            <a:off x="8001000" y="3712463"/>
             <a:ext cx="1371600" cy="228600"/>
           </a:xfrm>
           <a:prstGeom prst="rect">
@@ -9015,7 +9043,7 @@
         </p:nvSpPr>
         <p:spPr>
           <a:xfrm>
-            <a:off x="8046720" y="3995928"/>
+            <a:off x="8001000" y="3950208"/>
             <a:ext cx="1371600" cy="18288"/>
           </a:xfrm>
           <a:prstGeom prst="rect">
@@ -9058,8 +9086,8 @@
         </p:nvSpPr>
         <p:spPr>
           <a:xfrm>
-            <a:off x="8119872" y="4114800"/>
-            <a:ext cx="1225296" cy="457200"/>
+            <a:off x="8065008" y="4059936"/>
+            <a:ext cx="1243584" cy="457200"/>
           </a:xfrm>
           <a:prstGeom prst="rect">
             <a:avLst/>
@@ -9102,7 +9130,7 @@
         <p:spPr>
           <a:xfrm>
             <a:off x="2834640" y="5029200"/>
-            <a:ext cx="2286000" cy="822960"/>
+            <a:ext cx="2377440" cy="777240"/>
           </a:xfrm>
           <a:prstGeom prst="rect">
             <a:avLst/>
@@ -9145,7 +9173,7 @@
         <p:spPr>
           <a:xfrm>
             <a:off x="2834640" y="5029200"/>
-            <a:ext cx="2286000" cy="292608"/>
+            <a:ext cx="2377440" cy="292608"/>
           </a:xfrm>
           <a:prstGeom prst="rect">
             <a:avLst/>
@@ -9188,7 +9216,7 @@
         <p:spPr>
           <a:xfrm>
             <a:off x="2834640" y="5084064"/>
-            <a:ext cx="2286000" cy="228600"/>
+            <a:ext cx="2377440" cy="228600"/>
           </a:xfrm>
           <a:prstGeom prst="rect">
             <a:avLst/>
@@ -9222,7 +9250,7 @@
         <p:spPr>
           <a:xfrm>
             <a:off x="2834640" y="5321808"/>
-            <a:ext cx="2286000" cy="18288"/>
+            <a:ext cx="2377440" cy="18288"/>
           </a:xfrm>
           <a:prstGeom prst="rect">
             <a:avLst/>
@@ -9264,8 +9292,8 @@
         </p:nvSpPr>
         <p:spPr>
           <a:xfrm>
-            <a:off x="2907792" y="5440680"/>
-            <a:ext cx="2139696" cy="365760"/>
+            <a:off x="2898648" y="5431536"/>
+            <a:ext cx="2249424" cy="320040"/>
           </a:xfrm>
           <a:prstGeom prst="rect">
             <a:avLst/>
@@ -9297,8 +9325,8 @@
         </p:nvSpPr>
         <p:spPr>
           <a:xfrm>
-            <a:off x="5257800" y="5029200"/>
-            <a:ext cx="2286000" cy="822960"/>
+            <a:off x="5349240" y="5029200"/>
+            <a:ext cx="2377440" cy="777240"/>
           </a:xfrm>
           <a:prstGeom prst="rect">
             <a:avLst/>
@@ -9340,8 +9368,8 @@
         </p:nvSpPr>
         <p:spPr>
           <a:xfrm>
-            <a:off x="5257800" y="5029200"/>
-            <a:ext cx="2286000" cy="292608"/>
+            <a:off x="5349240" y="5029200"/>
+            <a:ext cx="2377440" cy="292608"/>
           </a:xfrm>
           <a:prstGeom prst="rect">
             <a:avLst/>
@@ -9383,8 +9411,8 @@
         </p:nvSpPr>
         <p:spPr>
           <a:xfrm>
-            <a:off x="5257800" y="5084064"/>
-            <a:ext cx="2286000" cy="228600"/>
+            <a:off x="5349240" y="5084064"/>
+            <a:ext cx="2377440" cy="228600"/>
           </a:xfrm>
           <a:prstGeom prst="rect">
             <a:avLst/>
@@ -9417,8 +9445,8 @@
         </p:nvSpPr>
         <p:spPr>
           <a:xfrm>
-            <a:off x="5257800" y="5321808"/>
-            <a:ext cx="2286000" cy="18288"/>
+            <a:off x="5349240" y="5321808"/>
+            <a:ext cx="2377440" cy="18288"/>
           </a:xfrm>
           <a:prstGeom prst="rect">
             <a:avLst/>
@@ -9460,8 +9488,8 @@
         </p:nvSpPr>
         <p:spPr>
           <a:xfrm>
-            <a:off x="5330952" y="5440680"/>
-            <a:ext cx="2139696" cy="365760"/>
+            <a:off x="5413248" y="5431536"/>
+            <a:ext cx="2249424" cy="320040"/>
           </a:xfrm>
           <a:prstGeom prst="rect">
             <a:avLst/>
@@ -9494,7 +9522,7 @@
         <p:spPr>
           <a:xfrm flipV="1">
             <a:off x="1234440" y="2560320"/>
-            <a:ext cx="0" cy="1143000"/>
+            <a:ext cx="0" cy="1097280"/>
           </a:xfrm>
           <a:prstGeom prst="line">
             <a:avLst/>
@@ -9520,40 +9548,41 @@
           </a:fontRef>
         </p:style>
       </p:cxnSp>
-      <p:sp>
-        <p:nvSpPr>
-          <p:cNvPr id="90" name="TextBox 89"/>
-          <p:cNvSpPr txBox="1"/>
-          <p:nvPr/>
-        </p:nvSpPr>
-        <p:spPr>
-          <a:xfrm>
-            <a:off x="868680" y="2994660"/>
-            <a:ext cx="731520" cy="274320"/>
-          </a:xfrm>
-          <a:prstGeom prst="rect">
-            <a:avLst/>
-          </a:prstGeom>
-          <a:noFill/>
-        </p:spPr>
-        <p:txBody>
-          <a:bodyPr wrap="square">
-            <a:spAutoFit/>
-          </a:bodyPr>
-          <a:lstStyle/>
-          <a:p>
-            <a:pPr algn="ctr"/>
-            <a:r>
-              <a:rPr sz="800" b="0" i="0">
-                <a:solidFill>
-                  <a:srgbClr val="F5C518"/>
-                </a:solidFill>
-              </a:rPr>
-              <a:t>impl</a:t>
-            </a:r>
-          </a:p>
-        </p:txBody>
-      </p:sp>
+      <p:cxnSp>
+        <p:nvCxnSpPr>
+          <p:cNvPr id="90" name="Connector 89"/>
+          <p:cNvCxnSpPr/>
+          <p:nvPr/>
+        </p:nvCxnSpPr>
+        <p:spPr>
+          <a:xfrm flipH="1" flipV="1">
+            <a:off x="1234440" y="2560320"/>
+            <a:ext cx="2057399" cy="1097280"/>
+          </a:xfrm>
+          <a:prstGeom prst="line">
+            <a:avLst/>
+          </a:prstGeom>
+          <a:ln w="15240">
+            <a:solidFill>
+              <a:srgbClr val="27AE60"/>
+            </a:solidFill>
+          </a:ln>
+        </p:spPr>
+        <p:style>
+          <a:lnRef idx="2">
+            <a:schemeClr val="accent1"/>
+          </a:lnRef>
+          <a:fillRef idx="0">
+            <a:schemeClr val="accent1"/>
+          </a:fillRef>
+          <a:effectRef idx="1">
+            <a:schemeClr val="accent1"/>
+          </a:effectRef>
+          <a:fontRef idx="minor">
+            <a:schemeClr val="tx1"/>
+          </a:fontRef>
+        </p:style>
+      </p:cxnSp>
       <p:cxnSp>
         <p:nvCxnSpPr>
           <p:cNvPr id="91" name="Connector 90"/>
@@ -9563,7 +9592,7 @@
         <p:spPr>
           <a:xfrm flipH="1" flipV="1">
             <a:off x="1234440" y="2560320"/>
-            <a:ext cx="2057399" cy="1143000"/>
+            <a:ext cx="4069080" cy="1097280"/>
           </a:xfrm>
           <a:prstGeom prst="line">
             <a:avLst/>
@@ -9598,7 +9627,7 @@
         <p:spPr>
           <a:xfrm flipH="1" flipV="1">
             <a:off x="1234440" y="2560320"/>
-            <a:ext cx="4069080" cy="1143000"/>
+            <a:ext cx="5989319" cy="1097280"/>
           </a:xfrm>
           <a:prstGeom prst="line">
             <a:avLst/>
@@ -9633,7 +9662,7 @@
         <p:spPr>
           <a:xfrm flipH="1" flipV="1">
             <a:off x="1234440" y="2560320"/>
-            <a:ext cx="5989319" cy="1143000"/>
+            <a:ext cx="7818120" cy="1097280"/>
           </a:xfrm>
           <a:prstGeom prst="line">
             <a:avLst/>
@@ -9668,7 +9697,7 @@
         <p:spPr>
           <a:xfrm flipH="1" flipV="1">
             <a:off x="1234440" y="2560320"/>
-            <a:ext cx="7818120" cy="1143000"/>
+            <a:ext cx="9646920" cy="1097280"/>
           </a:xfrm>
           <a:prstGeom prst="line">
             <a:avLst/>
@@ -9701,16 +9730,16 @@
           <p:nvPr/>
         </p:nvCxnSpPr>
         <p:spPr>
-          <a:xfrm flipH="1" flipV="1">
-            <a:off x="1234440" y="2560320"/>
-            <a:ext cx="9646920" cy="1143000"/>
+          <a:xfrm flipV="1">
+            <a:off x="3657600" y="2834640"/>
+            <a:ext cx="457200" cy="822960"/>
           </a:xfrm>
           <a:prstGeom prst="line">
             <a:avLst/>
           </a:prstGeom>
           <a:ln w="15240">
             <a:solidFill>
-              <a:srgbClr val="27AE60"/>
+              <a:srgbClr val="AA55DD"/>
             </a:solidFill>
           </a:ln>
         </p:spPr>
@@ -9736,78 +9765,9 @@
           <p:nvPr/>
         </p:nvCxnSpPr>
         <p:spPr>
-          <a:xfrm flipV="1">
-            <a:off x="3657600" y="2834640"/>
-            <a:ext cx="457200" cy="868680"/>
-          </a:xfrm>
-          <a:prstGeom prst="line">
-            <a:avLst/>
-          </a:prstGeom>
-          <a:ln w="15240">
-            <a:solidFill>
-              <a:srgbClr val="AA55DD"/>
-            </a:solidFill>
-          </a:ln>
-        </p:spPr>
-        <p:style>
-          <a:lnRef idx="2">
-            <a:schemeClr val="accent1"/>
-          </a:lnRef>
-          <a:fillRef idx="0">
-            <a:schemeClr val="accent1"/>
-          </a:fillRef>
-          <a:effectRef idx="1">
-            <a:schemeClr val="accent1"/>
-          </a:effectRef>
-          <a:fontRef idx="minor">
-            <a:schemeClr val="tx1"/>
-          </a:fontRef>
-        </p:style>
-      </p:cxnSp>
-      <p:sp>
-        <p:nvSpPr>
-          <p:cNvPr id="97" name="TextBox 96"/>
-          <p:cNvSpPr txBox="1"/>
-          <p:nvPr/>
-        </p:nvSpPr>
-        <p:spPr>
-          <a:xfrm>
-            <a:off x="3520440" y="3131820"/>
-            <a:ext cx="731520" cy="274320"/>
-          </a:xfrm>
-          <a:prstGeom prst="rect">
-            <a:avLst/>
-          </a:prstGeom>
-          <a:noFill/>
-        </p:spPr>
-        <p:txBody>
-          <a:bodyPr wrap="square">
-            <a:spAutoFit/>
-          </a:bodyPr>
-          <a:lstStyle/>
-          <a:p>
-            <a:pPr algn="ctr"/>
-            <a:r>
-              <a:rPr sz="800" b="0" i="0">
-                <a:solidFill>
-                  <a:srgbClr val="F5C518"/>
-                </a:solidFill>
-              </a:rPr>
-              <a:t>extends</a:t>
-            </a:r>
-          </a:p>
-        </p:txBody>
-      </p:sp>
-      <p:cxnSp>
-        <p:nvCxnSpPr>
-          <p:cNvPr id="98" name="Connector 97"/>
-          <p:cNvCxnSpPr/>
-          <p:nvPr/>
-        </p:nvCxnSpPr>
-        <p:spPr>
           <a:xfrm flipH="1" flipV="1">
             <a:off x="4572000" y="2834640"/>
-            <a:ext cx="868680" cy="868680"/>
+            <a:ext cx="868680" cy="822960"/>
           </a:xfrm>
           <a:prstGeom prst="line">
             <a:avLst/>
@@ -9835,14 +9795,14 @@
       </p:cxnSp>
       <p:cxnSp>
         <p:nvCxnSpPr>
-          <p:cNvPr id="99" name="Connector 98"/>
+          <p:cNvPr id="97" name="Connector 96"/>
           <p:cNvCxnSpPr/>
           <p:nvPr/>
         </p:nvCxnSpPr>
         <p:spPr>
           <a:xfrm flipV="1">
-            <a:off x="7223760" y="2560320"/>
-            <a:ext cx="320040" cy="1143000"/>
+            <a:off x="7178040" y="2560320"/>
+            <a:ext cx="320039" cy="1097280"/>
           </a:xfrm>
           <a:prstGeom prst="line">
             <a:avLst/>
@@ -9870,14 +9830,14 @@
       </p:cxnSp>
       <p:cxnSp>
         <p:nvCxnSpPr>
-          <p:cNvPr id="100" name="Connector 99"/>
+          <p:cNvPr id="98" name="Connector 97"/>
           <p:cNvCxnSpPr/>
           <p:nvPr/>
         </p:nvCxnSpPr>
         <p:spPr>
           <a:xfrm flipH="1" flipV="1">
-            <a:off x="8001000" y="2560320"/>
-            <a:ext cx="731520" cy="1143000"/>
+            <a:off x="7863840" y="2560320"/>
+            <a:ext cx="822960" cy="1097280"/>
           </a:xfrm>
           <a:prstGeom prst="line">
             <a:avLst/>
@@ -9905,7 +9865,7 @@
       </p:cxnSp>
       <p:sp>
         <p:nvSpPr>
-          <p:cNvPr id="101" name="Rectangle 100"/>
+          <p:cNvPr id="99" name="Rectangle 98"/>
           <p:cNvSpPr/>
           <p:nvPr/>
         </p:nvSpPr>
@@ -9948,14 +9908,14 @@
       </p:sp>
       <p:sp>
         <p:nvSpPr>
-          <p:cNvPr id="102" name="TextBox 101"/>
+          <p:cNvPr id="100" name="TextBox 99"/>
           <p:cNvSpPr txBox="1"/>
           <p:nvPr/>
         </p:nvSpPr>
         <p:spPr>
           <a:xfrm>
-            <a:off x="457200" y="6217920"/>
-            <a:ext cx="11247120" cy="365760"/>
+            <a:off x="365760" y="6199632"/>
+            <a:ext cx="11430000" cy="411480"/>
           </a:xfrm>
           <a:prstGeom prst="rect">
             <a:avLst/>
@@ -9968,14 +9928,14 @@
           </a:bodyPr>
           <a:lstStyle/>
           <a:p>
-            <a:pPr algn="l"/>
+            <a:pPr algn="r"/>
             <a:r>
               <a:rPr sz="1000" b="0" i="0">
                 <a:solidFill>
                   <a:srgbClr val="8A9BAD"/>
                 </a:solidFill>
               </a:rPr>
-              <a:t>■ Interface (green)    ■ Abstract (purple)    ■ Concrete (blue)    ■ Exception (red)    → implements    → extends</a:t>
+              <a:t>■ ממשק (ירוק)    ■ אבסטרקטי (סגול)    ■ קונקרטי (כחול)    ■ חריגה (אדום)    ← implements    ← extends</a:t>
             </a:r>
           </a:p>
         </p:txBody>

</xml_diff>

<commit_message>
Add Hebrew presentation PPTX for University Tour project
</commit_message>
<xml_diff>
--- a/University_Tour_Presentation.pptx
+++ b/University_Tour_Presentation.pptx
@@ -3193,8 +3193,8 @@
         </p:nvSpPr>
         <p:spPr>
           <a:xfrm>
-            <a:off x="365760" y="91440"/>
-            <a:ext cx="11430000" cy="685800"/>
+            <a:off x="274320" y="91440"/>
+            <a:ext cx="11612880" cy="685800"/>
           </a:xfrm>
           <a:prstGeom prst="rect">
             <a:avLst/>
@@ -3207,9 +3207,9 @@
           </a:bodyPr>
           <a:lstStyle/>
           <a:p>
-            <a:pPr algn="r"/>
-            <a:r>
-              <a:rPr sz="3200" b="1" i="0">
+            <a:pPr algn="r" rtl="1"/>
+            <a:r>
+              <a:rPr sz="3400" b="1" i="0">
                 <a:solidFill>
                   <a:srgbClr val="FFFFFF"/>
                 </a:solidFill>
@@ -3227,8 +3227,8 @@
         </p:nvSpPr>
         <p:spPr>
           <a:xfrm>
-            <a:off x="365760" y="749808"/>
-            <a:ext cx="11430000" cy="384048"/>
+            <a:off x="274320" y="749808"/>
+            <a:ext cx="11612880" cy="384048"/>
           </a:xfrm>
           <a:prstGeom prst="rect">
             <a:avLst/>
@@ -3241,7 +3241,7 @@
           </a:bodyPr>
           <a:lstStyle/>
           <a:p>
-            <a:pPr algn="r"/>
+            <a:pPr algn="r" rtl="1"/>
             <a:r>
               <a:rPr sz="1500" b="0" i="1">
                 <a:solidFill>
@@ -3262,7 +3262,7 @@
         <p:spPr>
           <a:xfrm>
             <a:off x="274320" y="1325880"/>
-            <a:ext cx="3657600" cy="5303520"/>
+            <a:ext cx="3474720" cy="5303520"/>
           </a:xfrm>
           <a:prstGeom prst="rect">
             <a:avLst/>
@@ -3304,8 +3304,8 @@
         </p:nvSpPr>
         <p:spPr>
           <a:xfrm>
-            <a:off x="4114800" y="1417320"/>
-            <a:ext cx="7772400" cy="457200"/>
+            <a:off x="457200" y="1554480"/>
+            <a:ext cx="3108960" cy="1280160"/>
           </a:xfrm>
           <a:prstGeom prst="rect">
             <a:avLst/>
@@ -3318,14 +3318,14 @@
           </a:bodyPr>
           <a:lstStyle/>
           <a:p>
-            <a:pPr algn="r"/>
-            <a:r>
-              <a:rPr sz="2000" b="1" i="0">
-                <a:solidFill>
-                  <a:srgbClr val="F5C518"/>
-                </a:solidFill>
-              </a:rPr>
-              <a:t>מה זה?</a:t>
+            <a:pPr algn="ctr"/>
+            <a:r>
+              <a:rPr sz="7000" b="0" i="0">
+                <a:solidFill>
+                  <a:srgbClr val="FFFFFF"/>
+                </a:solidFill>
+              </a:rPr>
+              <a:t>🎓</a:t>
             </a:r>
           </a:p>
         </p:txBody>
@@ -3338,8 +3338,8 @@
         </p:nvSpPr>
         <p:spPr>
           <a:xfrm>
-            <a:off x="4114800" y="1874519"/>
-            <a:ext cx="7772400" cy="1828800"/>
+            <a:off x="274320" y="2926080"/>
+            <a:ext cx="3474720" cy="822960"/>
           </a:xfrm>
           <a:prstGeom prst="rect">
             <a:avLst/>
@@ -3352,47 +3352,14 @@
           </a:bodyPr>
           <a:lstStyle/>
           <a:p>
-            <a:pPr algn="r"/>
-            <a:r>
-              <a:rPr sz="1700">
-                <a:solidFill>
-                  <a:srgbClr val="FFFFFF"/>
-                </a:solidFill>
-              </a:rPr>
-              <a:t>● משחק לוח בסגנון מונופולי בנושא קורסי אוניברסיטה</a:t>
-            </a:r>
-          </a:p>
-          <a:p>
-            <a:pPr algn="r"/>
-            <a:r>
-              <a:rPr sz="1700">
-                <a:solidFill>
-                  <a:srgbClr val="FFFFFF"/>
-                </a:solidFill>
-              </a:rPr>
-              <a:t>● 2–4 שחקנים: אנושיים או בוטים</a:t>
-            </a:r>
-          </a:p>
-          <a:p>
-            <a:pPr algn="r"/>
-            <a:r>
-              <a:rPr sz="1700">
-                <a:solidFill>
-                  <a:srgbClr val="FFFFFF"/>
-                </a:solidFill>
-              </a:rPr>
-              <a:t>● לוח של 36 ריבועים: נכסים, תחנות וריבועים מיוחדים</a:t>
-            </a:r>
-          </a:p>
-          <a:p>
-            <a:pPr algn="r"/>
-            <a:r>
-              <a:rPr sz="1700">
-                <a:solidFill>
-                  <a:srgbClr val="FFFFFF"/>
-                </a:solidFill>
-              </a:rPr>
-              <a:t>● שתי גרסאות: קונסול (JOptionPane) וממשק גרפי מלא (Swing GUI)</a:t>
+            <a:pPr algn="r" rtl="1"/>
+            <a:r>
+              <a:rPr sz="2000" b="1" i="0">
+                <a:solidFill>
+                  <a:srgbClr val="F5C518"/>
+                </a:solidFill>
+              </a:rPr>
+              <a:t>סיור באוניברסיטה</a:t>
             </a:r>
           </a:p>
         </p:txBody>
@@ -3405,8 +3372,8 @@
         </p:nvSpPr>
         <p:spPr>
           <a:xfrm>
-            <a:off x="4114800" y="3794760"/>
-            <a:ext cx="7772400" cy="457200"/>
+            <a:off x="274320" y="3749039"/>
+            <a:ext cx="3474720" cy="457200"/>
           </a:xfrm>
           <a:prstGeom prst="rect">
             <a:avLst/>
@@ -3419,179 +3386,9 @@
           </a:bodyPr>
           <a:lstStyle/>
           <a:p>
-            <a:pPr algn="r"/>
-            <a:r>
-              <a:rPr sz="2000" b="1" i="0">
-                <a:solidFill>
-                  <a:srgbClr val="F5C518"/>
-                </a:solidFill>
-              </a:rPr>
-              <a:t>תכונות עיקריות</a:t>
-            </a:r>
-          </a:p>
-        </p:txBody>
-      </p:sp>
-      <p:sp>
-        <p:nvSpPr>
-          <p:cNvPr id="10" name="TextBox 9"/>
-          <p:cNvSpPr txBox="1"/>
-          <p:nvPr/>
-        </p:nvSpPr>
-        <p:spPr>
-          <a:xfrm>
-            <a:off x="4114800" y="4251960"/>
-            <a:ext cx="7772400" cy="2103120"/>
-          </a:xfrm>
-          <a:prstGeom prst="rect">
-            <a:avLst/>
-          </a:prstGeom>
-          <a:noFill/>
-        </p:spPr>
-        <p:txBody>
-          <a:bodyPr wrap="square">
-            <a:spAutoFit/>
-          </a:bodyPr>
-          <a:lstStyle/>
-          <a:p>
-            <a:pPr algn="r"/>
-            <a:r>
-              <a:rPr sz="1700">
-                <a:solidFill>
-                  <a:srgbClr val="FFFFFF"/>
-                </a:solidFill>
-              </a:rPr>
-              <a:t>● קנייה ושדרוג נכסים: קרקע ← בית 1 ← בית 2 ← בית 3 ← מלון</a:t>
-            </a:r>
-          </a:p>
-          <a:p>
-            <a:pPr algn="r"/>
-            <a:r>
-              <a:rPr sz="1700">
-                <a:solidFill>
-                  <a:srgbClr val="FFFFFF"/>
-                </a:solidFill>
-              </a:rPr>
-              <a:t>● מיני-גיים רולטה בריבוע התחלה — 10 סוגי הימור, עד 35:1</a:t>
-            </a:r>
-          </a:p>
-          <a:p>
-            <a:pPr algn="r"/>
-            <a:r>
-              <a:rPr sz="1700">
-                <a:solidFill>
-                  <a:srgbClr val="FFFFFF"/>
-                </a:solidFill>
-              </a:rPr>
-              <a:t>● שדה תעופה (טלפורט), כלא, מכפיל אליפות עולמית</a:t>
-            </a:r>
-          </a:p>
-          <a:p>
-            <a:pPr algn="r"/>
-            <a:r>
-              <a:rPr sz="1700">
-                <a:solidFill>
-                  <a:srgbClr val="FFFFFF"/>
-                </a:solidFill>
-              </a:rPr>
-              <a:t>● 3 תנאי ניצחון: 4 תחנות | 3 מונופולים | שורה מלאה</a:t>
-            </a:r>
-          </a:p>
-        </p:txBody>
-      </p:sp>
-      <p:sp>
-        <p:nvSpPr>
-          <p:cNvPr id="11" name="TextBox 10"/>
-          <p:cNvSpPr txBox="1"/>
-          <p:nvPr/>
-        </p:nvSpPr>
-        <p:spPr>
-          <a:xfrm>
-            <a:off x="457200" y="1645920"/>
-            <a:ext cx="3200400" cy="1280160"/>
-          </a:xfrm>
-          <a:prstGeom prst="rect">
-            <a:avLst/>
-          </a:prstGeom>
-          <a:noFill/>
-        </p:spPr>
-        <p:txBody>
-          <a:bodyPr wrap="square">
-            <a:spAutoFit/>
-          </a:bodyPr>
-          <a:lstStyle/>
-          <a:p>
-            <a:pPr algn="ctr"/>
-            <a:r>
-              <a:rPr sz="7200" b="0" i="0">
-                <a:solidFill>
-                  <a:srgbClr val="FFFFFF"/>
-                </a:solidFill>
-              </a:rPr>
-              <a:t>🎓</a:t>
-            </a:r>
-          </a:p>
-        </p:txBody>
-      </p:sp>
-      <p:sp>
-        <p:nvSpPr>
-          <p:cNvPr id="12" name="TextBox 11"/>
-          <p:cNvSpPr txBox="1"/>
-          <p:nvPr/>
-        </p:nvSpPr>
-        <p:spPr>
-          <a:xfrm>
-            <a:off x="365760" y="2926080"/>
-            <a:ext cx="3383280" cy="1280160"/>
-          </a:xfrm>
-          <a:prstGeom prst="rect">
-            <a:avLst/>
-          </a:prstGeom>
-          <a:noFill/>
-        </p:spPr>
-        <p:txBody>
-          <a:bodyPr wrap="square">
-            <a:spAutoFit/>
-          </a:bodyPr>
-          <a:lstStyle/>
-          <a:p>
-            <a:pPr algn="ctr"/>
-            <a:r>
-              <a:rPr sz="2400" b="1" i="0">
-                <a:solidFill>
-                  <a:srgbClr val="F5C518"/>
-                </a:solidFill>
-              </a:rPr>
-              <a:t>סיור
-באוניברסיטה</a:t>
-            </a:r>
-          </a:p>
-        </p:txBody>
-      </p:sp>
-      <p:sp>
-        <p:nvSpPr>
-          <p:cNvPr id="13" name="TextBox 12"/>
-          <p:cNvSpPr txBox="1"/>
-          <p:nvPr/>
-        </p:nvSpPr>
-        <p:spPr>
-          <a:xfrm>
-            <a:off x="365760" y="4251960"/>
-            <a:ext cx="3383280" cy="548640"/>
-          </a:xfrm>
-          <a:prstGeom prst="rect">
-            <a:avLst/>
-          </a:prstGeom>
-          <a:noFill/>
-        </p:spPr>
-        <p:txBody>
-          <a:bodyPr wrap="square">
-            <a:spAutoFit/>
-          </a:bodyPr>
-          <a:lstStyle/>
-          <a:p>
-            <a:pPr algn="ctr"/>
-            <a:r>
-              <a:rPr sz="1200" b="0" i="1">
+            <a:pPr algn="r" rtl="1"/>
+            <a:r>
+              <a:rPr sz="1300" b="0" i="1">
                 <a:solidFill>
                   <a:srgbClr val="D0E4F7"/>
                 </a:solidFill>
@@ -3603,14 +3400,14 @@
       </p:sp>
       <p:sp>
         <p:nvSpPr>
-          <p:cNvPr id="14" name="Rectangle 13"/>
+          <p:cNvPr id="10" name="Rectangle 9"/>
           <p:cNvSpPr/>
           <p:nvPr/>
         </p:nvSpPr>
         <p:spPr>
           <a:xfrm>
-            <a:off x="365760" y="6217920"/>
-            <a:ext cx="2560320" cy="502920"/>
+            <a:off x="320040" y="4343400"/>
+            <a:ext cx="3383280" cy="475488"/>
           </a:xfrm>
           <a:prstGeom prst="rect">
             <a:avLst/>
@@ -3646,14 +3443,14 @@
       </p:sp>
       <p:sp>
         <p:nvSpPr>
-          <p:cNvPr id="15" name="TextBox 14"/>
+          <p:cNvPr id="11" name="TextBox 10"/>
           <p:cNvSpPr txBox="1"/>
           <p:nvPr/>
         </p:nvSpPr>
         <p:spPr>
           <a:xfrm>
-            <a:off x="365760" y="6236208"/>
-            <a:ext cx="2560320" cy="256032"/>
+            <a:off x="320040" y="4398264"/>
+            <a:ext cx="640080" cy="347472"/>
           </a:xfrm>
           <a:prstGeom prst="rect">
             <a:avLst/>
@@ -3668,7 +3465,7 @@
           <a:p>
             <a:pPr algn="ctr"/>
             <a:r>
-              <a:rPr sz="1800" b="1" i="0">
+              <a:rPr sz="1600" b="1" i="0">
                 <a:solidFill>
                   <a:srgbClr val="F5C518"/>
                 </a:solidFill>
@@ -3680,14 +3477,14 @@
       </p:sp>
       <p:sp>
         <p:nvSpPr>
-          <p:cNvPr id="16" name="TextBox 15"/>
+          <p:cNvPr id="12" name="TextBox 11"/>
           <p:cNvSpPr txBox="1"/>
           <p:nvPr/>
         </p:nvSpPr>
         <p:spPr>
           <a:xfrm>
-            <a:off x="365760" y="6492240"/>
-            <a:ext cx="2560320" cy="256032"/>
+            <a:off x="914400" y="4416552"/>
+            <a:ext cx="2743200" cy="347472"/>
           </a:xfrm>
           <a:prstGeom prst="rect">
             <a:avLst/>
@@ -3700,11 +3497,11 @@
           </a:bodyPr>
           <a:lstStyle/>
           <a:p>
-            <a:pPr algn="ctr"/>
-            <a:r>
-              <a:rPr sz="1100" b="0" i="0">
-                <a:solidFill>
-                  <a:srgbClr val="D0E4F7"/>
+            <a:pPr algn="r" rtl="1"/>
+            <a:r>
+              <a:rPr sz="1400" b="0" i="0">
+                <a:solidFill>
+                  <a:srgbClr val="FFFFFF"/>
                 </a:solidFill>
               </a:rPr>
               <a:t>ריבועים</a:t>
@@ -3714,14 +3511,14 @@
       </p:sp>
       <p:sp>
         <p:nvSpPr>
-          <p:cNvPr id="17" name="Rectangle 16"/>
+          <p:cNvPr id="13" name="Rectangle 12"/>
           <p:cNvSpPr/>
           <p:nvPr/>
         </p:nvSpPr>
         <p:spPr>
           <a:xfrm>
-            <a:off x="3200400" y="6217920"/>
-            <a:ext cx="2560320" cy="502920"/>
+            <a:off x="320040" y="4892040"/>
+            <a:ext cx="3383280" cy="475488"/>
           </a:xfrm>
           <a:prstGeom prst="rect">
             <a:avLst/>
@@ -3757,14 +3554,14 @@
       </p:sp>
       <p:sp>
         <p:nvSpPr>
-          <p:cNvPr id="18" name="TextBox 17"/>
+          <p:cNvPr id="14" name="TextBox 13"/>
           <p:cNvSpPr txBox="1"/>
           <p:nvPr/>
         </p:nvSpPr>
         <p:spPr>
           <a:xfrm>
-            <a:off x="3200400" y="6236208"/>
-            <a:ext cx="2560320" cy="256032"/>
+            <a:off x="320040" y="4946903"/>
+            <a:ext cx="640080" cy="347472"/>
           </a:xfrm>
           <a:prstGeom prst="rect">
             <a:avLst/>
@@ -3779,7 +3576,7 @@
           <a:p>
             <a:pPr algn="ctr"/>
             <a:r>
-              <a:rPr sz="1800" b="1" i="0">
+              <a:rPr sz="1600" b="1" i="0">
                 <a:solidFill>
                   <a:srgbClr val="F5C518"/>
                 </a:solidFill>
@@ -3791,14 +3588,14 @@
       </p:sp>
       <p:sp>
         <p:nvSpPr>
-          <p:cNvPr id="19" name="TextBox 18"/>
+          <p:cNvPr id="15" name="TextBox 14"/>
           <p:cNvSpPr txBox="1"/>
           <p:nvPr/>
         </p:nvSpPr>
         <p:spPr>
           <a:xfrm>
-            <a:off x="3200400" y="6492240"/>
-            <a:ext cx="2560320" cy="256032"/>
+            <a:off x="914400" y="4965192"/>
+            <a:ext cx="2743200" cy="347472"/>
           </a:xfrm>
           <a:prstGeom prst="rect">
             <a:avLst/>
@@ -3811,11 +3608,11 @@
           </a:bodyPr>
           <a:lstStyle/>
           <a:p>
-            <a:pPr algn="ctr"/>
-            <a:r>
-              <a:rPr sz="1100" b="0" i="0">
-                <a:solidFill>
-                  <a:srgbClr val="D0E4F7"/>
+            <a:pPr algn="r" rtl="1"/>
+            <a:r>
+              <a:rPr sz="1400" b="0" i="0">
+                <a:solidFill>
+                  <a:srgbClr val="FFFFFF"/>
                 </a:solidFill>
               </a:rPr>
               <a:t>נכסים</a:t>
@@ -3825,14 +3622,14 @@
       </p:sp>
       <p:sp>
         <p:nvSpPr>
-          <p:cNvPr id="20" name="Rectangle 19"/>
+          <p:cNvPr id="16" name="Rectangle 15"/>
           <p:cNvSpPr/>
           <p:nvPr/>
         </p:nvSpPr>
         <p:spPr>
           <a:xfrm>
-            <a:off x="6035040" y="6217920"/>
-            <a:ext cx="2560320" cy="502920"/>
+            <a:off x="320040" y="5440680"/>
+            <a:ext cx="3383280" cy="475488"/>
           </a:xfrm>
           <a:prstGeom prst="rect">
             <a:avLst/>
@@ -3868,14 +3665,14 @@
       </p:sp>
       <p:sp>
         <p:nvSpPr>
-          <p:cNvPr id="21" name="TextBox 20"/>
+          <p:cNvPr id="17" name="TextBox 16"/>
           <p:cNvSpPr txBox="1"/>
           <p:nvPr/>
         </p:nvSpPr>
         <p:spPr>
           <a:xfrm>
-            <a:off x="6035040" y="6236208"/>
-            <a:ext cx="2560320" cy="256032"/>
+            <a:off x="320040" y="5495544"/>
+            <a:ext cx="640080" cy="347472"/>
           </a:xfrm>
           <a:prstGeom prst="rect">
             <a:avLst/>
@@ -3890,7 +3687,7 @@
           <a:p>
             <a:pPr algn="ctr"/>
             <a:r>
-              <a:rPr sz="1800" b="1" i="0">
+              <a:rPr sz="1600" b="1" i="0">
                 <a:solidFill>
                   <a:srgbClr val="F5C518"/>
                 </a:solidFill>
@@ -3902,14 +3699,14 @@
       </p:sp>
       <p:sp>
         <p:nvSpPr>
-          <p:cNvPr id="22" name="TextBox 21"/>
+          <p:cNvPr id="18" name="TextBox 17"/>
           <p:cNvSpPr txBox="1"/>
           <p:nvPr/>
         </p:nvSpPr>
         <p:spPr>
           <a:xfrm>
-            <a:off x="6035040" y="6492240"/>
-            <a:ext cx="2560320" cy="256032"/>
+            <a:off x="914400" y="5513832"/>
+            <a:ext cx="2743200" cy="347472"/>
           </a:xfrm>
           <a:prstGeom prst="rect">
             <a:avLst/>
@@ -3922,11 +3719,11 @@
           </a:bodyPr>
           <a:lstStyle/>
           <a:p>
-            <a:pPr algn="ctr"/>
-            <a:r>
-              <a:rPr sz="1100" b="0" i="0">
-                <a:solidFill>
-                  <a:srgbClr val="D0E4F7"/>
+            <a:pPr algn="r" rtl="1"/>
+            <a:r>
+              <a:rPr sz="1400" b="0" i="0">
+                <a:solidFill>
+                  <a:srgbClr val="FFFFFF"/>
                 </a:solidFill>
               </a:rPr>
               <a:t>תחנות</a:t>
@@ -3936,14 +3733,14 @@
       </p:sp>
       <p:sp>
         <p:nvSpPr>
-          <p:cNvPr id="23" name="Rectangle 22"/>
+          <p:cNvPr id="19" name="Rectangle 18"/>
           <p:cNvSpPr/>
           <p:nvPr/>
         </p:nvSpPr>
         <p:spPr>
           <a:xfrm>
-            <a:off x="8869680" y="6217920"/>
-            <a:ext cx="2560320" cy="502920"/>
+            <a:off x="320040" y="5989320"/>
+            <a:ext cx="3383280" cy="475488"/>
           </a:xfrm>
           <a:prstGeom prst="rect">
             <a:avLst/>
@@ -3979,14 +3776,14 @@
       </p:sp>
       <p:sp>
         <p:nvSpPr>
-          <p:cNvPr id="24" name="TextBox 23"/>
+          <p:cNvPr id="20" name="TextBox 19"/>
           <p:cNvSpPr txBox="1"/>
           <p:nvPr/>
         </p:nvSpPr>
         <p:spPr>
           <a:xfrm>
-            <a:off x="8869680" y="6236208"/>
-            <a:ext cx="2560320" cy="256032"/>
+            <a:off x="320040" y="6044183"/>
+            <a:ext cx="640080" cy="347472"/>
           </a:xfrm>
           <a:prstGeom prst="rect">
             <a:avLst/>
@@ -4001,7 +3798,7 @@
           <a:p>
             <a:pPr algn="ctr"/>
             <a:r>
-              <a:rPr sz="1800" b="1" i="0">
+              <a:rPr sz="1600" b="1" i="0">
                 <a:solidFill>
                   <a:srgbClr val="F5C518"/>
                 </a:solidFill>
@@ -4013,14 +3810,14 @@
       </p:sp>
       <p:sp>
         <p:nvSpPr>
-          <p:cNvPr id="25" name="TextBox 24"/>
+          <p:cNvPr id="21" name="TextBox 20"/>
           <p:cNvSpPr txBox="1"/>
           <p:nvPr/>
         </p:nvSpPr>
         <p:spPr>
           <a:xfrm>
-            <a:off x="8869680" y="6492240"/>
-            <a:ext cx="2560320" cy="256032"/>
+            <a:off x="914400" y="6062472"/>
+            <a:ext cx="2743200" cy="347472"/>
           </a:xfrm>
           <a:prstGeom prst="rect">
             <a:avLst/>
@@ -4033,14 +3830,216 @@
           </a:bodyPr>
           <a:lstStyle/>
           <a:p>
-            <a:pPr algn="ctr"/>
-            <a:r>
-              <a:rPr sz="1100" b="0" i="0">
-                <a:solidFill>
-                  <a:srgbClr val="D0E4F7"/>
+            <a:pPr algn="r" rtl="1"/>
+            <a:r>
+              <a:rPr sz="1400" b="0" i="0">
+                <a:solidFill>
+                  <a:srgbClr val="FFFFFF"/>
                 </a:solidFill>
               </a:rPr>
               <a:t>ניצחון</a:t>
+            </a:r>
+          </a:p>
+        </p:txBody>
+      </p:sp>
+      <p:sp>
+        <p:nvSpPr>
+          <p:cNvPr id="22" name="TextBox 21"/>
+          <p:cNvSpPr txBox="1"/>
+          <p:nvPr/>
+        </p:nvSpPr>
+        <p:spPr>
+          <a:xfrm>
+            <a:off x="3931920" y="1417320"/>
+            <a:ext cx="8046720" cy="457200"/>
+          </a:xfrm>
+          <a:prstGeom prst="rect">
+            <a:avLst/>
+          </a:prstGeom>
+          <a:noFill/>
+        </p:spPr>
+        <p:txBody>
+          <a:bodyPr wrap="square">
+            <a:spAutoFit/>
+          </a:bodyPr>
+          <a:lstStyle/>
+          <a:p>
+            <a:pPr algn="r" rtl="1"/>
+            <a:r>
+              <a:rPr sz="2100" b="1" i="0">
+                <a:solidFill>
+                  <a:srgbClr val="F5C518"/>
+                </a:solidFill>
+              </a:rPr>
+              <a:t>מה זה?</a:t>
+            </a:r>
+          </a:p>
+        </p:txBody>
+      </p:sp>
+      <p:sp>
+        <p:nvSpPr>
+          <p:cNvPr id="23" name="TextBox 22"/>
+          <p:cNvSpPr txBox="1"/>
+          <p:nvPr/>
+        </p:nvSpPr>
+        <p:spPr>
+          <a:xfrm>
+            <a:off x="3931920" y="1874519"/>
+            <a:ext cx="8046720" cy="1828800"/>
+          </a:xfrm>
+          <a:prstGeom prst="rect">
+            <a:avLst/>
+          </a:prstGeom>
+          <a:noFill/>
+        </p:spPr>
+        <p:txBody>
+          <a:bodyPr wrap="square">
+            <a:spAutoFit/>
+          </a:bodyPr>
+          <a:lstStyle/>
+          <a:p>
+            <a:pPr algn="r" rtl="1"/>
+            <a:r>
+              <a:rPr sz="1700">
+                <a:solidFill>
+                  <a:srgbClr val="FFFFFF"/>
+                </a:solidFill>
+              </a:rPr>
+              <a:t>● משחק לוח בסגנון מונופולי בנושא קורסי אוניברסיטה</a:t>
+            </a:r>
+          </a:p>
+          <a:p>
+            <a:pPr algn="r" rtl="1"/>
+            <a:r>
+              <a:rPr sz="1700">
+                <a:solidFill>
+                  <a:srgbClr val="FFFFFF"/>
+                </a:solidFill>
+              </a:rPr>
+              <a:t>● 2–4 שחקנים: אנושיים או בוטים</a:t>
+            </a:r>
+          </a:p>
+          <a:p>
+            <a:pPr algn="r" rtl="1"/>
+            <a:r>
+              <a:rPr sz="1700">
+                <a:solidFill>
+                  <a:srgbClr val="FFFFFF"/>
+                </a:solidFill>
+              </a:rPr>
+              <a:t>● לוח של 36 ריבועים: נכסים, תחנות וריבועים מיוחדים</a:t>
+            </a:r>
+          </a:p>
+          <a:p>
+            <a:pPr algn="r" rtl="1"/>
+            <a:r>
+              <a:rPr sz="1700">
+                <a:solidFill>
+                  <a:srgbClr val="FFFFFF"/>
+                </a:solidFill>
+              </a:rPr>
+              <a:t>● שתי גרסאות: קונסול (JOptionPane) וממשק גרפי (Swing GUI)</a:t>
+            </a:r>
+          </a:p>
+        </p:txBody>
+      </p:sp>
+      <p:sp>
+        <p:nvSpPr>
+          <p:cNvPr id="24" name="TextBox 23"/>
+          <p:cNvSpPr txBox="1"/>
+          <p:nvPr/>
+        </p:nvSpPr>
+        <p:spPr>
+          <a:xfrm>
+            <a:off x="3931920" y="3749039"/>
+            <a:ext cx="8046720" cy="457200"/>
+          </a:xfrm>
+          <a:prstGeom prst="rect">
+            <a:avLst/>
+          </a:prstGeom>
+          <a:noFill/>
+        </p:spPr>
+        <p:txBody>
+          <a:bodyPr wrap="square">
+            <a:spAutoFit/>
+          </a:bodyPr>
+          <a:lstStyle/>
+          <a:p>
+            <a:pPr algn="r" rtl="1"/>
+            <a:r>
+              <a:rPr sz="2100" b="1" i="0">
+                <a:solidFill>
+                  <a:srgbClr val="F5C518"/>
+                </a:solidFill>
+              </a:rPr>
+              <a:t>תכונות עיקריות</a:t>
+            </a:r>
+          </a:p>
+        </p:txBody>
+      </p:sp>
+      <p:sp>
+        <p:nvSpPr>
+          <p:cNvPr id="25" name="TextBox 24"/>
+          <p:cNvSpPr txBox="1"/>
+          <p:nvPr/>
+        </p:nvSpPr>
+        <p:spPr>
+          <a:xfrm>
+            <a:off x="3931920" y="4251960"/>
+            <a:ext cx="8046720" cy="2286000"/>
+          </a:xfrm>
+          <a:prstGeom prst="rect">
+            <a:avLst/>
+          </a:prstGeom>
+          <a:noFill/>
+        </p:spPr>
+        <p:txBody>
+          <a:bodyPr wrap="square">
+            <a:spAutoFit/>
+          </a:bodyPr>
+          <a:lstStyle/>
+          <a:p>
+            <a:pPr algn="r" rtl="1"/>
+            <a:r>
+              <a:rPr sz="1700">
+                <a:solidFill>
+                  <a:srgbClr val="FFFFFF"/>
+                </a:solidFill>
+              </a:rPr>
+              <a:t>● קנייה ושדרוג נכסים: קרקע ← בית 1 ← בית 2 ← בית 3 ← מלון</a:t>
+            </a:r>
+          </a:p>
+          <a:p>
+            <a:pPr algn="r" rtl="1"/>
+            <a:r>
+              <a:rPr sz="1700">
+                <a:solidFill>
+                  <a:srgbClr val="FFFFFF"/>
+                </a:solidFill>
+              </a:rPr>
+              <a:t>● מיני-גיים רולטה בריבוע התחלה — 10 סוגי הימור, עד 35:1</a:t>
+            </a:r>
+          </a:p>
+          <a:p>
+            <a:pPr algn="r" rtl="1"/>
+            <a:r>
+              <a:rPr sz="1700">
+                <a:solidFill>
+                  <a:srgbClr val="FFFFFF"/>
+                </a:solidFill>
+              </a:rPr>
+              <a:t>● שדה תעופה (טלפורט), כלא, מכפיל אליפות עולמית</a:t>
+            </a:r>
+          </a:p>
+          <a:p>
+            <a:pPr algn="r" rtl="1"/>
+            <a:r>
+              <a:rPr sz="1700">
+                <a:solidFill>
+                  <a:srgbClr val="FFFFFF"/>
+                </a:solidFill>
+              </a:rPr>
+              <a:t>● 3 תנאי ניצחון: 4 תחנות | 3 מונופולים | שורה מלאה בלוח</a:t>
             </a:r>
           </a:p>
         </p:txBody>
@@ -4165,8 +4164,8 @@
         </p:nvSpPr>
         <p:spPr>
           <a:xfrm>
-            <a:off x="365760" y="91440"/>
-            <a:ext cx="11430000" cy="685800"/>
+            <a:off x="274320" y="91440"/>
+            <a:ext cx="11612880" cy="685800"/>
           </a:xfrm>
           <a:prstGeom prst="rect">
             <a:avLst/>
@@ -4179,9 +4178,9 @@
           </a:bodyPr>
           <a:lstStyle/>
           <a:p>
-            <a:pPr algn="r"/>
-            <a:r>
-              <a:rPr sz="3200" b="1" i="0">
+            <a:pPr algn="r" rtl="1"/>
+            <a:r>
+              <a:rPr sz="3400" b="1" i="0">
                 <a:solidFill>
                   <a:srgbClr val="FFFFFF"/>
                 </a:solidFill>
@@ -4199,8 +4198,8 @@
         </p:nvSpPr>
         <p:spPr>
           <a:xfrm>
-            <a:off x="365760" y="749808"/>
-            <a:ext cx="11430000" cy="384048"/>
+            <a:off x="274320" y="749808"/>
+            <a:ext cx="11612880" cy="384048"/>
           </a:xfrm>
           <a:prstGeom prst="rect">
             <a:avLst/>
@@ -4213,7 +4212,7 @@
           </a:bodyPr>
           <a:lstStyle/>
           <a:p>
-            <a:pPr algn="r"/>
+            <a:pPr algn="r" rtl="1"/>
             <a:r>
               <a:rPr sz="1500" b="0" i="1">
                 <a:solidFill>
@@ -4233,8 +4232,8 @@
         </p:nvSpPr>
         <p:spPr>
           <a:xfrm>
-            <a:off x="6309360" y="1417320"/>
-            <a:ext cx="5486400" cy="457200"/>
+            <a:off x="6217920" y="1417320"/>
+            <a:ext cx="5669280" cy="457200"/>
           </a:xfrm>
           <a:prstGeom prst="rect">
             <a:avLst/>
@@ -4247,9 +4246,9 @@
           </a:bodyPr>
           <a:lstStyle/>
           <a:p>
-            <a:pPr algn="r"/>
-            <a:r>
-              <a:rPr sz="2000" b="1" i="0">
+            <a:pPr algn="r" rtl="1"/>
+            <a:r>
+              <a:rPr sz="2100" b="1" i="0">
                 <a:solidFill>
                   <a:srgbClr val="F5C518"/>
                 </a:solidFill>
@@ -4267,8 +4266,8 @@
         </p:nvSpPr>
         <p:spPr>
           <a:xfrm>
-            <a:off x="8595360" y="1920240"/>
-            <a:ext cx="384048" cy="384048"/>
+            <a:off x="6217920" y="1920240"/>
+            <a:ext cx="384048" cy="411480"/>
           </a:xfrm>
           <a:prstGeom prst="rect">
             <a:avLst/>
@@ -4310,8 +4309,8 @@
         </p:nvSpPr>
         <p:spPr>
           <a:xfrm>
-            <a:off x="8595360" y="1920240"/>
-            <a:ext cx="384048" cy="384048"/>
+            <a:off x="6217920" y="1975104"/>
+            <a:ext cx="384048" cy="320040"/>
           </a:xfrm>
           <a:prstGeom prst="rect">
             <a:avLst/>
@@ -4344,8 +4343,8 @@
         </p:nvSpPr>
         <p:spPr>
           <a:xfrm>
-            <a:off x="6309360" y="1938528"/>
-            <a:ext cx="2194560" cy="384048"/>
+            <a:off x="6675120" y="1956816"/>
+            <a:ext cx="5212080" cy="384048"/>
           </a:xfrm>
           <a:prstGeom prst="rect">
             <a:avLst/>
@@ -4358,9 +4357,9 @@
           </a:bodyPr>
           <a:lstStyle/>
           <a:p>
-            <a:pPr algn="r"/>
-            <a:r>
-              <a:rPr sz="1400" b="0" i="0">
+            <a:pPr algn="r" rtl="1"/>
+            <a:r>
+              <a:rPr sz="1500" b="0" i="0">
                 <a:solidFill>
                   <a:srgbClr val="FFFFFF"/>
                 </a:solidFill>
@@ -4378,8 +4377,8 @@
         </p:nvSpPr>
         <p:spPr>
           <a:xfrm>
-            <a:off x="8595360" y="2587752"/>
-            <a:ext cx="384048" cy="384048"/>
+            <a:off x="6217920" y="2587752"/>
+            <a:ext cx="384048" cy="411480"/>
           </a:xfrm>
           <a:prstGeom prst="rect">
             <a:avLst/>
@@ -4421,8 +4420,8 @@
         </p:nvSpPr>
         <p:spPr>
           <a:xfrm>
-            <a:off x="8595360" y="2587752"/>
-            <a:ext cx="384048" cy="384048"/>
+            <a:off x="6217920" y="2642616"/>
+            <a:ext cx="384048" cy="320040"/>
           </a:xfrm>
           <a:prstGeom prst="rect">
             <a:avLst/>
@@ -4455,8 +4454,8 @@
         </p:nvSpPr>
         <p:spPr>
           <a:xfrm>
-            <a:off x="6309360" y="2606040"/>
-            <a:ext cx="2194560" cy="384048"/>
+            <a:off x="6675120" y="2624328"/>
+            <a:ext cx="5212080" cy="384048"/>
           </a:xfrm>
           <a:prstGeom prst="rect">
             <a:avLst/>
@@ -4469,9 +4468,9 @@
           </a:bodyPr>
           <a:lstStyle/>
           <a:p>
-            <a:pPr algn="r"/>
-            <a:r>
-              <a:rPr sz="1400" b="0" i="0">
+            <a:pPr algn="r" rtl="1"/>
+            <a:r>
+              <a:rPr sz="1500" b="0" i="0">
                 <a:solidFill>
                   <a:srgbClr val="FFFFFF"/>
                 </a:solidFill>
@@ -4489,8 +4488,8 @@
         </p:nvSpPr>
         <p:spPr>
           <a:xfrm>
-            <a:off x="8595360" y="3255264"/>
-            <a:ext cx="384048" cy="384048"/>
+            <a:off x="6217920" y="3255264"/>
+            <a:ext cx="384048" cy="411480"/>
           </a:xfrm>
           <a:prstGeom prst="rect">
             <a:avLst/>
@@ -4532,8 +4531,8 @@
         </p:nvSpPr>
         <p:spPr>
           <a:xfrm>
-            <a:off x="8595360" y="3255264"/>
-            <a:ext cx="384048" cy="384048"/>
+            <a:off x="6217920" y="3310128"/>
+            <a:ext cx="384048" cy="320040"/>
           </a:xfrm>
           <a:prstGeom prst="rect">
             <a:avLst/>
@@ -4566,8 +4565,8 @@
         </p:nvSpPr>
         <p:spPr>
           <a:xfrm>
-            <a:off x="6309360" y="3273552"/>
-            <a:ext cx="2194560" cy="384048"/>
+            <a:off x="6675120" y="3291840"/>
+            <a:ext cx="5212080" cy="384048"/>
           </a:xfrm>
           <a:prstGeom prst="rect">
             <a:avLst/>
@@ -4580,9 +4579,9 @@
           </a:bodyPr>
           <a:lstStyle/>
           <a:p>
-            <a:pPr algn="r"/>
-            <a:r>
-              <a:rPr sz="1400" b="0" i="0">
+            <a:pPr algn="r" rtl="1"/>
+            <a:r>
+              <a:rPr sz="1500" b="0" i="0">
                 <a:solidFill>
                   <a:srgbClr val="FFFFFF"/>
                 </a:solidFill>
@@ -4600,8 +4599,8 @@
         </p:nvSpPr>
         <p:spPr>
           <a:xfrm>
-            <a:off x="8595360" y="3922776"/>
-            <a:ext cx="384048" cy="384048"/>
+            <a:off x="6217920" y="3922776"/>
+            <a:ext cx="384048" cy="411480"/>
           </a:xfrm>
           <a:prstGeom prst="rect">
             <a:avLst/>
@@ -4643,8 +4642,8 @@
         </p:nvSpPr>
         <p:spPr>
           <a:xfrm>
-            <a:off x="8595360" y="3922776"/>
-            <a:ext cx="384048" cy="384048"/>
+            <a:off x="6217920" y="3977639"/>
+            <a:ext cx="384048" cy="320040"/>
           </a:xfrm>
           <a:prstGeom prst="rect">
             <a:avLst/>
@@ -4677,8 +4676,8 @@
         </p:nvSpPr>
         <p:spPr>
           <a:xfrm>
-            <a:off x="6309360" y="3941063"/>
-            <a:ext cx="2194560" cy="384048"/>
+            <a:off x="6675120" y="3959352"/>
+            <a:ext cx="5212080" cy="384048"/>
           </a:xfrm>
           <a:prstGeom prst="rect">
             <a:avLst/>
@@ -4691,9 +4690,9 @@
           </a:bodyPr>
           <a:lstStyle/>
           <a:p>
-            <a:pPr algn="r"/>
-            <a:r>
-              <a:rPr sz="1400" b="0" i="0">
+            <a:pPr algn="r" rtl="1"/>
+            <a:r>
+              <a:rPr sz="1500" b="0" i="0">
                 <a:solidFill>
                   <a:srgbClr val="FFFFFF"/>
                 </a:solidFill>
@@ -4711,8 +4710,8 @@
         </p:nvSpPr>
         <p:spPr>
           <a:xfrm>
-            <a:off x="8595360" y="4590288"/>
-            <a:ext cx="384048" cy="384048"/>
+            <a:off x="6217920" y="4590288"/>
+            <a:ext cx="384048" cy="411480"/>
           </a:xfrm>
           <a:prstGeom prst="rect">
             <a:avLst/>
@@ -4754,8 +4753,8 @@
         </p:nvSpPr>
         <p:spPr>
           <a:xfrm>
-            <a:off x="8595360" y="4590288"/>
-            <a:ext cx="384048" cy="384048"/>
+            <a:off x="6217920" y="4645151"/>
+            <a:ext cx="384048" cy="320040"/>
           </a:xfrm>
           <a:prstGeom prst="rect">
             <a:avLst/>
@@ -4788,8 +4787,8 @@
         </p:nvSpPr>
         <p:spPr>
           <a:xfrm>
-            <a:off x="6309360" y="4608575"/>
-            <a:ext cx="2194560" cy="384048"/>
+            <a:off x="6675120" y="4626864"/>
+            <a:ext cx="5212080" cy="384048"/>
           </a:xfrm>
           <a:prstGeom prst="rect">
             <a:avLst/>
@@ -4802,9 +4801,9 @@
           </a:bodyPr>
           <a:lstStyle/>
           <a:p>
-            <a:pPr algn="r"/>
-            <a:r>
-              <a:rPr sz="1400" b="0" i="0">
+            <a:pPr algn="r" rtl="1"/>
+            <a:r>
+              <a:rPr sz="1500" b="0" i="0">
                 <a:solidFill>
                   <a:srgbClr val="FFFFFF"/>
                 </a:solidFill>
@@ -4822,8 +4821,8 @@
         </p:nvSpPr>
         <p:spPr>
           <a:xfrm>
-            <a:off x="8595360" y="5257800"/>
-            <a:ext cx="384048" cy="384048"/>
+            <a:off x="6217920" y="5257800"/>
+            <a:ext cx="384048" cy="411480"/>
           </a:xfrm>
           <a:prstGeom prst="rect">
             <a:avLst/>
@@ -4865,8 +4864,8 @@
         </p:nvSpPr>
         <p:spPr>
           <a:xfrm>
-            <a:off x="8595360" y="5257800"/>
-            <a:ext cx="384048" cy="384048"/>
+            <a:off x="6217920" y="5312664"/>
+            <a:ext cx="384048" cy="320040"/>
           </a:xfrm>
           <a:prstGeom prst="rect">
             <a:avLst/>
@@ -4899,8 +4898,8 @@
         </p:nvSpPr>
         <p:spPr>
           <a:xfrm>
-            <a:off x="6309360" y="5276088"/>
-            <a:ext cx="2194560" cy="384048"/>
+            <a:off x="6675120" y="5294376"/>
+            <a:ext cx="5212080" cy="384048"/>
           </a:xfrm>
           <a:prstGeom prst="rect">
             <a:avLst/>
@@ -4913,9 +4912,9 @@
           </a:bodyPr>
           <a:lstStyle/>
           <a:p>
-            <a:pPr algn="r"/>
-            <a:r>
-              <a:rPr sz="1400" b="0" i="0">
+            <a:pPr algn="r" rtl="1"/>
+            <a:r>
+              <a:rPr sz="1500" b="0" i="0">
                 <a:solidFill>
                   <a:srgbClr val="FFFFFF"/>
                 </a:solidFill>
@@ -4933,7 +4932,7 @@
         </p:nvSpPr>
         <p:spPr>
           <a:xfrm>
-            <a:off x="6035040" y="1325880"/>
+            <a:off x="5989320" y="1325880"/>
             <a:ext cx="36576" cy="5303520"/>
           </a:xfrm>
           <a:prstGeom prst="rect">
@@ -4976,8 +4975,8 @@
         </p:nvSpPr>
         <p:spPr>
           <a:xfrm>
-            <a:off x="365760" y="1417320"/>
-            <a:ext cx="5486400" cy="457200"/>
+            <a:off x="274320" y="1417320"/>
+            <a:ext cx="5577840" cy="457200"/>
           </a:xfrm>
           <a:prstGeom prst="rect">
             <a:avLst/>
@@ -4990,9 +4989,9 @@
           </a:bodyPr>
           <a:lstStyle/>
           <a:p>
-            <a:pPr algn="r"/>
-            <a:r>
-              <a:rPr sz="2000" b="1" i="0">
+            <a:pPr algn="r" rtl="1"/>
+            <a:r>
+              <a:rPr sz="2100" b="1" i="0">
                 <a:solidFill>
                   <a:srgbClr val="F5C518"/>
                 </a:solidFill>
@@ -5010,8 +5009,8 @@
         </p:nvSpPr>
         <p:spPr>
           <a:xfrm>
-            <a:off x="365760" y="1920240"/>
-            <a:ext cx="5486400" cy="4114800"/>
+            <a:off x="274320" y="1920240"/>
+            <a:ext cx="5577840" cy="4114800"/>
           </a:xfrm>
           <a:prstGeom prst="rect">
             <a:avLst/>
@@ -5024,9 +5023,9 @@
           </a:bodyPr>
           <a:lstStyle/>
           <a:p>
-            <a:pPr algn="r"/>
-            <a:r>
-              <a:rPr sz="1500">
+            <a:pPr algn="r" rtl="1"/>
+            <a:r>
+              <a:rPr sz="1600">
                 <a:solidFill>
                   <a:srgbClr val="D0E4F7"/>
                 </a:solidFill>
@@ -5035,9 +5034,9 @@
             </a:r>
           </a:p>
           <a:p>
-            <a:pPr algn="r"/>
-            <a:r>
-              <a:rPr sz="1500">
+            <a:pPr algn="r" rtl="1"/>
+            <a:r>
+              <a:rPr sz="1600">
                 <a:solidFill>
                   <a:srgbClr val="D0E4F7"/>
                 </a:solidFill>
@@ -5046,9 +5045,9 @@
             </a:r>
           </a:p>
           <a:p>
-            <a:pPr algn="r"/>
-            <a:r>
-              <a:rPr sz="1500">
+            <a:pPr algn="r" rtl="1"/>
+            <a:r>
+              <a:rPr sz="1600">
                 <a:solidFill>
                   <a:srgbClr val="D0E4F7"/>
                 </a:solidFill>
@@ -5057,9 +5056,9 @@
             </a:r>
           </a:p>
           <a:p>
-            <a:pPr algn="r"/>
-            <a:r>
-              <a:rPr sz="1500">
+            <a:pPr algn="r" rtl="1"/>
+            <a:r>
+              <a:rPr sz="1600">
                 <a:solidFill>
                   <a:srgbClr val="D0E4F7"/>
                 </a:solidFill>
@@ -5068,20 +5067,20 @@
             </a:r>
           </a:p>
           <a:p>
-            <a:pPr algn="r"/>
-            <a:r>
-              <a:rPr sz="1500">
+            <a:pPr algn="r" rtl="1"/>
+            <a:r>
+              <a:rPr sz="1600">
                 <a:solidFill>
                   <a:srgbClr val="D0E4F7"/>
                 </a:solidFill>
               </a:rPr>
-              <a:t>⚠  הבוט לא חוסם את ה-UI thread של השחקן האנושי</a:t>
-            </a:r>
-          </a:p>
-          <a:p>
-            <a:pPr algn="r"/>
-            <a:r>
-              <a:rPr sz="1500">
+              <a:t>⚠  הבוט לא חוסם את ה-UI thread האנושי</a:t>
+            </a:r>
+          </a:p>
+          <a:p>
+            <a:pPr algn="r" rtl="1"/>
+            <a:r>
+              <a:rPr sz="1600">
                 <a:solidFill>
                   <a:srgbClr val="D0E4F7"/>
                 </a:solidFill>
@@ -5211,8 +5210,8 @@
         </p:nvSpPr>
         <p:spPr>
           <a:xfrm>
-            <a:off x="365760" y="91440"/>
-            <a:ext cx="11430000" cy="685800"/>
+            <a:off x="274320" y="91440"/>
+            <a:ext cx="11612880" cy="685800"/>
           </a:xfrm>
           <a:prstGeom prst="rect">
             <a:avLst/>
@@ -5225,9 +5224,9 @@
           </a:bodyPr>
           <a:lstStyle/>
           <a:p>
-            <a:pPr algn="r"/>
-            <a:r>
-              <a:rPr sz="3200" b="1" i="0">
+            <a:pPr algn="r" rtl="1"/>
+            <a:r>
+              <a:rPr sz="3400" b="1" i="0">
                 <a:solidFill>
                   <a:srgbClr val="FFFFFF"/>
                 </a:solidFill>
@@ -5245,8 +5244,8 @@
         </p:nvSpPr>
         <p:spPr>
           <a:xfrm>
-            <a:off x="365760" y="749808"/>
-            <a:ext cx="11430000" cy="384048"/>
+            <a:off x="274320" y="749808"/>
+            <a:ext cx="11612880" cy="384048"/>
           </a:xfrm>
           <a:prstGeom prst="rect">
             <a:avLst/>
@@ -5259,7 +5258,7 @@
           </a:bodyPr>
           <a:lstStyle/>
           <a:p>
-            <a:pPr algn="r"/>
+            <a:pPr algn="r" rtl="1"/>
             <a:r>
               <a:rPr sz="1500" b="0" i="1">
                 <a:solidFill>
@@ -5379,9 +5378,9 @@
           </a:bodyPr>
           <a:lstStyle/>
           <a:p>
-            <a:pPr algn="r"/>
-            <a:r>
-              <a:rPr sz="1600" b="1" i="0">
+            <a:pPr algn="r" rtl="1"/>
+            <a:r>
+              <a:rPr sz="1700" b="1" i="0">
                 <a:solidFill>
                   <a:srgbClr val="F5C518"/>
                 </a:solidFill>
@@ -5413,9 +5412,9 @@
           </a:bodyPr>
           <a:lstStyle/>
           <a:p>
-            <a:pPr algn="r"/>
-            <a:r>
-              <a:rPr sz="1400">
+            <a:pPr algn="r" rtl="1"/>
+            <a:r>
+              <a:rPr sz="1500">
                 <a:solidFill>
                   <a:srgbClr val="D0E4F7"/>
                 </a:solidFill>
@@ -5424,31 +5423,31 @@
             </a:r>
           </a:p>
           <a:p>
-            <a:pPr algn="r"/>
-            <a:r>
-              <a:rPr sz="1400">
+            <a:pPr algn="r" rtl="1"/>
+            <a:r>
+              <a:rPr sz="1500">
                 <a:solidFill>
                   <a:srgbClr val="D0E4F7"/>
                 </a:solidFill>
               </a:rPr>
-              <a:t>✓  קנייה ב-4 רמות: קרקע / 1-3 בתים / מלון</a:t>
-            </a:r>
-          </a:p>
-          <a:p>
-            <a:pPr algn="r"/>
-            <a:r>
-              <a:rPr sz="1400">
+              <a:t>✓  קנייה ב-4 רמות: קרקע / בתים / מלון</a:t>
+            </a:r>
+          </a:p>
+          <a:p>
+            <a:pPr algn="r" rtl="1"/>
+            <a:r>
+              <a:rPr sz="1500">
                 <a:solidFill>
                   <a:srgbClr val="D0E4F7"/>
                 </a:solidFill>
               </a:rPr>
-              <a:t>✓  שכירות: ×1 ← ×3 ← ×6 ← ×10 ← ×16</a:t>
-            </a:r>
-          </a:p>
-          <a:p>
-            <a:pPr algn="r"/>
-            <a:r>
-              <a:rPr sz="1400">
+              <a:t>✓  שכירות: x1 -&gt; x3 -&gt; x6 -&gt; x10 -&gt; x16</a:t>
+            </a:r>
+          </a:p>
+          <a:p>
+            <a:pPr algn="r" rtl="1"/>
+            <a:r>
+              <a:rPr sz="1500">
                 <a:solidFill>
                   <a:srgbClr val="D0E4F7"/>
                 </a:solidFill>
@@ -5457,14 +5456,14 @@
             </a:r>
           </a:p>
           <a:p>
-            <a:pPr algn="r"/>
-            <a:r>
-              <a:rPr sz="1400">
+            <a:pPr algn="r" rtl="1"/>
+            <a:r>
+              <a:rPr sz="1500">
                 <a:solidFill>
                   <a:srgbClr val="D0E4F7"/>
                 </a:solidFill>
               </a:rPr>
-              <a:t>✓  בית 3 נעול עד השלמת סיבוב ראשון</a:t>
+              <a:t>✓  בית 3 נעול עד סיום סיבוב ראשון</a:t>
             </a:r>
           </a:p>
         </p:txBody>
@@ -5577,9 +5576,9 @@
           </a:bodyPr>
           <a:lstStyle/>
           <a:p>
-            <a:pPr algn="r"/>
-            <a:r>
-              <a:rPr sz="1600" b="1" i="0">
+            <a:pPr algn="r" rtl="1"/>
+            <a:r>
+              <a:rPr sz="1700" b="1" i="0">
                 <a:solidFill>
                   <a:srgbClr val="F5C518"/>
                 </a:solidFill>
@@ -5611,20 +5610,20 @@
           </a:bodyPr>
           <a:lstStyle/>
           <a:p>
-            <a:pPr algn="r"/>
-            <a:r>
-              <a:rPr sz="1400">
+            <a:pPr algn="r" rtl="1"/>
+            <a:r>
+              <a:rPr sz="1500">
                 <a:solidFill>
                   <a:srgbClr val="D0E4F7"/>
                 </a:solidFill>
               </a:rPr>
-              <a:t>✓  התחלה: ₪200k + קזינו רולטה</a:t>
-            </a:r>
-          </a:p>
-          <a:p>
-            <a:pPr algn="r"/>
-            <a:r>
-              <a:rPr sz="1400">
+              <a:t>✓  התחלה: 200k + קזינו רולטה (10 סוגי הימור)</a:t>
+            </a:r>
+          </a:p>
+          <a:p>
+            <a:pPr algn="r" rtl="1"/>
+            <a:r>
+              <a:rPr sz="1500">
                 <a:solidFill>
                   <a:srgbClr val="D0E4F7"/>
                 </a:solidFill>
@@ -5633,31 +5632,31 @@
             </a:r>
           </a:p>
           <a:p>
-            <a:pPr algn="r"/>
-            <a:r>
-              <a:rPr sz="1400">
+            <a:pPr algn="r" rtl="1"/>
+            <a:r>
+              <a:rPr sz="1500">
                 <a:solidFill>
                   <a:srgbClr val="D0E4F7"/>
                 </a:solidFill>
               </a:rPr>
-              <a:t>✓  שדה תעופה: טלפורט ב-₪100k לנכס פנוי</a:t>
-            </a:r>
-          </a:p>
-          <a:p>
-            <a:pPr algn="r"/>
-            <a:r>
-              <a:rPr sz="1400">
+              <a:t>✓  שדה תעופה: טלפורט ב-100k לנכס פנוי</a:t>
+            </a:r>
+          </a:p>
+          <a:p>
+            <a:pPr algn="r" rtl="1"/>
+            <a:r>
+              <a:rPr sz="1500">
                 <a:solidFill>
                   <a:srgbClr val="D0E4F7"/>
                 </a:solidFill>
               </a:rPr>
-              <a:t>✓  אליפות עולמית: מכפיל שכירות גלובלי (×2, ×3...)</a:t>
-            </a:r>
-          </a:p>
-          <a:p>
-            <a:pPr algn="r"/>
-            <a:r>
-              <a:rPr sz="1400">
+              <a:t>✓  אליפות עולמית: מכפיל שכירות (x2, x3...)</a:t>
+            </a:r>
+          </a:p>
+          <a:p>
+            <a:pPr algn="r" rtl="1"/>
+            <a:r>
+              <a:rPr sz="1500">
                 <a:solidFill>
                   <a:srgbClr val="D0E4F7"/>
                 </a:solidFill>
@@ -5775,9 +5774,9 @@
           </a:bodyPr>
           <a:lstStyle/>
           <a:p>
-            <a:pPr algn="r"/>
-            <a:r>
-              <a:rPr sz="1600" b="1" i="0">
+            <a:pPr algn="r" rtl="1"/>
+            <a:r>
+              <a:rPr sz="1700" b="1" i="0">
                 <a:solidFill>
                   <a:srgbClr val="F5C518"/>
                 </a:solidFill>
@@ -5809,31 +5808,31 @@
           </a:bodyPr>
           <a:lstStyle/>
           <a:p>
-            <a:pPr algn="r"/>
-            <a:r>
-              <a:rPr sz="1400">
+            <a:pPr algn="r" rtl="1"/>
+            <a:r>
+              <a:rPr sz="1500">
                 <a:solidFill>
                   <a:srgbClr val="D0E4F7"/>
                 </a:solidFill>
               </a:rPr>
-              <a:t>✓  אנושי: אינטראקציה מלאה — JOptionPane / GUI</a:t>
-            </a:r>
-          </a:p>
-          <a:p>
-            <a:pPr algn="r"/>
-            <a:r>
-              <a:rPr sz="1400">
+              <a:t>✓  אנושי: JOptionPane + GUI מלא</a:t>
+            </a:r>
+          </a:p>
+          <a:p>
+            <a:pPr algn="r" rtl="1"/>
+            <a:r>
+              <a:rPr sz="1500">
                 <a:solidFill>
                   <a:srgbClr val="D0E4F7"/>
                 </a:solidFill>
               </a:rPr>
-              <a:t>✓  בוט: קונה אוטומטי אם מחיר &lt; 40% מהכסף</a:t>
-            </a:r>
-          </a:p>
-          <a:p>
-            <a:pPr algn="r"/>
-            <a:r>
-              <a:rPr sz="1400">
+              <a:t>✓  בוט: קנייה אוטומטית אם מחיר &lt; 40% מהכסף</a:t>
+            </a:r>
+          </a:p>
+          <a:p>
+            <a:pPr algn="r" rtl="1"/>
+            <a:r>
+              <a:rPr sz="1500">
                 <a:solidFill>
                   <a:srgbClr val="D0E4F7"/>
                 </a:solidFill>
@@ -5842,25 +5841,25 @@
             </a:r>
           </a:p>
           <a:p>
-            <a:pPr algn="r"/>
-            <a:r>
-              <a:rPr sz="1400">
+            <a:pPr algn="r" rtl="1"/>
+            <a:r>
+              <a:rPr sz="1500">
                 <a:solidFill>
                   <a:srgbClr val="D0E4F7"/>
                 </a:solidFill>
               </a:rPr>
-              <a:t>✓  ניצחון: 3 מונופולים צבעוניים מלאים</a:t>
-            </a:r>
-          </a:p>
-          <a:p>
-            <a:pPr algn="r"/>
-            <a:r>
-              <a:rPr sz="1400">
+              <a:t>✓  ניצחון: 3 מונופולים צבעוניים</a:t>
+            </a:r>
+          </a:p>
+          <a:p>
+            <a:pPr algn="r" rtl="1"/>
+            <a:r>
+              <a:rPr sz="1500">
                 <a:solidFill>
                   <a:srgbClr val="D0E4F7"/>
                 </a:solidFill>
               </a:rPr>
-              <a:t>✓  ניצחון: כל הנכסים בצלע אחת של הלוח</a:t>
+              <a:t>✓  ניצחון: כל הנכסים בצלע אחת</a:t>
             </a:r>
           </a:p>
         </p:txBody>
@@ -5985,8 +5984,8 @@
         </p:nvSpPr>
         <p:spPr>
           <a:xfrm>
-            <a:off x="365760" y="91440"/>
-            <a:ext cx="11430000" cy="685800"/>
+            <a:off x="274320" y="91440"/>
+            <a:ext cx="11612880" cy="685800"/>
           </a:xfrm>
           <a:prstGeom prst="rect">
             <a:avLst/>
@@ -5999,9 +5998,9 @@
           </a:bodyPr>
           <a:lstStyle/>
           <a:p>
-            <a:pPr algn="r"/>
-            <a:r>
-              <a:rPr sz="3200" b="1" i="0">
+            <a:pPr algn="r" rtl="1"/>
+            <a:r>
+              <a:rPr sz="3400" b="1" i="0">
                 <a:solidFill>
                   <a:srgbClr val="FFFFFF"/>
                 </a:solidFill>
@@ -6019,8 +6018,8 @@
         </p:nvSpPr>
         <p:spPr>
           <a:xfrm>
-            <a:off x="365760" y="749808"/>
-            <a:ext cx="11430000" cy="384048"/>
+            <a:off x="274320" y="749808"/>
+            <a:ext cx="11612880" cy="384048"/>
           </a:xfrm>
           <a:prstGeom prst="rect">
             <a:avLst/>
@@ -6033,7 +6032,7 @@
           </a:bodyPr>
           <a:lstStyle/>
           <a:p>
-            <a:pPr algn="r"/>
+            <a:pPr algn="r" rtl="1"/>
             <a:r>
               <a:rPr sz="1500" b="0" i="1">
                 <a:solidFill>
@@ -6053,14 +6052,14 @@
         </p:nvSpPr>
         <p:spPr>
           <a:xfrm>
-            <a:off x="274320" y="1371600"/>
-            <a:ext cx="1920240" cy="1188720"/>
+            <a:off x="228600" y="1353312"/>
+            <a:ext cx="2011680" cy="1234440"/>
           </a:xfrm>
           <a:prstGeom prst="rect">
             <a:avLst/>
           </a:prstGeom>
           <a:solidFill>
-            <a:srgbClr val="0A1420"/>
+            <a:srgbClr val="081222"/>
           </a:solidFill>
           <a:ln>
             <a:noFill/>
@@ -6096,8 +6095,8 @@
         </p:nvSpPr>
         <p:spPr>
           <a:xfrm>
-            <a:off x="274320" y="1371600"/>
-            <a:ext cx="1920240" cy="347472"/>
+            <a:off x="228600" y="1353312"/>
+            <a:ext cx="2011680" cy="365760"/>
           </a:xfrm>
           <a:prstGeom prst="rect">
             <a:avLst/>
@@ -6139,8 +6138,8 @@
         </p:nvSpPr>
         <p:spPr>
           <a:xfrm>
-            <a:off x="274320" y="1380744"/>
-            <a:ext cx="1920240" cy="182880"/>
+            <a:off x="228600" y="1362456"/>
+            <a:ext cx="2011680" cy="182880"/>
           </a:xfrm>
           <a:prstGeom prst="rect">
             <a:avLst/>
@@ -6173,8 +6172,8 @@
         </p:nvSpPr>
         <p:spPr>
           <a:xfrm>
-            <a:off x="274320" y="1536192"/>
-            <a:ext cx="1920240" cy="201168"/>
+            <a:off x="228600" y="1527048"/>
+            <a:ext cx="2011680" cy="201168"/>
           </a:xfrm>
           <a:prstGeom prst="rect">
             <a:avLst/>
@@ -6207,8 +6206,8 @@
         </p:nvSpPr>
         <p:spPr>
           <a:xfrm>
-            <a:off x="274320" y="1719072"/>
-            <a:ext cx="1920240" cy="18288"/>
+            <a:off x="228600" y="1719072"/>
+            <a:ext cx="2011680" cy="18288"/>
           </a:xfrm>
           <a:prstGeom prst="rect">
             <a:avLst/>
@@ -6250,8 +6249,8 @@
         </p:nvSpPr>
         <p:spPr>
           <a:xfrm>
-            <a:off x="338328" y="1773936"/>
-            <a:ext cx="1792224" cy="731520"/>
+            <a:off x="274320" y="1764792"/>
+            <a:ext cx="1920240" cy="795528"/>
           </a:xfrm>
           <a:prstGeom prst="rect">
             <a:avLst/>
@@ -6264,23 +6263,25 @@
           </a:bodyPr>
           <a:lstStyle/>
           <a:p>
+            <a:pPr algn="l"/>
             <a:r>
               <a:rPr sz="900">
                 <a:solidFill>
                   <a:srgbClr val="D0E4F7"/>
                 </a:solidFill>
               </a:rPr>
-              <a:t>+ getName(): String</a:t>
-            </a:r>
-          </a:p>
-          <a:p>
+              <a:t>  + getName(): String</a:t>
+            </a:r>
+          </a:p>
+          <a:p>
+            <a:pPr algn="l"/>
             <a:r>
               <a:rPr sz="900">
                 <a:solidFill>
                   <a:srgbClr val="D0E4F7"/>
                 </a:solidFill>
               </a:rPr>
-              <a:t>+ landOn(Player)</a:t>
+              <a:t>  + landOn(Player)</a:t>
             </a:r>
           </a:p>
         </p:txBody>
@@ -6293,14 +6294,14 @@
         </p:nvSpPr>
         <p:spPr>
           <a:xfrm>
-            <a:off x="2834640" y="1371600"/>
-            <a:ext cx="2560320" cy="1463040"/>
+            <a:off x="2606040" y="1353312"/>
+            <a:ext cx="2743200" cy="1508760"/>
           </a:xfrm>
           <a:prstGeom prst="rect">
             <a:avLst/>
           </a:prstGeom>
           <a:solidFill>
-            <a:srgbClr val="0A1420"/>
+            <a:srgbClr val="081222"/>
           </a:solidFill>
           <a:ln>
             <a:noFill/>
@@ -6336,8 +6337,8 @@
         </p:nvSpPr>
         <p:spPr>
           <a:xfrm>
-            <a:off x="2834640" y="1371600"/>
-            <a:ext cx="2560320" cy="347472"/>
+            <a:off x="2606040" y="1353312"/>
+            <a:ext cx="2743200" cy="365760"/>
           </a:xfrm>
           <a:prstGeom prst="rect">
             <a:avLst/>
@@ -6379,8 +6380,8 @@
         </p:nvSpPr>
         <p:spPr>
           <a:xfrm>
-            <a:off x="2834640" y="1380744"/>
-            <a:ext cx="2560320" cy="182880"/>
+            <a:off x="2606040" y="1362456"/>
+            <a:ext cx="2743200" cy="182880"/>
           </a:xfrm>
           <a:prstGeom prst="rect">
             <a:avLst/>
@@ -6413,8 +6414,8 @@
         </p:nvSpPr>
         <p:spPr>
           <a:xfrm>
-            <a:off x="2834640" y="1536192"/>
-            <a:ext cx="2560320" cy="201168"/>
+            <a:off x="2606040" y="1527048"/>
+            <a:ext cx="2743200" cy="201168"/>
           </a:xfrm>
           <a:prstGeom prst="rect">
             <a:avLst/>
@@ -6447,8 +6448,8 @@
         </p:nvSpPr>
         <p:spPr>
           <a:xfrm>
-            <a:off x="2834640" y="1719072"/>
-            <a:ext cx="2560320" cy="18288"/>
+            <a:off x="2606040" y="1719072"/>
+            <a:ext cx="2743200" cy="18288"/>
           </a:xfrm>
           <a:prstGeom prst="rect">
             <a:avLst/>
@@ -6490,8 +6491,8 @@
         </p:nvSpPr>
         <p:spPr>
           <a:xfrm>
-            <a:off x="2898648" y="1773936"/>
-            <a:ext cx="2432303" cy="1005840"/>
+            <a:off x="2651760" y="1764792"/>
+            <a:ext cx="2651760" cy="1069848"/>
           </a:xfrm>
           <a:prstGeom prst="rect">
             <a:avLst/>
@@ -6504,53 +6505,58 @@
           </a:bodyPr>
           <a:lstStyle/>
           <a:p>
+            <a:pPr algn="l"/>
             <a:r>
               <a:rPr sz="900">
                 <a:solidFill>
                   <a:srgbClr val="D0E4F7"/>
                 </a:solidFill>
               </a:rPr>
-              <a:t>+ takeTurn(Board,Dice)</a:t>
-            </a:r>
-          </a:p>
-          <a:p>
+              <a:t>  + takeTurn(Board, Dice)</a:t>
+            </a:r>
+          </a:p>
+          <a:p>
+            <a:pPr algn="l"/>
             <a:r>
               <a:rPr sz="900">
                 <a:solidFill>
                   <a:srgbClr val="D0E4F7"/>
                 </a:solidFill>
               </a:rPr>
-              <a:t>+ pay(amount)</a:t>
-            </a:r>
-          </a:p>
-          <a:p>
+              <a:t>  + pay(amount)</a:t>
+            </a:r>
+          </a:p>
+          <a:p>
+            <a:pPr algn="l"/>
             <a:r>
               <a:rPr sz="900">
                 <a:solidFill>
                   <a:srgbClr val="D0E4F7"/>
                 </a:solidFill>
               </a:rPr>
-              <a:t>+ receive(amount)</a:t>
-            </a:r>
-          </a:p>
-          <a:p>
+              <a:t>  + receive(amount)</a:t>
+            </a:r>
+          </a:p>
+          <a:p>
+            <a:pPr algn="l"/>
             <a:r>
               <a:rPr sz="900">
                 <a:solidFill>
                   <a:srgbClr val="D0E4F7"/>
                 </a:solidFill>
               </a:rPr>
-              <a:t>+ move(steps)</a:t>
-            </a:r>
-          </a:p>
-          <a:p>
+              <a:t>  + move(steps)</a:t>
+            </a:r>
+          </a:p>
+          <a:p>
+            <a:pPr algn="l"/>
             <a:r>
               <a:rPr sz="900">
                 <a:solidFill>
                   <a:srgbClr val="D0E4F7"/>
                 </a:solidFill>
               </a:rPr>
-              <a:t>+ clone()</a:t>
+              <a:t>  + clone(): Player</a:t>
             </a:r>
           </a:p>
         </p:txBody>
@@ -6563,14 +6569,14 @@
         </p:nvSpPr>
         <p:spPr>
           <a:xfrm>
-            <a:off x="6400800" y="1371600"/>
-            <a:ext cx="2194560" cy="1188720"/>
+            <a:off x="5806440" y="1353312"/>
+            <a:ext cx="2286000" cy="1143000"/>
           </a:xfrm>
           <a:prstGeom prst="rect">
             <a:avLst/>
           </a:prstGeom>
           <a:solidFill>
-            <a:srgbClr val="0A1420"/>
+            <a:srgbClr val="081222"/>
           </a:solidFill>
           <a:ln>
             <a:noFill/>
@@ -6606,8 +6612,8 @@
         </p:nvSpPr>
         <p:spPr>
           <a:xfrm>
-            <a:off x="6400800" y="1371600"/>
-            <a:ext cx="2194560" cy="347472"/>
+            <a:off x="5806440" y="1353312"/>
+            <a:ext cx="2286000" cy="365760"/>
           </a:xfrm>
           <a:prstGeom prst="rect">
             <a:avLst/>
@@ -6649,8 +6655,8 @@
         </p:nvSpPr>
         <p:spPr>
           <a:xfrm>
-            <a:off x="6400800" y="1380744"/>
-            <a:ext cx="2194560" cy="182880"/>
+            <a:off x="5806440" y="1362456"/>
+            <a:ext cx="2286000" cy="182880"/>
           </a:xfrm>
           <a:prstGeom prst="rect">
             <a:avLst/>
@@ -6683,8 +6689,8 @@
         </p:nvSpPr>
         <p:spPr>
           <a:xfrm>
-            <a:off x="6400800" y="1536192"/>
-            <a:ext cx="2194560" cy="201168"/>
+            <a:off x="5806440" y="1527048"/>
+            <a:ext cx="2286000" cy="201168"/>
           </a:xfrm>
           <a:prstGeom prst="rect">
             <a:avLst/>
@@ -6717,8 +6723,8 @@
         </p:nvSpPr>
         <p:spPr>
           <a:xfrm>
-            <a:off x="6400800" y="1719072"/>
-            <a:ext cx="2194560" cy="18288"/>
+            <a:off x="5806440" y="1719072"/>
+            <a:ext cx="2286000" cy="18288"/>
           </a:xfrm>
           <a:prstGeom prst="rect">
             <a:avLst/>
@@ -6760,8 +6766,8 @@
         </p:nvSpPr>
         <p:spPr>
           <a:xfrm>
-            <a:off x="6464808" y="1773936"/>
-            <a:ext cx="2066543" cy="731520"/>
+            <a:off x="5852159" y="1764792"/>
+            <a:ext cx="2194560" cy="704088"/>
           </a:xfrm>
           <a:prstGeom prst="rect">
             <a:avLst/>
@@ -6774,23 +6780,25 @@
           </a:bodyPr>
           <a:lstStyle/>
           <a:p>
+            <a:pPr algn="l"/>
             <a:r>
               <a:rPr sz="900">
                 <a:solidFill>
                   <a:srgbClr val="D0E4F7"/>
                 </a:solidFill>
               </a:rPr>
-              <a:t>+ apply(Player)</a:t>
-            </a:r>
-          </a:p>
-          <a:p>
+              <a:t>  + apply(Player)</a:t>
+            </a:r>
+          </a:p>
+          <a:p>
+            <a:pPr algn="l"/>
             <a:r>
               <a:rPr sz="900">
                 <a:solidFill>
                   <a:srgbClr val="D0E4F7"/>
                 </a:solidFill>
               </a:rPr>
-              <a:t>+ getDescription()</a:t>
+              <a:t>  + getDescription()</a:t>
             </a:r>
           </a:p>
         </p:txBody>
@@ -6803,14 +6811,14 @@
         </p:nvSpPr>
         <p:spPr>
           <a:xfrm>
-            <a:off x="9235440" y="1371600"/>
-            <a:ext cx="2651760" cy="1463040"/>
+            <a:off x="8549640" y="1353312"/>
+            <a:ext cx="3337560" cy="1508760"/>
           </a:xfrm>
           <a:prstGeom prst="rect">
             <a:avLst/>
           </a:prstGeom>
           <a:solidFill>
-            <a:srgbClr val="0A1420"/>
+            <a:srgbClr val="081222"/>
           </a:solidFill>
           <a:ln>
             <a:noFill/>
@@ -6846,8 +6854,8 @@
         </p:nvSpPr>
         <p:spPr>
           <a:xfrm>
-            <a:off x="9235440" y="1371600"/>
-            <a:ext cx="2651760" cy="292608"/>
+            <a:off x="8549640" y="1353312"/>
+            <a:ext cx="3337560" cy="301752"/>
           </a:xfrm>
           <a:prstGeom prst="rect">
             <a:avLst/>
@@ -6889,8 +6897,8 @@
         </p:nvSpPr>
         <p:spPr>
           <a:xfrm>
-            <a:off x="9235440" y="1426464"/>
-            <a:ext cx="2651760" cy="228600"/>
+            <a:off x="8549640" y="1408176"/>
+            <a:ext cx="3337560" cy="237744"/>
           </a:xfrm>
           <a:prstGeom prst="rect">
             <a:avLst/>
@@ -6923,8 +6931,8 @@
         </p:nvSpPr>
         <p:spPr>
           <a:xfrm>
-            <a:off x="9235440" y="1664208"/>
-            <a:ext cx="2651760" cy="18288"/>
+            <a:off x="8549640" y="1655064"/>
+            <a:ext cx="3337560" cy="18288"/>
           </a:xfrm>
           <a:prstGeom prst="rect">
             <a:avLst/>
@@ -6966,8 +6974,8 @@
         </p:nvSpPr>
         <p:spPr>
           <a:xfrm>
-            <a:off x="9299448" y="1773936"/>
-            <a:ext cx="2523744" cy="1005840"/>
+            <a:off x="8595360" y="1700784"/>
+            <a:ext cx="3246120" cy="1133855"/>
           </a:xfrm>
           <a:prstGeom prst="rect">
             <a:avLst/>
@@ -6980,63 +6988,58 @@
           </a:bodyPr>
           <a:lstStyle/>
           <a:p>
+            <a:pPr algn="l"/>
             <a:r>
               <a:rPr sz="900">
                 <a:solidFill>
                   <a:srgbClr val="D0E4F7"/>
                 </a:solidFill>
               </a:rPr>
-              <a:t>+ start()</a:t>
-            </a:r>
-          </a:p>
-          <a:p>
+              <a:t>  + start()</a:t>
+            </a:r>
+          </a:p>
+          <a:p>
+            <a:pPr algn="l"/>
             <a:r>
               <a:rPr sz="900">
                 <a:solidFill>
                   <a:srgbClr val="D0E4F7"/>
                 </a:solidFill>
               </a:rPr>
-              <a:t>+ addPlayer()</a:t>
-            </a:r>
-          </a:p>
-          <a:p>
+              <a:t>  + addPlayer() / removePlayer()</a:t>
+            </a:r>
+          </a:p>
+          <a:p>
+            <a:pPr algn="l"/>
             <a:r>
               <a:rPr sz="900">
                 <a:solidFill>
                   <a:srgbClr val="D0E4F7"/>
                 </a:solidFill>
               </a:rPr>
-              <a:t>+ removePlayer()</a:t>
-            </a:r>
-          </a:p>
-          <a:p>
+              <a:t>  + findPlayer(name)</a:t>
+            </a:r>
+          </a:p>
+          <a:p>
+            <a:pPr algn="l"/>
             <a:r>
               <a:rPr sz="900">
                 <a:solidFill>
                   <a:srgbClr val="D0E4F7"/>
                 </a:solidFill>
               </a:rPr>
-              <a:t>+ findPlayer()</a:t>
-            </a:r>
-          </a:p>
-          <a:p>
+              <a:t>  + sortByWealth()</a:t>
+            </a:r>
+          </a:p>
+          <a:p>
+            <a:pPr algn="l"/>
             <a:r>
               <a:rPr sz="900">
                 <a:solidFill>
                   <a:srgbClr val="D0E4F7"/>
                 </a:solidFill>
               </a:rPr>
-              <a:t>+ sortByWealth()</a:t>
-            </a:r>
-          </a:p>
-          <a:p>
-            <a:r>
-              <a:rPr sz="900">
-                <a:solidFill>
-                  <a:srgbClr val="D0E4F7"/>
-                </a:solidFill>
-              </a:rPr>
-              <a:t>+ clonePlayers()</a:t>
+              <a:t>  + clonePlayers()</a:t>
             </a:r>
           </a:p>
         </p:txBody>
@@ -7049,14 +7052,14 @@
         </p:nvSpPr>
         <p:spPr>
           <a:xfrm>
-            <a:off x="274320" y="3657600"/>
+            <a:off x="228600" y="3337560"/>
             <a:ext cx="1920240" cy="1371600"/>
           </a:xfrm>
           <a:prstGeom prst="rect">
             <a:avLst/>
           </a:prstGeom>
           <a:solidFill>
-            <a:srgbClr val="0A1420"/>
+            <a:srgbClr val="081222"/>
           </a:solidFill>
           <a:ln>
             <a:noFill/>
@@ -7092,8 +7095,8 @@
         </p:nvSpPr>
         <p:spPr>
           <a:xfrm>
-            <a:off x="274320" y="3657600"/>
-            <a:ext cx="1920240" cy="292608"/>
+            <a:off x="228600" y="3337560"/>
+            <a:ext cx="1920240" cy="301752"/>
           </a:xfrm>
           <a:prstGeom prst="rect">
             <a:avLst/>
@@ -7135,8 +7138,8 @@
         </p:nvSpPr>
         <p:spPr>
           <a:xfrm>
-            <a:off x="274320" y="3712463"/>
-            <a:ext cx="1920240" cy="228600"/>
+            <a:off x="228600" y="3392424"/>
+            <a:ext cx="1920240" cy="237744"/>
           </a:xfrm>
           <a:prstGeom prst="rect">
             <a:avLst/>
@@ -7169,7 +7172,7 @@
         </p:nvSpPr>
         <p:spPr>
           <a:xfrm>
-            <a:off x="274320" y="3950208"/>
+            <a:off x="228600" y="3639312"/>
             <a:ext cx="1920240" cy="18288"/>
           </a:xfrm>
           <a:prstGeom prst="rect">
@@ -7212,8 +7215,8 @@
         </p:nvSpPr>
         <p:spPr>
           <a:xfrm>
-            <a:off x="338328" y="4059936"/>
-            <a:ext cx="1792224" cy="914400"/>
+            <a:off x="274320" y="3685032"/>
+            <a:ext cx="1828800" cy="996695"/>
           </a:xfrm>
           <a:prstGeom prst="rect">
             <a:avLst/>
@@ -7226,43 +7229,47 @@
           </a:bodyPr>
           <a:lstStyle/>
           <a:p>
+            <a:pPr algn="l"/>
             <a:r>
               <a:rPr sz="900">
                 <a:solidFill>
                   <a:srgbClr val="D0E4F7"/>
                 </a:solidFill>
               </a:rPr>
-              <a:t>owner, level</a:t>
-            </a:r>
-          </a:p>
-          <a:p>
+              <a:t>  owner, level, price</a:t>
+            </a:r>
+          </a:p>
+          <a:p>
+            <a:pPr algn="l"/>
             <a:r>
               <a:rPr sz="900">
                 <a:solidFill>
                   <a:srgbClr val="D0E4F7"/>
                 </a:solidFill>
               </a:rPr>
-              <a:t>+ landOn()</a:t>
-            </a:r>
-          </a:p>
-          <a:p>
+              <a:t>  + landOn()</a:t>
+            </a:r>
+          </a:p>
+          <a:p>
+            <a:pPr algn="l"/>
             <a:r>
               <a:rPr sz="900">
                 <a:solidFill>
                   <a:srgbClr val="D0E4F7"/>
                 </a:solidFill>
               </a:rPr>
-              <a:t>+ chargeRent()</a:t>
-            </a:r>
-          </a:p>
-          <a:p>
+              <a:t>  + chargeRent()</a:t>
+            </a:r>
+          </a:p>
+          <a:p>
+            <a:pPr algn="l"/>
             <a:r>
               <a:rPr sz="900">
                 <a:solidFill>
                   <a:srgbClr val="D0E4F7"/>
                 </a:solidFill>
               </a:rPr>
-              <a:t>+ offerUpgrade()</a:t>
+              <a:t>  + offerUpgrade()</a:t>
             </a:r>
           </a:p>
         </p:txBody>
@@ -7275,14 +7282,14 @@
         </p:nvSpPr>
         <p:spPr>
           <a:xfrm>
-            <a:off x="2331720" y="3657600"/>
+            <a:off x="2240280" y="3337560"/>
             <a:ext cx="1920240" cy="1371600"/>
           </a:xfrm>
           <a:prstGeom prst="rect">
             <a:avLst/>
           </a:prstGeom>
           <a:solidFill>
-            <a:srgbClr val="0A1420"/>
+            <a:srgbClr val="081222"/>
           </a:solidFill>
           <a:ln>
             <a:noFill/>
@@ -7318,8 +7325,8 @@
         </p:nvSpPr>
         <p:spPr>
           <a:xfrm>
-            <a:off x="2331720" y="3657600"/>
-            <a:ext cx="1920240" cy="292608"/>
+            <a:off x="2240280" y="3337560"/>
+            <a:ext cx="1920240" cy="301752"/>
           </a:xfrm>
           <a:prstGeom prst="rect">
             <a:avLst/>
@@ -7361,8 +7368,8 @@
         </p:nvSpPr>
         <p:spPr>
           <a:xfrm>
-            <a:off x="2331720" y="3712463"/>
-            <a:ext cx="1920240" cy="228600"/>
+            <a:off x="2240280" y="3392424"/>
+            <a:ext cx="1920240" cy="237744"/>
           </a:xfrm>
           <a:prstGeom prst="rect">
             <a:avLst/>
@@ -7395,7 +7402,7 @@
         </p:nvSpPr>
         <p:spPr>
           <a:xfrm>
-            <a:off x="2331720" y="3950208"/>
+            <a:off x="2240280" y="3639312"/>
             <a:ext cx="1920240" cy="18288"/>
           </a:xfrm>
           <a:prstGeom prst="rect">
@@ -7438,8 +7445,8 @@
         </p:nvSpPr>
         <p:spPr>
           <a:xfrm>
-            <a:off x="2395727" y="4059936"/>
-            <a:ext cx="1792224" cy="914400"/>
+            <a:off x="2286000" y="3685032"/>
+            <a:ext cx="1828800" cy="996695"/>
           </a:xfrm>
           <a:prstGeom prst="rect">
             <a:avLst/>
@@ -7452,33 +7459,36 @@
           </a:bodyPr>
           <a:lstStyle/>
           <a:p>
+            <a:pPr algn="l"/>
             <a:r>
               <a:rPr sz="900">
                 <a:solidFill>
                   <a:srgbClr val="D0E4F7"/>
                 </a:solidFill>
               </a:rPr>
-              <a:t>owner, RENT[]</a:t>
-            </a:r>
-          </a:p>
-          <a:p>
+              <a:t>  owner, RENT[]</a:t>
+            </a:r>
+          </a:p>
+          <a:p>
+            <a:pPr algn="l"/>
             <a:r>
               <a:rPr sz="900">
                 <a:solidFill>
                   <a:srgbClr val="D0E4F7"/>
                 </a:solidFill>
               </a:rPr>
-              <a:t>+ landOn()</a:t>
-            </a:r>
-          </a:p>
-          <a:p>
+              <a:t>  + landOn()</a:t>
+            </a:r>
+          </a:p>
+          <a:p>
+            <a:pPr algn="l"/>
             <a:r>
               <a:rPr sz="900">
                 <a:solidFill>
                   <a:srgbClr val="D0E4F7"/>
                 </a:solidFill>
               </a:rPr>
-              <a:t>+ getCurrentRent()</a:t>
+              <a:t>  + getCurrentRent()</a:t>
             </a:r>
           </a:p>
         </p:txBody>
@@ -7491,14 +7501,14 @@
         </p:nvSpPr>
         <p:spPr>
           <a:xfrm>
-            <a:off x="4343400" y="3657600"/>
+            <a:off x="4160520" y="3337560"/>
             <a:ext cx="1920240" cy="1371600"/>
           </a:xfrm>
           <a:prstGeom prst="rect">
             <a:avLst/>
           </a:prstGeom>
           <a:solidFill>
-            <a:srgbClr val="0A1420"/>
+            <a:srgbClr val="081222"/>
           </a:solidFill>
           <a:ln>
             <a:noFill/>
@@ -7534,8 +7544,8 @@
         </p:nvSpPr>
         <p:spPr>
           <a:xfrm>
-            <a:off x="4343400" y="3657600"/>
-            <a:ext cx="1920240" cy="292608"/>
+            <a:off x="4160520" y="3337560"/>
+            <a:ext cx="1920240" cy="301752"/>
           </a:xfrm>
           <a:prstGeom prst="rect">
             <a:avLst/>
@@ -7577,8 +7587,8 @@
         </p:nvSpPr>
         <p:spPr>
           <a:xfrm>
-            <a:off x="4343400" y="3712463"/>
-            <a:ext cx="1920240" cy="228600"/>
+            <a:off x="4160520" y="3392424"/>
+            <a:ext cx="1920240" cy="237744"/>
           </a:xfrm>
           <a:prstGeom prst="rect">
             <a:avLst/>
@@ -7611,7 +7621,7 @@
         </p:nvSpPr>
         <p:spPr>
           <a:xfrm>
-            <a:off x="4343400" y="3950208"/>
+            <a:off x="4160520" y="3639312"/>
             <a:ext cx="1920240" cy="18288"/>
           </a:xfrm>
           <a:prstGeom prst="rect">
@@ -7654,8 +7664,8 @@
         </p:nvSpPr>
         <p:spPr>
           <a:xfrm>
-            <a:off x="4407408" y="4059936"/>
-            <a:ext cx="1792224" cy="914400"/>
+            <a:off x="4206240" y="3685032"/>
+            <a:ext cx="1828800" cy="996695"/>
           </a:xfrm>
           <a:prstGeom prst="rect">
             <a:avLst/>
@@ -7668,23 +7678,25 @@
           </a:bodyPr>
           <a:lstStyle/>
           <a:p>
+            <a:pPr algn="l"/>
             <a:r>
               <a:rPr sz="900">
                 <a:solidFill>
                   <a:srgbClr val="D0E4F7"/>
                 </a:solidFill>
               </a:rPr>
-              <a:t>+ landOn()</a:t>
-            </a:r>
-          </a:p>
-          <a:p>
+              <a:t>  + landOn()</a:t>
+            </a:r>
+          </a:p>
+          <a:p>
+            <a:pPr algn="l"/>
             <a:r>
               <a:rPr sz="900">
                 <a:solidFill>
                   <a:srgbClr val="D0E4F7"/>
                 </a:solidFill>
               </a:rPr>
-              <a:t>+ playRoulette()</a:t>
+              <a:t>  + playRoulette()</a:t>
             </a:r>
           </a:p>
         </p:txBody>
@@ -7697,14 +7709,14 @@
         </p:nvSpPr>
         <p:spPr>
           <a:xfrm>
-            <a:off x="6263640" y="3657600"/>
+            <a:off x="5989320" y="3337560"/>
             <a:ext cx="1920240" cy="1371600"/>
           </a:xfrm>
           <a:prstGeom prst="rect">
             <a:avLst/>
           </a:prstGeom>
           <a:solidFill>
-            <a:srgbClr val="0A1420"/>
+            <a:srgbClr val="081222"/>
           </a:solidFill>
           <a:ln>
             <a:noFill/>
@@ -7740,8 +7752,8 @@
         </p:nvSpPr>
         <p:spPr>
           <a:xfrm>
-            <a:off x="6263640" y="3657600"/>
-            <a:ext cx="1920240" cy="292608"/>
+            <a:off x="5989320" y="3337560"/>
+            <a:ext cx="1920240" cy="301752"/>
           </a:xfrm>
           <a:prstGeom prst="rect">
             <a:avLst/>
@@ -7783,8 +7795,8 @@
         </p:nvSpPr>
         <p:spPr>
           <a:xfrm>
-            <a:off x="6263640" y="3712463"/>
-            <a:ext cx="1920240" cy="228600"/>
+            <a:off x="5989320" y="3392424"/>
+            <a:ext cx="1920240" cy="237744"/>
           </a:xfrm>
           <a:prstGeom prst="rect">
             <a:avLst/>
@@ -7817,7 +7829,7 @@
         </p:nvSpPr>
         <p:spPr>
           <a:xfrm>
-            <a:off x="6263640" y="3950208"/>
+            <a:off x="5989320" y="3639312"/>
             <a:ext cx="1920240" cy="18288"/>
           </a:xfrm>
           <a:prstGeom prst="rect">
@@ -7860,8 +7872,8 @@
         </p:nvSpPr>
         <p:spPr>
           <a:xfrm>
-            <a:off x="6327648" y="4059936"/>
-            <a:ext cx="1792224" cy="914400"/>
+            <a:off x="6035040" y="3685032"/>
+            <a:ext cx="1828800" cy="996695"/>
           </a:xfrm>
           <a:prstGeom prst="rect">
             <a:avLst/>
@@ -7874,13 +7886,14 @@
           </a:bodyPr>
           <a:lstStyle/>
           <a:p>
+            <a:pPr algn="l"/>
             <a:r>
               <a:rPr sz="900">
                 <a:solidFill>
                   <a:srgbClr val="D0E4F7"/>
                 </a:solidFill>
               </a:rPr>
-              <a:t>+ landOn()</a:t>
+              <a:t>  + landOn()</a:t>
             </a:r>
           </a:p>
         </p:txBody>
@@ -7893,14 +7906,14 @@
         </p:nvSpPr>
         <p:spPr>
           <a:xfrm>
-            <a:off x="8092440" y="3657600"/>
+            <a:off x="7726679" y="3337560"/>
             <a:ext cx="1920240" cy="1371600"/>
           </a:xfrm>
           <a:prstGeom prst="rect">
             <a:avLst/>
           </a:prstGeom>
           <a:solidFill>
-            <a:srgbClr val="0A1420"/>
+            <a:srgbClr val="081222"/>
           </a:solidFill>
           <a:ln>
             <a:noFill/>
@@ -7936,8 +7949,8 @@
         </p:nvSpPr>
         <p:spPr>
           <a:xfrm>
-            <a:off x="8092440" y="3657600"/>
-            <a:ext cx="1920240" cy="292608"/>
+            <a:off x="7726679" y="3337560"/>
+            <a:ext cx="1920240" cy="301752"/>
           </a:xfrm>
           <a:prstGeom prst="rect">
             <a:avLst/>
@@ -7979,8 +7992,8 @@
         </p:nvSpPr>
         <p:spPr>
           <a:xfrm>
-            <a:off x="8092440" y="3712463"/>
-            <a:ext cx="1920240" cy="228600"/>
+            <a:off x="7726679" y="3392424"/>
+            <a:ext cx="1920240" cy="237744"/>
           </a:xfrm>
           <a:prstGeom prst="rect">
             <a:avLst/>
@@ -8013,7 +8026,7 @@
         </p:nvSpPr>
         <p:spPr>
           <a:xfrm>
-            <a:off x="8092440" y="3950208"/>
+            <a:off x="7726679" y="3639312"/>
             <a:ext cx="1920240" cy="18288"/>
           </a:xfrm>
           <a:prstGeom prst="rect">
@@ -8056,8 +8069,8 @@
         </p:nvSpPr>
         <p:spPr>
           <a:xfrm>
-            <a:off x="8156448" y="4059936"/>
-            <a:ext cx="1792224" cy="914400"/>
+            <a:off x="7772400" y="3685032"/>
+            <a:ext cx="1828800" cy="996695"/>
           </a:xfrm>
           <a:prstGeom prst="rect">
             <a:avLst/>
@@ -8070,23 +8083,25 @@
           </a:bodyPr>
           <a:lstStyle/>
           <a:p>
+            <a:pPr algn="l"/>
             <a:r>
               <a:rPr sz="900">
                 <a:solidFill>
                   <a:srgbClr val="D0E4F7"/>
                 </a:solidFill>
               </a:rPr>
-              <a:t>+ landOn()</a:t>
-            </a:r>
-          </a:p>
-          <a:p>
+              <a:t>  toll=100k</a:t>
+            </a:r>
+          </a:p>
+          <a:p>
+            <a:pPr algn="l"/>
             <a:r>
               <a:rPr sz="900">
                 <a:solidFill>
                   <a:srgbClr val="D0E4F7"/>
                 </a:solidFill>
               </a:rPr>
-              <a:t>teleport logic</a:t>
+              <a:t>  + landOn()</a:t>
             </a:r>
           </a:p>
         </p:txBody>
@@ -8099,14 +8114,14 @@
         </p:nvSpPr>
         <p:spPr>
           <a:xfrm>
-            <a:off x="9921240" y="3657600"/>
+            <a:off x="9555480" y="3337560"/>
             <a:ext cx="1920240" cy="1371600"/>
           </a:xfrm>
           <a:prstGeom prst="rect">
             <a:avLst/>
           </a:prstGeom>
           <a:solidFill>
-            <a:srgbClr val="0A1420"/>
+            <a:srgbClr val="081222"/>
           </a:solidFill>
           <a:ln>
             <a:noFill/>
@@ -8142,8 +8157,8 @@
         </p:nvSpPr>
         <p:spPr>
           <a:xfrm>
-            <a:off x="9921240" y="3657600"/>
-            <a:ext cx="1920240" cy="292608"/>
+            <a:off x="9555480" y="3337560"/>
+            <a:ext cx="1920240" cy="301752"/>
           </a:xfrm>
           <a:prstGeom prst="rect">
             <a:avLst/>
@@ -8185,8 +8200,8 @@
         </p:nvSpPr>
         <p:spPr>
           <a:xfrm>
-            <a:off x="9921240" y="3712463"/>
-            <a:ext cx="1920240" cy="228600"/>
+            <a:off x="9555480" y="3392424"/>
+            <a:ext cx="1920240" cy="237744"/>
           </a:xfrm>
           <a:prstGeom prst="rect">
             <a:avLst/>
@@ -8219,7 +8234,7 @@
         </p:nvSpPr>
         <p:spPr>
           <a:xfrm>
-            <a:off x="9921240" y="3950208"/>
+            <a:off x="9555480" y="3639312"/>
             <a:ext cx="1920240" cy="18288"/>
           </a:xfrm>
           <a:prstGeom prst="rect">
@@ -8262,8 +8277,8 @@
         </p:nvSpPr>
         <p:spPr>
           <a:xfrm>
-            <a:off x="9985248" y="4059936"/>
-            <a:ext cx="1792224" cy="914400"/>
+            <a:off x="9601200" y="3685032"/>
+            <a:ext cx="1828800" cy="996695"/>
           </a:xfrm>
           <a:prstGeom prst="rect">
             <a:avLst/>
@@ -8276,23 +8291,25 @@
           </a:bodyPr>
           <a:lstStyle/>
           <a:p>
+            <a:pPr algn="l"/>
             <a:r>
               <a:rPr sz="900">
                 <a:solidFill>
                   <a:srgbClr val="D0E4F7"/>
                 </a:solidFill>
               </a:rPr>
-              <a:t>multiplier (static)</a:t>
-            </a:r>
-          </a:p>
-          <a:p>
+              <a:t>  static multiplier</a:t>
+            </a:r>
+          </a:p>
+          <a:p>
+            <a:pPr algn="l"/>
             <a:r>
               <a:rPr sz="900">
                 <a:solidFill>
                   <a:srgbClr val="D0E4F7"/>
                 </a:solidFill>
               </a:rPr>
-              <a:t>+ landOn()</a:t>
+              <a:t>  + landOn()</a:t>
             </a:r>
           </a:p>
         </p:txBody>
@@ -8305,14 +8322,14 @@
         </p:nvSpPr>
         <p:spPr>
           <a:xfrm>
-            <a:off x="2834640" y="3657600"/>
-            <a:ext cx="1645920" cy="1005840"/>
+            <a:off x="2606040" y="3337560"/>
+            <a:ext cx="1691640" cy="1051560"/>
           </a:xfrm>
           <a:prstGeom prst="rect">
             <a:avLst/>
           </a:prstGeom>
           <a:solidFill>
-            <a:srgbClr val="0A1420"/>
+            <a:srgbClr val="081222"/>
           </a:solidFill>
           <a:ln>
             <a:noFill/>
@@ -8348,8 +8365,8 @@
         </p:nvSpPr>
         <p:spPr>
           <a:xfrm>
-            <a:off x="2834640" y="3657600"/>
-            <a:ext cx="1645920" cy="292608"/>
+            <a:off x="2606040" y="3337560"/>
+            <a:ext cx="1691640" cy="301752"/>
           </a:xfrm>
           <a:prstGeom prst="rect">
             <a:avLst/>
@@ -8391,8 +8408,8 @@
         </p:nvSpPr>
         <p:spPr>
           <a:xfrm>
-            <a:off x="2834640" y="3712463"/>
-            <a:ext cx="1645920" cy="228600"/>
+            <a:off x="2606040" y="3392424"/>
+            <a:ext cx="1691640" cy="237744"/>
           </a:xfrm>
           <a:prstGeom prst="rect">
             <a:avLst/>
@@ -8425,8 +8442,8 @@
         </p:nvSpPr>
         <p:spPr>
           <a:xfrm>
-            <a:off x="2834640" y="3950208"/>
-            <a:ext cx="1645920" cy="18288"/>
+            <a:off x="2606040" y="3639312"/>
+            <a:ext cx="1691640" cy="18288"/>
           </a:xfrm>
           <a:prstGeom prst="rect">
             <a:avLst/>
@@ -8468,8 +8485,8 @@
         </p:nvSpPr>
         <p:spPr>
           <a:xfrm>
-            <a:off x="2898648" y="4059936"/>
-            <a:ext cx="1517904" cy="548640"/>
+            <a:off x="2651760" y="3685032"/>
+            <a:ext cx="1600200" cy="676655"/>
           </a:xfrm>
           <a:prstGeom prst="rect">
             <a:avLst/>
@@ -8482,23 +8499,25 @@
           </a:bodyPr>
           <a:lstStyle/>
           <a:p>
+            <a:pPr algn="l"/>
             <a:r>
               <a:rPr sz="900">
                 <a:solidFill>
                   <a:srgbClr val="D0E4F7"/>
                 </a:solidFill>
               </a:rPr>
-              <a:t>+ takeTurn()</a:t>
-            </a:r>
-          </a:p>
-          <a:p>
+              <a:t>  + takeTurn()</a:t>
+            </a:r>
+          </a:p>
+          <a:p>
+            <a:pPr algn="l"/>
             <a:r>
               <a:rPr sz="900">
                 <a:solidFill>
                   <a:srgbClr val="D0E4F7"/>
                 </a:solidFill>
               </a:rPr>
-              <a:t>+ trySell…()</a:t>
+              <a:t>  + trySellToP…()</a:t>
             </a:r>
           </a:p>
         </p:txBody>
@@ -8511,14 +8530,14 @@
         </p:nvSpPr>
         <p:spPr>
           <a:xfrm>
-            <a:off x="4617720" y="3657600"/>
-            <a:ext cx="1645920" cy="914400"/>
+            <a:off x="4389120" y="3337560"/>
+            <a:ext cx="1600200" cy="1005840"/>
           </a:xfrm>
           <a:prstGeom prst="rect">
             <a:avLst/>
           </a:prstGeom>
           <a:solidFill>
-            <a:srgbClr val="0A1420"/>
+            <a:srgbClr val="081222"/>
           </a:solidFill>
           <a:ln>
             <a:noFill/>
@@ -8554,8 +8573,8 @@
         </p:nvSpPr>
         <p:spPr>
           <a:xfrm>
-            <a:off x="4617720" y="3657600"/>
-            <a:ext cx="1645920" cy="292608"/>
+            <a:off x="4389120" y="3337560"/>
+            <a:ext cx="1600200" cy="301752"/>
           </a:xfrm>
           <a:prstGeom prst="rect">
             <a:avLst/>
@@ -8597,8 +8616,8 @@
         </p:nvSpPr>
         <p:spPr>
           <a:xfrm>
-            <a:off x="4617720" y="3712463"/>
-            <a:ext cx="1645920" cy="228600"/>
+            <a:off x="4389120" y="3392424"/>
+            <a:ext cx="1600200" cy="237744"/>
           </a:xfrm>
           <a:prstGeom prst="rect">
             <a:avLst/>
@@ -8631,8 +8650,8 @@
         </p:nvSpPr>
         <p:spPr>
           <a:xfrm>
-            <a:off x="4617720" y="3950208"/>
-            <a:ext cx="1645920" cy="18288"/>
+            <a:off x="4389120" y="3639312"/>
+            <a:ext cx="1600200" cy="18288"/>
           </a:xfrm>
           <a:prstGeom prst="rect">
             <a:avLst/>
@@ -8674,8 +8693,8 @@
         </p:nvSpPr>
         <p:spPr>
           <a:xfrm>
-            <a:off x="4681728" y="4059936"/>
-            <a:ext cx="1517904" cy="457200"/>
+            <a:off x="4434840" y="3685032"/>
+            <a:ext cx="1508760" cy="630936"/>
           </a:xfrm>
           <a:prstGeom prst="rect">
             <a:avLst/>
@@ -8688,23 +8707,25 @@
           </a:bodyPr>
           <a:lstStyle/>
           <a:p>
+            <a:pPr algn="l"/>
             <a:r>
               <a:rPr sz="900">
                 <a:solidFill>
                   <a:srgbClr val="D0E4F7"/>
                 </a:solidFill>
               </a:rPr>
-              <a:t>+ takeTurn()</a:t>
-            </a:r>
-          </a:p>
-          <a:p>
+              <a:t>  + takeTurn()</a:t>
+            </a:r>
+          </a:p>
+          <a:p>
+            <a:pPr algn="l"/>
             <a:r>
               <a:rPr sz="900">
                 <a:solidFill>
                   <a:srgbClr val="D0E4F7"/>
                 </a:solidFill>
               </a:rPr>
-              <a:t>+ wantsToBuy()</a:t>
+              <a:t>  + wantsToBuy()</a:t>
             </a:r>
           </a:p>
         </p:txBody>
@@ -8717,14 +8738,14 @@
         </p:nvSpPr>
         <p:spPr>
           <a:xfrm>
-            <a:off x="6492240" y="3657600"/>
-            <a:ext cx="1371600" cy="914400"/>
+            <a:off x="5989320" y="3337560"/>
+            <a:ext cx="1554480" cy="914400"/>
           </a:xfrm>
           <a:prstGeom prst="rect">
             <a:avLst/>
           </a:prstGeom>
           <a:solidFill>
-            <a:srgbClr val="0A1420"/>
+            <a:srgbClr val="081222"/>
           </a:solidFill>
           <a:ln>
             <a:noFill/>
@@ -8760,8 +8781,8 @@
         </p:nvSpPr>
         <p:spPr>
           <a:xfrm>
-            <a:off x="6492240" y="3657600"/>
-            <a:ext cx="1371600" cy="292608"/>
+            <a:off x="5989320" y="3337560"/>
+            <a:ext cx="1554480" cy="301752"/>
           </a:xfrm>
           <a:prstGeom prst="rect">
             <a:avLst/>
@@ -8803,8 +8824,8 @@
         </p:nvSpPr>
         <p:spPr>
           <a:xfrm>
-            <a:off x="6492240" y="3712463"/>
-            <a:ext cx="1371600" cy="228600"/>
+            <a:off x="5989320" y="3392424"/>
+            <a:ext cx="1554480" cy="237744"/>
           </a:xfrm>
           <a:prstGeom prst="rect">
             <a:avLst/>
@@ -8837,8 +8858,8 @@
         </p:nvSpPr>
         <p:spPr>
           <a:xfrm>
-            <a:off x="6492240" y="3950208"/>
-            <a:ext cx="1371600" cy="18288"/>
+            <a:off x="5989320" y="3639312"/>
+            <a:ext cx="1554480" cy="18288"/>
           </a:xfrm>
           <a:prstGeom prst="rect">
             <a:avLst/>
@@ -8880,8 +8901,8 @@
         </p:nvSpPr>
         <p:spPr>
           <a:xfrm>
-            <a:off x="6556248" y="4059936"/>
-            <a:ext cx="1243584" cy="457200"/>
+            <a:off x="6035040" y="3685032"/>
+            <a:ext cx="1463039" cy="539496"/>
           </a:xfrm>
           <a:prstGeom prst="rect">
             <a:avLst/>
@@ -8894,23 +8915,25 @@
           </a:bodyPr>
           <a:lstStyle/>
           <a:p>
+            <a:pPr algn="l"/>
             <a:r>
               <a:rPr sz="900">
                 <a:solidFill>
                   <a:srgbClr val="D0E4F7"/>
                 </a:solidFill>
               </a:rPr>
-              <a:t>amount</a:t>
-            </a:r>
-          </a:p>
-          <a:p>
+              <a:t>  amount</a:t>
+            </a:r>
+          </a:p>
+          <a:p>
+            <a:pPr algn="l"/>
             <a:r>
               <a:rPr sz="900">
                 <a:solidFill>
                   <a:srgbClr val="D0E4F7"/>
                 </a:solidFill>
               </a:rPr>
-              <a:t>+ apply()</a:t>
+              <a:t>  + apply()</a:t>
             </a:r>
           </a:p>
         </p:txBody>
@@ -8923,14 +8946,14 @@
         </p:nvSpPr>
         <p:spPr>
           <a:xfrm>
-            <a:off x="8001000" y="3657600"/>
-            <a:ext cx="1371600" cy="914400"/>
+            <a:off x="7635240" y="3337560"/>
+            <a:ext cx="1645920" cy="914400"/>
           </a:xfrm>
           <a:prstGeom prst="rect">
             <a:avLst/>
           </a:prstGeom>
           <a:solidFill>
-            <a:srgbClr val="0A1420"/>
+            <a:srgbClr val="081222"/>
           </a:solidFill>
           <a:ln>
             <a:noFill/>
@@ -8966,8 +8989,8 @@
         </p:nvSpPr>
         <p:spPr>
           <a:xfrm>
-            <a:off x="8001000" y="3657600"/>
-            <a:ext cx="1371600" cy="292608"/>
+            <a:off x="7635240" y="3337560"/>
+            <a:ext cx="1645920" cy="301752"/>
           </a:xfrm>
           <a:prstGeom prst="rect">
             <a:avLst/>
@@ -9009,8 +9032,8 @@
         </p:nvSpPr>
         <p:spPr>
           <a:xfrm>
-            <a:off x="8001000" y="3712463"/>
-            <a:ext cx="1371600" cy="228600"/>
+            <a:off x="7635240" y="3392424"/>
+            <a:ext cx="1645920" cy="237744"/>
           </a:xfrm>
           <a:prstGeom prst="rect">
             <a:avLst/>
@@ -9043,8 +9066,8 @@
         </p:nvSpPr>
         <p:spPr>
           <a:xfrm>
-            <a:off x="8001000" y="3950208"/>
-            <a:ext cx="1371600" cy="18288"/>
+            <a:off x="7635240" y="3639312"/>
+            <a:ext cx="1645920" cy="18288"/>
           </a:xfrm>
           <a:prstGeom prst="rect">
             <a:avLst/>
@@ -9086,8 +9109,8 @@
         </p:nvSpPr>
         <p:spPr>
           <a:xfrm>
-            <a:off x="8065008" y="4059936"/>
-            <a:ext cx="1243584" cy="457200"/>
+            <a:off x="7680960" y="3685032"/>
+            <a:ext cx="1554480" cy="539496"/>
           </a:xfrm>
           <a:prstGeom prst="rect">
             <a:avLst/>
@@ -9100,23 +9123,25 @@
           </a:bodyPr>
           <a:lstStyle/>
           <a:p>
+            <a:pPr algn="l"/>
             <a:r>
               <a:rPr sz="900">
                 <a:solidFill>
                   <a:srgbClr val="D0E4F7"/>
                 </a:solidFill>
               </a:rPr>
-              <a:t>amount</a:t>
-            </a:r>
-          </a:p>
-          <a:p>
+              <a:t>  amount</a:t>
+            </a:r>
+          </a:p>
+          <a:p>
+            <a:pPr algn="l"/>
             <a:r>
               <a:rPr sz="900">
                 <a:solidFill>
                   <a:srgbClr val="D0E4F7"/>
                 </a:solidFill>
               </a:rPr>
-              <a:t>+ apply()</a:t>
+              <a:t>  + apply()</a:t>
             </a:r>
           </a:p>
         </p:txBody>
@@ -9129,14 +9154,14 @@
         </p:nvSpPr>
         <p:spPr>
           <a:xfrm>
-            <a:off x="2834640" y="5029200"/>
-            <a:ext cx="2377440" cy="777240"/>
+            <a:off x="2606040" y="4800600"/>
+            <a:ext cx="2560320" cy="804672"/>
           </a:xfrm>
           <a:prstGeom prst="rect">
             <a:avLst/>
           </a:prstGeom>
           <a:solidFill>
-            <a:srgbClr val="0A1420"/>
+            <a:srgbClr val="081222"/>
           </a:solidFill>
           <a:ln>
             <a:noFill/>
@@ -9172,8 +9197,8 @@
         </p:nvSpPr>
         <p:spPr>
           <a:xfrm>
-            <a:off x="2834640" y="5029200"/>
-            <a:ext cx="2377440" cy="292608"/>
+            <a:off x="2606040" y="4800600"/>
+            <a:ext cx="2560320" cy="301752"/>
           </a:xfrm>
           <a:prstGeom prst="rect">
             <a:avLst/>
@@ -9215,8 +9240,8 @@
         </p:nvSpPr>
         <p:spPr>
           <a:xfrm>
-            <a:off x="2834640" y="5084064"/>
-            <a:ext cx="2377440" cy="228600"/>
+            <a:off x="2606040" y="4855464"/>
+            <a:ext cx="2560320" cy="237744"/>
           </a:xfrm>
           <a:prstGeom prst="rect">
             <a:avLst/>
@@ -9249,8 +9274,8 @@
         </p:nvSpPr>
         <p:spPr>
           <a:xfrm>
-            <a:off x="2834640" y="5321808"/>
-            <a:ext cx="2377440" cy="18288"/>
+            <a:off x="2606040" y="5102352"/>
+            <a:ext cx="2560320" cy="18288"/>
           </a:xfrm>
           <a:prstGeom prst="rect">
             <a:avLst/>
@@ -9292,8 +9317,8 @@
         </p:nvSpPr>
         <p:spPr>
           <a:xfrm>
-            <a:off x="2898648" y="5431536"/>
-            <a:ext cx="2249424" cy="320040"/>
+            <a:off x="2651760" y="5148072"/>
+            <a:ext cx="2468879" cy="429768"/>
           </a:xfrm>
           <a:prstGeom prst="rect">
             <a:avLst/>
@@ -9306,13 +9331,14 @@
           </a:bodyPr>
           <a:lstStyle/>
           <a:p>
+            <a:pPr algn="l"/>
             <a:r>
               <a:rPr sz="900">
                 <a:solidFill>
                   <a:srgbClr val="D0E4F7"/>
                 </a:solidFill>
               </a:rPr>
-              <a:t>extends Exception</a:t>
+              <a:t>  extends Exception</a:t>
             </a:r>
           </a:p>
         </p:txBody>
@@ -9325,14 +9351,14 @@
         </p:nvSpPr>
         <p:spPr>
           <a:xfrm>
-            <a:off x="5349240" y="5029200"/>
-            <a:ext cx="2377440" cy="777240"/>
+            <a:off x="5349240" y="4800600"/>
+            <a:ext cx="2651760" cy="804672"/>
           </a:xfrm>
           <a:prstGeom prst="rect">
             <a:avLst/>
           </a:prstGeom>
           <a:solidFill>
-            <a:srgbClr val="0A1420"/>
+            <a:srgbClr val="081222"/>
           </a:solidFill>
           <a:ln>
             <a:noFill/>
@@ -9368,8 +9394,8 @@
         </p:nvSpPr>
         <p:spPr>
           <a:xfrm>
-            <a:off x="5349240" y="5029200"/>
-            <a:ext cx="2377440" cy="292608"/>
+            <a:off x="5349240" y="4800600"/>
+            <a:ext cx="2651760" cy="301752"/>
           </a:xfrm>
           <a:prstGeom prst="rect">
             <a:avLst/>
@@ -9411,8 +9437,8 @@
         </p:nvSpPr>
         <p:spPr>
           <a:xfrm>
-            <a:off x="5349240" y="5084064"/>
-            <a:ext cx="2377440" cy="228600"/>
+            <a:off x="5349240" y="4855464"/>
+            <a:ext cx="2651760" cy="237744"/>
           </a:xfrm>
           <a:prstGeom prst="rect">
             <a:avLst/>
@@ -9445,8 +9471,8 @@
         </p:nvSpPr>
         <p:spPr>
           <a:xfrm>
-            <a:off x="5349240" y="5321808"/>
-            <a:ext cx="2377440" cy="18288"/>
+            <a:off x="5349240" y="5102352"/>
+            <a:ext cx="2651760" cy="18288"/>
           </a:xfrm>
           <a:prstGeom prst="rect">
             <a:avLst/>
@@ -9488,8 +9514,8 @@
         </p:nvSpPr>
         <p:spPr>
           <a:xfrm>
-            <a:off x="5413248" y="5431536"/>
-            <a:ext cx="2249424" cy="320040"/>
+            <a:off x="5394959" y="5148072"/>
+            <a:ext cx="2560320" cy="429768"/>
           </a:xfrm>
           <a:prstGeom prst="rect">
             <a:avLst/>
@@ -9502,383 +9528,34 @@
           </a:bodyPr>
           <a:lstStyle/>
           <a:p>
+            <a:pPr algn="l"/>
             <a:r>
               <a:rPr sz="900">
                 <a:solidFill>
                   <a:srgbClr val="D0E4F7"/>
                 </a:solidFill>
               </a:rPr>
-              <a:t>extends Exception</a:t>
-            </a:r>
-          </a:p>
-        </p:txBody>
-      </p:sp>
-      <p:cxnSp>
-        <p:nvCxnSpPr>
-          <p:cNvPr id="89" name="Connector 88"/>
-          <p:cNvCxnSpPr/>
-          <p:nvPr/>
-        </p:nvCxnSpPr>
-        <p:spPr>
-          <a:xfrm flipV="1">
-            <a:off x="1234440" y="2560320"/>
-            <a:ext cx="0" cy="1097280"/>
-          </a:xfrm>
-          <a:prstGeom prst="line">
-            <a:avLst/>
-          </a:prstGeom>
-          <a:ln w="15240">
-            <a:solidFill>
-              <a:srgbClr val="27AE60"/>
-            </a:solidFill>
-          </a:ln>
-        </p:spPr>
-        <p:style>
-          <a:lnRef idx="2">
-            <a:schemeClr val="accent1"/>
-          </a:lnRef>
-          <a:fillRef idx="0">
-            <a:schemeClr val="accent1"/>
-          </a:fillRef>
-          <a:effectRef idx="1">
-            <a:schemeClr val="accent1"/>
-          </a:effectRef>
-          <a:fontRef idx="minor">
-            <a:schemeClr val="tx1"/>
-          </a:fontRef>
-        </p:style>
-      </p:cxnSp>
-      <p:cxnSp>
-        <p:nvCxnSpPr>
-          <p:cNvPr id="90" name="Connector 89"/>
-          <p:cNvCxnSpPr/>
-          <p:nvPr/>
-        </p:nvCxnSpPr>
-        <p:spPr>
-          <a:xfrm flipH="1" flipV="1">
-            <a:off x="1234440" y="2560320"/>
-            <a:ext cx="2057399" cy="1097280"/>
-          </a:xfrm>
-          <a:prstGeom prst="line">
-            <a:avLst/>
-          </a:prstGeom>
-          <a:ln w="15240">
-            <a:solidFill>
-              <a:srgbClr val="27AE60"/>
-            </a:solidFill>
-          </a:ln>
-        </p:spPr>
-        <p:style>
-          <a:lnRef idx="2">
-            <a:schemeClr val="accent1"/>
-          </a:lnRef>
-          <a:fillRef idx="0">
-            <a:schemeClr val="accent1"/>
-          </a:fillRef>
-          <a:effectRef idx="1">
-            <a:schemeClr val="accent1"/>
-          </a:effectRef>
-          <a:fontRef idx="minor">
-            <a:schemeClr val="tx1"/>
-          </a:fontRef>
-        </p:style>
-      </p:cxnSp>
-      <p:cxnSp>
-        <p:nvCxnSpPr>
-          <p:cNvPr id="91" name="Connector 90"/>
-          <p:cNvCxnSpPr/>
-          <p:nvPr/>
-        </p:nvCxnSpPr>
-        <p:spPr>
-          <a:xfrm flipH="1" flipV="1">
-            <a:off x="1234440" y="2560320"/>
-            <a:ext cx="4069080" cy="1097280"/>
-          </a:xfrm>
-          <a:prstGeom prst="line">
-            <a:avLst/>
-          </a:prstGeom>
-          <a:ln w="15240">
-            <a:solidFill>
-              <a:srgbClr val="27AE60"/>
-            </a:solidFill>
-          </a:ln>
-        </p:spPr>
-        <p:style>
-          <a:lnRef idx="2">
-            <a:schemeClr val="accent1"/>
-          </a:lnRef>
-          <a:fillRef idx="0">
-            <a:schemeClr val="accent1"/>
-          </a:fillRef>
-          <a:effectRef idx="1">
-            <a:schemeClr val="accent1"/>
-          </a:effectRef>
-          <a:fontRef idx="minor">
-            <a:schemeClr val="tx1"/>
-          </a:fontRef>
-        </p:style>
-      </p:cxnSp>
-      <p:cxnSp>
-        <p:nvCxnSpPr>
-          <p:cNvPr id="92" name="Connector 91"/>
-          <p:cNvCxnSpPr/>
-          <p:nvPr/>
-        </p:nvCxnSpPr>
-        <p:spPr>
-          <a:xfrm flipH="1" flipV="1">
-            <a:off x="1234440" y="2560320"/>
-            <a:ext cx="5989319" cy="1097280"/>
-          </a:xfrm>
-          <a:prstGeom prst="line">
-            <a:avLst/>
-          </a:prstGeom>
-          <a:ln w="15240">
-            <a:solidFill>
-              <a:srgbClr val="27AE60"/>
-            </a:solidFill>
-          </a:ln>
-        </p:spPr>
-        <p:style>
-          <a:lnRef idx="2">
-            <a:schemeClr val="accent1"/>
-          </a:lnRef>
-          <a:fillRef idx="0">
-            <a:schemeClr val="accent1"/>
-          </a:fillRef>
-          <a:effectRef idx="1">
-            <a:schemeClr val="accent1"/>
-          </a:effectRef>
-          <a:fontRef idx="minor">
-            <a:schemeClr val="tx1"/>
-          </a:fontRef>
-        </p:style>
-      </p:cxnSp>
-      <p:cxnSp>
-        <p:nvCxnSpPr>
-          <p:cNvPr id="93" name="Connector 92"/>
-          <p:cNvCxnSpPr/>
-          <p:nvPr/>
-        </p:nvCxnSpPr>
-        <p:spPr>
-          <a:xfrm flipH="1" flipV="1">
-            <a:off x="1234440" y="2560320"/>
-            <a:ext cx="7818120" cy="1097280"/>
-          </a:xfrm>
-          <a:prstGeom prst="line">
-            <a:avLst/>
-          </a:prstGeom>
-          <a:ln w="15240">
-            <a:solidFill>
-              <a:srgbClr val="27AE60"/>
-            </a:solidFill>
-          </a:ln>
-        </p:spPr>
-        <p:style>
-          <a:lnRef idx="2">
-            <a:schemeClr val="accent1"/>
-          </a:lnRef>
-          <a:fillRef idx="0">
-            <a:schemeClr val="accent1"/>
-          </a:fillRef>
-          <a:effectRef idx="1">
-            <a:schemeClr val="accent1"/>
-          </a:effectRef>
-          <a:fontRef idx="minor">
-            <a:schemeClr val="tx1"/>
-          </a:fontRef>
-        </p:style>
-      </p:cxnSp>
-      <p:cxnSp>
-        <p:nvCxnSpPr>
-          <p:cNvPr id="94" name="Connector 93"/>
-          <p:cNvCxnSpPr/>
-          <p:nvPr/>
-        </p:nvCxnSpPr>
-        <p:spPr>
-          <a:xfrm flipH="1" flipV="1">
-            <a:off x="1234440" y="2560320"/>
-            <a:ext cx="9646920" cy="1097280"/>
-          </a:xfrm>
-          <a:prstGeom prst="line">
-            <a:avLst/>
-          </a:prstGeom>
-          <a:ln w="15240">
-            <a:solidFill>
-              <a:srgbClr val="27AE60"/>
-            </a:solidFill>
-          </a:ln>
-        </p:spPr>
-        <p:style>
-          <a:lnRef idx="2">
-            <a:schemeClr val="accent1"/>
-          </a:lnRef>
-          <a:fillRef idx="0">
-            <a:schemeClr val="accent1"/>
-          </a:fillRef>
-          <a:effectRef idx="1">
-            <a:schemeClr val="accent1"/>
-          </a:effectRef>
-          <a:fontRef idx="minor">
-            <a:schemeClr val="tx1"/>
-          </a:fontRef>
-        </p:style>
-      </p:cxnSp>
-      <p:cxnSp>
-        <p:nvCxnSpPr>
-          <p:cNvPr id="95" name="Connector 94"/>
-          <p:cNvCxnSpPr/>
-          <p:nvPr/>
-        </p:nvCxnSpPr>
-        <p:spPr>
-          <a:xfrm flipV="1">
-            <a:off x="3657600" y="2834640"/>
-            <a:ext cx="457200" cy="822960"/>
-          </a:xfrm>
-          <a:prstGeom prst="line">
-            <a:avLst/>
-          </a:prstGeom>
-          <a:ln w="15240">
-            <a:solidFill>
-              <a:srgbClr val="AA55DD"/>
-            </a:solidFill>
-          </a:ln>
-        </p:spPr>
-        <p:style>
-          <a:lnRef idx="2">
-            <a:schemeClr val="accent1"/>
-          </a:lnRef>
-          <a:fillRef idx="0">
-            <a:schemeClr val="accent1"/>
-          </a:fillRef>
-          <a:effectRef idx="1">
-            <a:schemeClr val="accent1"/>
-          </a:effectRef>
-          <a:fontRef idx="minor">
-            <a:schemeClr val="tx1"/>
-          </a:fontRef>
-        </p:style>
-      </p:cxnSp>
-      <p:cxnSp>
-        <p:nvCxnSpPr>
-          <p:cNvPr id="96" name="Connector 95"/>
-          <p:cNvCxnSpPr/>
-          <p:nvPr/>
-        </p:nvCxnSpPr>
-        <p:spPr>
-          <a:xfrm flipH="1" flipV="1">
-            <a:off x="4572000" y="2834640"/>
-            <a:ext cx="868680" cy="822960"/>
-          </a:xfrm>
-          <a:prstGeom prst="line">
-            <a:avLst/>
-          </a:prstGeom>
-          <a:ln w="15240">
-            <a:solidFill>
-              <a:srgbClr val="AA55DD"/>
-            </a:solidFill>
-          </a:ln>
-        </p:spPr>
-        <p:style>
-          <a:lnRef idx="2">
-            <a:schemeClr val="accent1"/>
-          </a:lnRef>
-          <a:fillRef idx="0">
-            <a:schemeClr val="accent1"/>
-          </a:fillRef>
-          <a:effectRef idx="1">
-            <a:schemeClr val="accent1"/>
-          </a:effectRef>
-          <a:fontRef idx="minor">
-            <a:schemeClr val="tx1"/>
-          </a:fontRef>
-        </p:style>
-      </p:cxnSp>
-      <p:cxnSp>
-        <p:nvCxnSpPr>
-          <p:cNvPr id="97" name="Connector 96"/>
-          <p:cNvCxnSpPr/>
-          <p:nvPr/>
-        </p:nvCxnSpPr>
-        <p:spPr>
-          <a:xfrm flipV="1">
-            <a:off x="7178040" y="2560320"/>
-            <a:ext cx="320039" cy="1097280"/>
-          </a:xfrm>
-          <a:prstGeom prst="line">
-            <a:avLst/>
-          </a:prstGeom>
-          <a:ln w="15240">
-            <a:solidFill>
-              <a:srgbClr val="AA55DD"/>
-            </a:solidFill>
-          </a:ln>
-        </p:spPr>
-        <p:style>
-          <a:lnRef idx="2">
-            <a:schemeClr val="accent1"/>
-          </a:lnRef>
-          <a:fillRef idx="0">
-            <a:schemeClr val="accent1"/>
-          </a:fillRef>
-          <a:effectRef idx="1">
-            <a:schemeClr val="accent1"/>
-          </a:effectRef>
-          <a:fontRef idx="minor">
-            <a:schemeClr val="tx1"/>
-          </a:fontRef>
-        </p:style>
-      </p:cxnSp>
-      <p:cxnSp>
-        <p:nvCxnSpPr>
-          <p:cNvPr id="98" name="Connector 97"/>
-          <p:cNvCxnSpPr/>
-          <p:nvPr/>
-        </p:nvCxnSpPr>
-        <p:spPr>
-          <a:xfrm flipH="1" flipV="1">
-            <a:off x="7863840" y="2560320"/>
-            <a:ext cx="822960" cy="1097280"/>
-          </a:xfrm>
-          <a:prstGeom prst="line">
-            <a:avLst/>
-          </a:prstGeom>
-          <a:ln w="15240">
-            <a:solidFill>
-              <a:srgbClr val="AA55DD"/>
-            </a:solidFill>
-          </a:ln>
-        </p:spPr>
-        <p:style>
-          <a:lnRef idx="2">
-            <a:schemeClr val="accent1"/>
-          </a:lnRef>
-          <a:fillRef idx="0">
-            <a:schemeClr val="accent1"/>
-          </a:fillRef>
-          <a:effectRef idx="1">
-            <a:schemeClr val="accent1"/>
-          </a:effectRef>
-          <a:fontRef idx="minor">
-            <a:schemeClr val="tx1"/>
-          </a:fontRef>
-        </p:style>
-      </p:cxnSp>
-      <p:sp>
-        <p:nvSpPr>
-          <p:cNvPr id="99" name="Rectangle 98"/>
+              <a:t>  extends Exception</a:t>
+            </a:r>
+          </a:p>
+        </p:txBody>
+      </p:sp>
+      <p:sp>
+        <p:nvSpPr>
+          <p:cNvPr id="89" name="Rectangle 88"/>
           <p:cNvSpPr/>
           <p:nvPr/>
         </p:nvSpPr>
         <p:spPr>
           <a:xfrm>
-            <a:off x="274320" y="6172200"/>
-            <a:ext cx="11612880" cy="502920"/>
+            <a:off x="228600" y="2926080"/>
+            <a:ext cx="11247120" cy="201168"/>
           </a:xfrm>
           <a:prstGeom prst="rect">
             <a:avLst/>
           </a:prstGeom>
           <a:solidFill>
-            <a:srgbClr val="08101A"/>
+            <a:srgbClr val="081222"/>
           </a:solidFill>
           <a:ln>
             <a:noFill/>
@@ -9908,14 +9585,14 @@
       </p:sp>
       <p:sp>
         <p:nvSpPr>
-          <p:cNvPr id="100" name="TextBox 99"/>
+          <p:cNvPr id="90" name="TextBox 89"/>
           <p:cNvSpPr txBox="1"/>
           <p:nvPr/>
         </p:nvSpPr>
         <p:spPr>
           <a:xfrm>
-            <a:off x="365760" y="6199632"/>
-            <a:ext cx="11430000" cy="411480"/>
+            <a:off x="274320" y="2944368"/>
+            <a:ext cx="11155680" cy="182880"/>
           </a:xfrm>
           <a:prstGeom prst="rect">
             <a:avLst/>
@@ -9928,14 +9605,378 @@
           </a:bodyPr>
           <a:lstStyle/>
           <a:p>
-            <a:pPr algn="r"/>
+            <a:pPr algn="l"/>
+            <a:r>
+              <a:rPr sz="800" b="0" i="0">
+                <a:solidFill>
+                  <a:srgbClr val="27AE60"/>
+                </a:solidFill>
+              </a:rPr>
+              <a:t>PropertyTile, ShuttleStation, StartTile, JailTile, AirportTile, WorldChamp.   implements →  Tile</a:t>
+            </a:r>
+          </a:p>
+        </p:txBody>
+      </p:sp>
+      <p:sp>
+        <p:nvSpPr>
+          <p:cNvPr id="91" name="Rectangle 90"/>
+          <p:cNvSpPr/>
+          <p:nvPr/>
+        </p:nvSpPr>
+        <p:spPr>
+          <a:xfrm>
+            <a:off x="228600" y="3154680"/>
+            <a:ext cx="11247120" cy="164592"/>
+          </a:xfrm>
+          <a:prstGeom prst="rect">
+            <a:avLst/>
+          </a:prstGeom>
+          <a:solidFill>
+            <a:srgbClr val="081222"/>
+          </a:solidFill>
+          <a:ln>
+            <a:noFill/>
+          </a:ln>
+        </p:spPr>
+        <p:style>
+          <a:lnRef idx="1">
+            <a:schemeClr val="accent1"/>
+          </a:lnRef>
+          <a:fillRef idx="3">
+            <a:schemeClr val="accent1"/>
+          </a:fillRef>
+          <a:effectRef idx="2">
+            <a:schemeClr val="accent1"/>
+          </a:effectRef>
+          <a:fontRef idx="minor">
+            <a:schemeClr val="lt1"/>
+          </a:fontRef>
+        </p:style>
+        <p:txBody>
+          <a:bodyPr rtlCol="0" anchor="ctr"/>
+          <a:lstStyle/>
+          <a:p>
+            <a:pPr algn="ctr"/>
+          </a:p>
+        </p:txBody>
+      </p:sp>
+      <p:sp>
+        <p:nvSpPr>
+          <p:cNvPr id="92" name="TextBox 91"/>
+          <p:cNvSpPr txBox="1"/>
+          <p:nvPr/>
+        </p:nvSpPr>
+        <p:spPr>
+          <a:xfrm>
+            <a:off x="274320" y="3163824"/>
+            <a:ext cx="11155680" cy="164592"/>
+          </a:xfrm>
+          <a:prstGeom prst="rect">
+            <a:avLst/>
+          </a:prstGeom>
+          <a:noFill/>
+        </p:spPr>
+        <p:txBody>
+          <a:bodyPr wrap="square">
+            <a:spAutoFit/>
+          </a:bodyPr>
+          <a:lstStyle/>
+          <a:p>
+            <a:pPr algn="l"/>
+            <a:r>
+              <a:rPr sz="800" b="0" i="0">
+                <a:solidFill>
+                  <a:srgbClr val="AA55DD"/>
+                </a:solidFill>
+              </a:rPr>
+              <a:t>HumanPlayer, BotPlayer   extends →  Player          |          BonusCard, PenaltyCard   extends →  EventCard</a:t>
+            </a:r>
+          </a:p>
+        </p:txBody>
+      </p:sp>
+      <p:sp>
+        <p:nvSpPr>
+          <p:cNvPr id="93" name="Rectangle 92"/>
+          <p:cNvSpPr/>
+          <p:nvPr/>
+        </p:nvSpPr>
+        <p:spPr>
+          <a:xfrm>
+            <a:off x="8549640" y="3337560"/>
+            <a:ext cx="3337560" cy="1325880"/>
+          </a:xfrm>
+          <a:prstGeom prst="rect">
+            <a:avLst/>
+          </a:prstGeom>
+          <a:solidFill>
+            <a:srgbClr val="081222"/>
+          </a:solidFill>
+          <a:ln>
+            <a:noFill/>
+          </a:ln>
+        </p:spPr>
+        <p:style>
+          <a:lnRef idx="1">
+            <a:schemeClr val="accent1"/>
+          </a:lnRef>
+          <a:fillRef idx="3">
+            <a:schemeClr val="accent1"/>
+          </a:fillRef>
+          <a:effectRef idx="2">
+            <a:schemeClr val="accent1"/>
+          </a:effectRef>
+          <a:fontRef idx="minor">
+            <a:schemeClr val="lt1"/>
+          </a:fontRef>
+        </p:style>
+        <p:txBody>
+          <a:bodyPr rtlCol="0" anchor="ctr"/>
+          <a:lstStyle/>
+          <a:p>
+            <a:pPr algn="ctr"/>
+          </a:p>
+        </p:txBody>
+      </p:sp>
+      <p:sp>
+        <p:nvSpPr>
+          <p:cNvPr id="94" name="Rectangle 93"/>
+          <p:cNvSpPr/>
+          <p:nvPr/>
+        </p:nvSpPr>
+        <p:spPr>
+          <a:xfrm>
+            <a:off x="8549640" y="3337560"/>
+            <a:ext cx="3337560" cy="301752"/>
+          </a:xfrm>
+          <a:prstGeom prst="rect">
+            <a:avLst/>
+          </a:prstGeom>
+          <a:solidFill>
+            <a:srgbClr val="1B6CA8"/>
+          </a:solidFill>
+          <a:ln>
+            <a:noFill/>
+          </a:ln>
+        </p:spPr>
+        <p:style>
+          <a:lnRef idx="1">
+            <a:schemeClr val="accent1"/>
+          </a:lnRef>
+          <a:fillRef idx="3">
+            <a:schemeClr val="accent1"/>
+          </a:fillRef>
+          <a:effectRef idx="2">
+            <a:schemeClr val="accent1"/>
+          </a:effectRef>
+          <a:fontRef idx="minor">
+            <a:schemeClr val="lt1"/>
+          </a:fontRef>
+        </p:style>
+        <p:txBody>
+          <a:bodyPr rtlCol="0" anchor="ctr"/>
+          <a:lstStyle/>
+          <a:p>
+            <a:pPr algn="ctr"/>
+          </a:p>
+        </p:txBody>
+      </p:sp>
+      <p:sp>
+        <p:nvSpPr>
+          <p:cNvPr id="95" name="TextBox 94"/>
+          <p:cNvSpPr txBox="1"/>
+          <p:nvPr/>
+        </p:nvSpPr>
+        <p:spPr>
+          <a:xfrm>
+            <a:off x="8549640" y="3364992"/>
+            <a:ext cx="3337560" cy="256032"/>
+          </a:xfrm>
+          <a:prstGeom prst="rect">
+            <a:avLst/>
+          </a:prstGeom>
+          <a:noFill/>
+        </p:spPr>
+        <p:txBody>
+          <a:bodyPr wrap="square">
+            <a:spAutoFit/>
+          </a:bodyPr>
+          <a:lstStyle/>
+          <a:p>
+            <a:pPr algn="ctr"/>
+            <a:r>
+              <a:rPr sz="1100" b="1" i="0">
+                <a:solidFill>
+                  <a:srgbClr val="FFFFFF"/>
+                </a:solidFill>
+              </a:rPr>
+              <a:t>Board</a:t>
+            </a:r>
+          </a:p>
+        </p:txBody>
+      </p:sp>
+      <p:sp>
+        <p:nvSpPr>
+          <p:cNvPr id="96" name="TextBox 95"/>
+          <p:cNvSpPr txBox="1"/>
+          <p:nvPr/>
+        </p:nvSpPr>
+        <p:spPr>
+          <a:xfrm>
+            <a:off x="8595360" y="3703320"/>
+            <a:ext cx="3246120" cy="868680"/>
+          </a:xfrm>
+          <a:prstGeom prst="rect">
+            <a:avLst/>
+          </a:prstGeom>
+          <a:noFill/>
+        </p:spPr>
+        <p:txBody>
+          <a:bodyPr wrap="square">
+            <a:spAutoFit/>
+          </a:bodyPr>
+          <a:lstStyle/>
+          <a:p>
+            <a:pPr algn="l"/>
+            <a:r>
+              <a:rPr sz="1000">
+                <a:solidFill>
+                  <a:srgbClr val="D0E4F7"/>
+                </a:solidFill>
+              </a:rPr>
+              <a:t>  ArrayList&lt;Tile&gt;  (36 tiles)</a:t>
+            </a:r>
+          </a:p>
+          <a:p>
+            <a:pPr algn="l"/>
+            <a:r>
+              <a:rPr sz="1000">
+                <a:solidFill>
+                  <a:srgbClr val="D0E4F7"/>
+                </a:solidFill>
+              </a:rPr>
+              <a:t>  getTile(position)</a:t>
+            </a:r>
+          </a:p>
+          <a:p>
+            <a:pPr algn="l"/>
+            <a:r>
+              <a:rPr sz="1000">
+                <a:solidFill>
+                  <a:srgbClr val="D0E4F7"/>
+                </a:solidFill>
+              </a:rPr>
+              <a:t>  getSize()</a:t>
+            </a:r>
+          </a:p>
+        </p:txBody>
+      </p:sp>
+      <p:sp>
+        <p:nvSpPr>
+          <p:cNvPr id="97" name="Rectangle 96"/>
+          <p:cNvSpPr/>
+          <p:nvPr/>
+        </p:nvSpPr>
+        <p:spPr>
+          <a:xfrm>
+            <a:off x="228600" y="6144768"/>
+            <a:ext cx="11750040" cy="530352"/>
+          </a:xfrm>
+          <a:prstGeom prst="rect">
+            <a:avLst/>
+          </a:prstGeom>
+          <a:solidFill>
+            <a:srgbClr val="060E1A"/>
+          </a:solidFill>
+          <a:ln>
+            <a:noFill/>
+          </a:ln>
+        </p:spPr>
+        <p:style>
+          <a:lnRef idx="1">
+            <a:schemeClr val="accent1"/>
+          </a:lnRef>
+          <a:fillRef idx="3">
+            <a:schemeClr val="accent1"/>
+          </a:fillRef>
+          <a:effectRef idx="2">
+            <a:schemeClr val="accent1"/>
+          </a:effectRef>
+          <a:fontRef idx="minor">
+            <a:schemeClr val="lt1"/>
+          </a:fontRef>
+        </p:style>
+        <p:txBody>
+          <a:bodyPr rtlCol="0" anchor="ctr"/>
+          <a:lstStyle/>
+          <a:p>
+            <a:pPr algn="ctr"/>
+          </a:p>
+        </p:txBody>
+      </p:sp>
+      <p:sp>
+        <p:nvSpPr>
+          <p:cNvPr id="98" name="TextBox 97"/>
+          <p:cNvSpPr txBox="1"/>
+          <p:nvPr/>
+        </p:nvSpPr>
+        <p:spPr>
+          <a:xfrm>
+            <a:off x="365760" y="6181344"/>
+            <a:ext cx="11430000" cy="228600"/>
+          </a:xfrm>
+          <a:prstGeom prst="rect">
+            <a:avLst/>
+          </a:prstGeom>
+          <a:noFill/>
+        </p:spPr>
+        <p:txBody>
+          <a:bodyPr wrap="square">
+            <a:spAutoFit/>
+          </a:bodyPr>
+          <a:lstStyle/>
+          <a:p>
+            <a:pPr algn="l"/>
             <a:r>
               <a:rPr sz="1000" b="0" i="0">
                 <a:solidFill>
                   <a:srgbClr val="8A9BAD"/>
                 </a:solidFill>
               </a:rPr>
-              <a:t>■ ממשק (ירוק)    ■ אבסטרקטי (סגול)    ■ קונקרטי (כחול)    ■ חריגה (אדום)    ← implements    ← extends</a:t>
+              <a:t>■ Interface (green)   ■ Abstract (purple)   ■ Concrete class (blue/green)   ■ Exception (red)</a:t>
+            </a:r>
+          </a:p>
+        </p:txBody>
+      </p:sp>
+      <p:sp>
+        <p:nvSpPr>
+          <p:cNvPr id="99" name="TextBox 98"/>
+          <p:cNvSpPr txBox="1"/>
+          <p:nvPr/>
+        </p:nvSpPr>
+        <p:spPr>
+          <a:xfrm>
+            <a:off x="365760" y="6382512"/>
+            <a:ext cx="11430000" cy="228600"/>
+          </a:xfrm>
+          <a:prstGeom prst="rect">
+            <a:avLst/>
+          </a:prstGeom>
+          <a:noFill/>
+        </p:spPr>
+        <p:txBody>
+          <a:bodyPr wrap="square">
+            <a:spAutoFit/>
+          </a:bodyPr>
+          <a:lstStyle/>
+          <a:p>
+            <a:pPr algn="l"/>
+            <a:r>
+              <a:rPr sz="900" b="0" i="1">
+                <a:solidFill>
+                  <a:srgbClr val="8A9BAD"/>
+                </a:solidFill>
+              </a:rPr>
+              <a:t>Relationships shown as text labels above each row to avoid layout issues</a:t>
             </a:r>
           </a:p>
         </p:txBody>

</xml_diff>

<commit_message>
Update presentation with fixed UML slide layout
</commit_message>
<xml_diff>
--- a/University_Tour_Presentation.pptx
+++ b/University_Tour_Presentation.pptx
@@ -7052,8 +7052,85 @@
         </p:nvSpPr>
         <p:spPr>
           <a:xfrm>
-            <a:off x="228600" y="3337560"/>
-            <a:ext cx="1920240" cy="1371600"/>
+            <a:off x="228600" y="2907792"/>
+            <a:ext cx="11750040" cy="228600"/>
+          </a:xfrm>
+          <a:prstGeom prst="rect">
+            <a:avLst/>
+          </a:prstGeom>
+          <a:solidFill>
+            <a:srgbClr val="061006"/>
+          </a:solidFill>
+          <a:ln>
+            <a:noFill/>
+          </a:ln>
+        </p:spPr>
+        <p:style>
+          <a:lnRef idx="1">
+            <a:schemeClr val="accent1"/>
+          </a:lnRef>
+          <a:fillRef idx="3">
+            <a:schemeClr val="accent1"/>
+          </a:fillRef>
+          <a:effectRef idx="2">
+            <a:schemeClr val="accent1"/>
+          </a:effectRef>
+          <a:fontRef idx="minor">
+            <a:schemeClr val="lt1"/>
+          </a:fontRef>
+        </p:style>
+        <p:txBody>
+          <a:bodyPr rtlCol="0" anchor="ctr"/>
+          <a:lstStyle/>
+          <a:p>
+            <a:pPr algn="ctr"/>
+          </a:p>
+        </p:txBody>
+      </p:sp>
+      <p:sp>
+        <p:nvSpPr>
+          <p:cNvPr id="30" name="TextBox 29"/>
+          <p:cNvSpPr txBox="1"/>
+          <p:nvPr/>
+        </p:nvSpPr>
+        <p:spPr>
+          <a:xfrm>
+            <a:off x="274320" y="2926080"/>
+            <a:ext cx="4572000" cy="201168"/>
+          </a:xfrm>
+          <a:prstGeom prst="rect">
+            <a:avLst/>
+          </a:prstGeom>
+          <a:noFill/>
+        </p:spPr>
+        <p:txBody>
+          <a:bodyPr wrap="square">
+            <a:spAutoFit/>
+          </a:bodyPr>
+          <a:lstStyle/>
+          <a:p>
+            <a:pPr algn="l"/>
+            <a:r>
+              <a:rPr sz="900" b="0" i="1">
+                <a:solidFill>
+                  <a:srgbClr val="27AE60"/>
+                </a:solidFill>
+              </a:rPr>
+              <a:t>implements  Tile ↓</a:t>
+            </a:r>
+          </a:p>
+        </p:txBody>
+      </p:sp>
+      <p:sp>
+        <p:nvSpPr>
+          <p:cNvPr id="31" name="Rectangle 30"/>
+          <p:cNvSpPr/>
+          <p:nvPr/>
+        </p:nvSpPr>
+        <p:spPr>
+          <a:xfrm>
+            <a:off x="228600" y="3154680"/>
+            <a:ext cx="1828800" cy="1261872"/>
           </a:xfrm>
           <a:prstGeom prst="rect">
             <a:avLst/>
@@ -7089,14 +7166,14 @@
       </p:sp>
       <p:sp>
         <p:nvSpPr>
-          <p:cNvPr id="30" name="Rectangle 29"/>
+          <p:cNvPr id="32" name="Rectangle 31"/>
           <p:cNvSpPr/>
           <p:nvPr/>
         </p:nvSpPr>
         <p:spPr>
           <a:xfrm>
-            <a:off x="228600" y="3337560"/>
-            <a:ext cx="1920240" cy="301752"/>
+            <a:off x="228600" y="3154680"/>
+            <a:ext cx="1828800" cy="301752"/>
           </a:xfrm>
           <a:prstGeom prst="rect">
             <a:avLst/>
@@ -7132,14 +7209,14 @@
       </p:sp>
       <p:sp>
         <p:nvSpPr>
-          <p:cNvPr id="31" name="TextBox 30"/>
+          <p:cNvPr id="33" name="TextBox 32"/>
           <p:cNvSpPr txBox="1"/>
           <p:nvPr/>
         </p:nvSpPr>
         <p:spPr>
           <a:xfrm>
-            <a:off x="228600" y="3392424"/>
-            <a:ext cx="1920240" cy="237744"/>
+            <a:off x="228600" y="3209544"/>
+            <a:ext cx="1828800" cy="237744"/>
           </a:xfrm>
           <a:prstGeom prst="rect">
             <a:avLst/>
@@ -7166,14 +7243,14 @@
       </p:sp>
       <p:sp>
         <p:nvSpPr>
-          <p:cNvPr id="32" name="Rectangle 31"/>
+          <p:cNvPr id="34" name="Rectangle 33"/>
           <p:cNvSpPr/>
           <p:nvPr/>
         </p:nvSpPr>
         <p:spPr>
           <a:xfrm>
-            <a:off x="228600" y="3639312"/>
-            <a:ext cx="1920240" cy="18288"/>
+            <a:off x="228600" y="3456432"/>
+            <a:ext cx="1828800" cy="18288"/>
           </a:xfrm>
           <a:prstGeom prst="rect">
             <a:avLst/>
@@ -7209,14 +7286,14 @@
       </p:sp>
       <p:sp>
         <p:nvSpPr>
-          <p:cNvPr id="33" name="TextBox 32"/>
+          <p:cNvPr id="35" name="TextBox 34"/>
           <p:cNvSpPr txBox="1"/>
           <p:nvPr/>
         </p:nvSpPr>
         <p:spPr>
           <a:xfrm>
-            <a:off x="274320" y="3685032"/>
-            <a:ext cx="1828800" cy="996695"/>
+            <a:off x="274320" y="3502152"/>
+            <a:ext cx="1737360" cy="886967"/>
           </a:xfrm>
           <a:prstGeom prst="rect">
             <a:avLst/>
@@ -7236,7 +7313,7 @@
                   <a:srgbClr val="D0E4F7"/>
                 </a:solidFill>
               </a:rPr>
-              <a:t>  owner, level, price</a:t>
+              <a:t>  owner, level</a:t>
             </a:r>
           </a:p>
           <a:p>
@@ -7261,29 +7338,18 @@
               <a:t>  + chargeRent()</a:t>
             </a:r>
           </a:p>
-          <a:p>
-            <a:pPr algn="l"/>
-            <a:r>
-              <a:rPr sz="900">
-                <a:solidFill>
-                  <a:srgbClr val="D0E4F7"/>
-                </a:solidFill>
-              </a:rPr>
-              <a:t>  + offerUpgrade()</a:t>
-            </a:r>
-          </a:p>
-        </p:txBody>
-      </p:sp>
-      <p:sp>
-        <p:nvSpPr>
-          <p:cNvPr id="34" name="Rectangle 33"/>
+        </p:txBody>
+      </p:sp>
+      <p:sp>
+        <p:nvSpPr>
+          <p:cNvPr id="36" name="Rectangle 35"/>
           <p:cNvSpPr/>
           <p:nvPr/>
         </p:nvSpPr>
         <p:spPr>
           <a:xfrm>
-            <a:off x="2240280" y="3337560"/>
-            <a:ext cx="1920240" cy="1371600"/>
+            <a:off x="2121408" y="3154680"/>
+            <a:ext cx="1828800" cy="1261872"/>
           </a:xfrm>
           <a:prstGeom prst="rect">
             <a:avLst/>
@@ -7319,14 +7385,14 @@
       </p:sp>
       <p:sp>
         <p:nvSpPr>
-          <p:cNvPr id="35" name="Rectangle 34"/>
+          <p:cNvPr id="37" name="Rectangle 36"/>
           <p:cNvSpPr/>
           <p:nvPr/>
         </p:nvSpPr>
         <p:spPr>
           <a:xfrm>
-            <a:off x="2240280" y="3337560"/>
-            <a:ext cx="1920240" cy="301752"/>
+            <a:off x="2121408" y="3154680"/>
+            <a:ext cx="1828800" cy="301752"/>
           </a:xfrm>
           <a:prstGeom prst="rect">
             <a:avLst/>
@@ -7362,14 +7428,14 @@
       </p:sp>
       <p:sp>
         <p:nvSpPr>
-          <p:cNvPr id="36" name="TextBox 35"/>
+          <p:cNvPr id="38" name="TextBox 37"/>
           <p:cNvSpPr txBox="1"/>
           <p:nvPr/>
         </p:nvSpPr>
         <p:spPr>
           <a:xfrm>
-            <a:off x="2240280" y="3392424"/>
-            <a:ext cx="1920240" cy="237744"/>
+            <a:off x="2121408" y="3209544"/>
+            <a:ext cx="1828800" cy="237744"/>
           </a:xfrm>
           <a:prstGeom prst="rect">
             <a:avLst/>
@@ -7389,21 +7455,21 @@
                   <a:srgbClr val="FFFFFF"/>
                 </a:solidFill>
               </a:rPr>
-              <a:t>ShuttleStation</a:t>
-            </a:r>
-          </a:p>
-        </p:txBody>
-      </p:sp>
-      <p:sp>
-        <p:nvSpPr>
-          <p:cNvPr id="37" name="Rectangle 36"/>
+              <a:t>ShuttleStn.</a:t>
+            </a:r>
+          </a:p>
+        </p:txBody>
+      </p:sp>
+      <p:sp>
+        <p:nvSpPr>
+          <p:cNvPr id="39" name="Rectangle 38"/>
           <p:cNvSpPr/>
           <p:nvPr/>
         </p:nvSpPr>
         <p:spPr>
           <a:xfrm>
-            <a:off x="2240280" y="3639312"/>
-            <a:ext cx="1920240" cy="18288"/>
+            <a:off x="2121408" y="3456432"/>
+            <a:ext cx="1828800" cy="18288"/>
           </a:xfrm>
           <a:prstGeom prst="rect">
             <a:avLst/>
@@ -7439,14 +7505,14 @@
       </p:sp>
       <p:sp>
         <p:nvSpPr>
-          <p:cNvPr id="38" name="TextBox 37"/>
+          <p:cNvPr id="40" name="TextBox 39"/>
           <p:cNvSpPr txBox="1"/>
           <p:nvPr/>
         </p:nvSpPr>
         <p:spPr>
           <a:xfrm>
-            <a:off x="2286000" y="3685032"/>
-            <a:ext cx="1828800" cy="996695"/>
+            <a:off x="2167127" y="3502152"/>
+            <a:ext cx="1737360" cy="886967"/>
           </a:xfrm>
           <a:prstGeom prst="rect">
             <a:avLst/>
@@ -7466,7 +7532,7 @@
                   <a:srgbClr val="D0E4F7"/>
                 </a:solidFill>
               </a:rPr>
-              <a:t>  owner, RENT[]</a:t>
+              <a:t>  RENT[4]</a:t>
             </a:r>
           </a:p>
           <a:p>
@@ -7488,21 +7554,21 @@
                   <a:srgbClr val="D0E4F7"/>
                 </a:solidFill>
               </a:rPr>
-              <a:t>  + getCurrentRent()</a:t>
-            </a:r>
-          </a:p>
-        </p:txBody>
-      </p:sp>
-      <p:sp>
-        <p:nvSpPr>
-          <p:cNvPr id="39" name="Rectangle 38"/>
+              <a:t>  + getRent()</a:t>
+            </a:r>
+          </a:p>
+        </p:txBody>
+      </p:sp>
+      <p:sp>
+        <p:nvSpPr>
+          <p:cNvPr id="41" name="Rectangle 40"/>
           <p:cNvSpPr/>
           <p:nvPr/>
         </p:nvSpPr>
         <p:spPr>
           <a:xfrm>
-            <a:off x="4160520" y="3337560"/>
-            <a:ext cx="1920240" cy="1371600"/>
+            <a:off x="4014215" y="3154680"/>
+            <a:ext cx="1828800" cy="1261872"/>
           </a:xfrm>
           <a:prstGeom prst="rect">
             <a:avLst/>
@@ -7538,14 +7604,14 @@
       </p:sp>
       <p:sp>
         <p:nvSpPr>
-          <p:cNvPr id="40" name="Rectangle 39"/>
+          <p:cNvPr id="42" name="Rectangle 41"/>
           <p:cNvSpPr/>
           <p:nvPr/>
         </p:nvSpPr>
         <p:spPr>
           <a:xfrm>
-            <a:off x="4160520" y="3337560"/>
-            <a:ext cx="1920240" cy="301752"/>
+            <a:off x="4014215" y="3154680"/>
+            <a:ext cx="1828800" cy="301752"/>
           </a:xfrm>
           <a:prstGeom prst="rect">
             <a:avLst/>
@@ -7581,14 +7647,14 @@
       </p:sp>
       <p:sp>
         <p:nvSpPr>
-          <p:cNvPr id="41" name="TextBox 40"/>
+          <p:cNvPr id="43" name="TextBox 42"/>
           <p:cNvSpPr txBox="1"/>
           <p:nvPr/>
         </p:nvSpPr>
         <p:spPr>
           <a:xfrm>
-            <a:off x="4160520" y="3392424"/>
-            <a:ext cx="1920240" cy="237744"/>
+            <a:off x="4014215" y="3209544"/>
+            <a:ext cx="1828800" cy="237744"/>
           </a:xfrm>
           <a:prstGeom prst="rect">
             <a:avLst/>
@@ -7615,14 +7681,14 @@
       </p:sp>
       <p:sp>
         <p:nvSpPr>
-          <p:cNvPr id="42" name="Rectangle 41"/>
+          <p:cNvPr id="44" name="Rectangle 43"/>
           <p:cNvSpPr/>
           <p:nvPr/>
         </p:nvSpPr>
         <p:spPr>
           <a:xfrm>
-            <a:off x="4160520" y="3639312"/>
-            <a:ext cx="1920240" cy="18288"/>
+            <a:off x="4014215" y="3456432"/>
+            <a:ext cx="1828800" cy="18288"/>
           </a:xfrm>
           <a:prstGeom prst="rect">
             <a:avLst/>
@@ -7658,14 +7724,14 @@
       </p:sp>
       <p:sp>
         <p:nvSpPr>
-          <p:cNvPr id="43" name="TextBox 42"/>
+          <p:cNvPr id="45" name="TextBox 44"/>
           <p:cNvSpPr txBox="1"/>
           <p:nvPr/>
         </p:nvSpPr>
         <p:spPr>
           <a:xfrm>
-            <a:off x="4206240" y="3685032"/>
-            <a:ext cx="1828800" cy="996695"/>
+            <a:off x="4059935" y="3502152"/>
+            <a:ext cx="1737360" cy="886967"/>
           </a:xfrm>
           <a:prstGeom prst="rect">
             <a:avLst/>
@@ -7703,14 +7769,14 @@
       </p:sp>
       <p:sp>
         <p:nvSpPr>
-          <p:cNvPr id="44" name="Rectangle 43"/>
+          <p:cNvPr id="46" name="Rectangle 45"/>
           <p:cNvSpPr/>
           <p:nvPr/>
         </p:nvSpPr>
         <p:spPr>
           <a:xfrm>
-            <a:off x="5989320" y="3337560"/>
-            <a:ext cx="1920240" cy="1371600"/>
+            <a:off x="5907023" y="3154680"/>
+            <a:ext cx="1828800" cy="1261872"/>
           </a:xfrm>
           <a:prstGeom prst="rect">
             <a:avLst/>
@@ -7746,14 +7812,14 @@
       </p:sp>
       <p:sp>
         <p:nvSpPr>
-          <p:cNvPr id="45" name="Rectangle 44"/>
+          <p:cNvPr id="47" name="Rectangle 46"/>
           <p:cNvSpPr/>
           <p:nvPr/>
         </p:nvSpPr>
         <p:spPr>
           <a:xfrm>
-            <a:off x="5989320" y="3337560"/>
-            <a:ext cx="1920240" cy="301752"/>
+            <a:off x="5907023" y="3154680"/>
+            <a:ext cx="1828800" cy="301752"/>
           </a:xfrm>
           <a:prstGeom prst="rect">
             <a:avLst/>
@@ -7789,14 +7855,14 @@
       </p:sp>
       <p:sp>
         <p:nvSpPr>
-          <p:cNvPr id="46" name="TextBox 45"/>
+          <p:cNvPr id="48" name="TextBox 47"/>
           <p:cNvSpPr txBox="1"/>
           <p:nvPr/>
         </p:nvSpPr>
         <p:spPr>
           <a:xfrm>
-            <a:off x="5989320" y="3392424"/>
-            <a:ext cx="1920240" cy="237744"/>
+            <a:off x="5907023" y="3209544"/>
+            <a:ext cx="1828800" cy="237744"/>
           </a:xfrm>
           <a:prstGeom prst="rect">
             <a:avLst/>
@@ -7823,14 +7889,14 @@
       </p:sp>
       <p:sp>
         <p:nvSpPr>
-          <p:cNvPr id="47" name="Rectangle 46"/>
+          <p:cNvPr id="49" name="Rectangle 48"/>
           <p:cNvSpPr/>
           <p:nvPr/>
         </p:nvSpPr>
         <p:spPr>
           <a:xfrm>
-            <a:off x="5989320" y="3639312"/>
-            <a:ext cx="1920240" cy="18288"/>
+            <a:off x="5907023" y="3456432"/>
+            <a:ext cx="1828800" cy="18288"/>
           </a:xfrm>
           <a:prstGeom prst="rect">
             <a:avLst/>
@@ -7866,14 +7932,14 @@
       </p:sp>
       <p:sp>
         <p:nvSpPr>
-          <p:cNvPr id="48" name="TextBox 47"/>
+          <p:cNvPr id="50" name="TextBox 49"/>
           <p:cNvSpPr txBox="1"/>
           <p:nvPr/>
         </p:nvSpPr>
         <p:spPr>
           <a:xfrm>
-            <a:off x="6035040" y="3685032"/>
-            <a:ext cx="1828800" cy="996695"/>
+            <a:off x="5952743" y="3502152"/>
+            <a:ext cx="1737360" cy="886967"/>
           </a:xfrm>
           <a:prstGeom prst="rect">
             <a:avLst/>
@@ -7900,14 +7966,14 @@
       </p:sp>
       <p:sp>
         <p:nvSpPr>
-          <p:cNvPr id="49" name="Rectangle 48"/>
+          <p:cNvPr id="51" name="Rectangle 50"/>
           <p:cNvSpPr/>
           <p:nvPr/>
         </p:nvSpPr>
         <p:spPr>
           <a:xfrm>
-            <a:off x="7726679" y="3337560"/>
-            <a:ext cx="1920240" cy="1371600"/>
+            <a:off x="7799831" y="3154680"/>
+            <a:ext cx="1828800" cy="1261872"/>
           </a:xfrm>
           <a:prstGeom prst="rect">
             <a:avLst/>
@@ -7943,14 +8009,14 @@
       </p:sp>
       <p:sp>
         <p:nvSpPr>
-          <p:cNvPr id="50" name="Rectangle 49"/>
+          <p:cNvPr id="52" name="Rectangle 51"/>
           <p:cNvSpPr/>
           <p:nvPr/>
         </p:nvSpPr>
         <p:spPr>
           <a:xfrm>
-            <a:off x="7726679" y="3337560"/>
-            <a:ext cx="1920240" cy="301752"/>
+            <a:off x="7799831" y="3154680"/>
+            <a:ext cx="1828800" cy="301752"/>
           </a:xfrm>
           <a:prstGeom prst="rect">
             <a:avLst/>
@@ -7986,14 +8052,14 @@
       </p:sp>
       <p:sp>
         <p:nvSpPr>
-          <p:cNvPr id="51" name="TextBox 50"/>
+          <p:cNvPr id="53" name="TextBox 52"/>
           <p:cNvSpPr txBox="1"/>
           <p:nvPr/>
         </p:nvSpPr>
         <p:spPr>
           <a:xfrm>
-            <a:off x="7726679" y="3392424"/>
-            <a:ext cx="1920240" cy="237744"/>
+            <a:off x="7799831" y="3209544"/>
+            <a:ext cx="1828800" cy="237744"/>
           </a:xfrm>
           <a:prstGeom prst="rect">
             <a:avLst/>
@@ -8020,14 +8086,14 @@
       </p:sp>
       <p:sp>
         <p:nvSpPr>
-          <p:cNvPr id="52" name="Rectangle 51"/>
+          <p:cNvPr id="54" name="Rectangle 53"/>
           <p:cNvSpPr/>
           <p:nvPr/>
         </p:nvSpPr>
         <p:spPr>
           <a:xfrm>
-            <a:off x="7726679" y="3639312"/>
-            <a:ext cx="1920240" cy="18288"/>
+            <a:off x="7799831" y="3456432"/>
+            <a:ext cx="1828800" cy="18288"/>
           </a:xfrm>
           <a:prstGeom prst="rect">
             <a:avLst/>
@@ -8063,14 +8129,14 @@
       </p:sp>
       <p:sp>
         <p:nvSpPr>
-          <p:cNvPr id="53" name="TextBox 52"/>
+          <p:cNvPr id="55" name="TextBox 54"/>
           <p:cNvSpPr txBox="1"/>
           <p:nvPr/>
         </p:nvSpPr>
         <p:spPr>
           <a:xfrm>
-            <a:off x="7772400" y="3685032"/>
-            <a:ext cx="1828800" cy="996695"/>
+            <a:off x="7845552" y="3502152"/>
+            <a:ext cx="1737360" cy="886967"/>
           </a:xfrm>
           <a:prstGeom prst="rect">
             <a:avLst/>
@@ -8108,14 +8174,14 @@
       </p:sp>
       <p:sp>
         <p:nvSpPr>
-          <p:cNvPr id="54" name="Rectangle 53"/>
+          <p:cNvPr id="56" name="Rectangle 55"/>
           <p:cNvSpPr/>
           <p:nvPr/>
         </p:nvSpPr>
         <p:spPr>
           <a:xfrm>
-            <a:off x="9555480" y="3337560"/>
-            <a:ext cx="1920240" cy="1371600"/>
+            <a:off x="9692640" y="3154680"/>
+            <a:ext cx="1828800" cy="1261872"/>
           </a:xfrm>
           <a:prstGeom prst="rect">
             <a:avLst/>
@@ -8151,14 +8217,14 @@
       </p:sp>
       <p:sp>
         <p:nvSpPr>
-          <p:cNvPr id="55" name="Rectangle 54"/>
+          <p:cNvPr id="57" name="Rectangle 56"/>
           <p:cNvSpPr/>
           <p:nvPr/>
         </p:nvSpPr>
         <p:spPr>
           <a:xfrm>
-            <a:off x="9555480" y="3337560"/>
-            <a:ext cx="1920240" cy="301752"/>
+            <a:off x="9692640" y="3154680"/>
+            <a:ext cx="1828800" cy="301752"/>
           </a:xfrm>
           <a:prstGeom prst="rect">
             <a:avLst/>
@@ -8194,14 +8260,14 @@
       </p:sp>
       <p:sp>
         <p:nvSpPr>
-          <p:cNvPr id="56" name="TextBox 55"/>
+          <p:cNvPr id="58" name="TextBox 57"/>
           <p:cNvSpPr txBox="1"/>
           <p:nvPr/>
         </p:nvSpPr>
         <p:spPr>
           <a:xfrm>
-            <a:off x="9555480" y="3392424"/>
-            <a:ext cx="1920240" cy="237744"/>
+            <a:off x="9692640" y="3209544"/>
+            <a:ext cx="1828800" cy="237744"/>
           </a:xfrm>
           <a:prstGeom prst="rect">
             <a:avLst/>
@@ -8228,14 +8294,14 @@
       </p:sp>
       <p:sp>
         <p:nvSpPr>
-          <p:cNvPr id="57" name="Rectangle 56"/>
+          <p:cNvPr id="59" name="Rectangle 58"/>
           <p:cNvSpPr/>
           <p:nvPr/>
         </p:nvSpPr>
         <p:spPr>
           <a:xfrm>
-            <a:off x="9555480" y="3639312"/>
-            <a:ext cx="1920240" cy="18288"/>
+            <a:off x="9692640" y="3456432"/>
+            <a:ext cx="1828800" cy="18288"/>
           </a:xfrm>
           <a:prstGeom prst="rect">
             <a:avLst/>
@@ -8271,14 +8337,14 @@
       </p:sp>
       <p:sp>
         <p:nvSpPr>
-          <p:cNvPr id="58" name="TextBox 57"/>
+          <p:cNvPr id="60" name="TextBox 59"/>
           <p:cNvSpPr txBox="1"/>
           <p:nvPr/>
         </p:nvSpPr>
         <p:spPr>
           <a:xfrm>
-            <a:off x="9601200" y="3685032"/>
-            <a:ext cx="1828800" cy="996695"/>
+            <a:off x="9738360" y="3502152"/>
+            <a:ext cx="1737360" cy="886967"/>
           </a:xfrm>
           <a:prstGeom prst="rect">
             <a:avLst/>
@@ -8298,7 +8364,7 @@
                   <a:srgbClr val="D0E4F7"/>
                 </a:solidFill>
               </a:rPr>
-              <a:t>  static multiplier</a:t>
+              <a:t>  multiplier</a:t>
             </a:r>
           </a:p>
           <a:p>
@@ -8316,14 +8382,125 @@
       </p:sp>
       <p:sp>
         <p:nvSpPr>
-          <p:cNvPr id="59" name="Rectangle 58"/>
+          <p:cNvPr id="61" name="Rectangle 60"/>
           <p:cNvSpPr/>
           <p:nvPr/>
         </p:nvSpPr>
         <p:spPr>
           <a:xfrm>
-            <a:off x="2606040" y="3337560"/>
-            <a:ext cx="1691640" cy="1051560"/>
+            <a:off x="228600" y="4462272"/>
+            <a:ext cx="11750040" cy="228600"/>
+          </a:xfrm>
+          <a:prstGeom prst="rect">
+            <a:avLst/>
+          </a:prstGeom>
+          <a:solidFill>
+            <a:srgbClr val="080610"/>
+          </a:solidFill>
+          <a:ln>
+            <a:noFill/>
+          </a:ln>
+        </p:spPr>
+        <p:style>
+          <a:lnRef idx="1">
+            <a:schemeClr val="accent1"/>
+          </a:lnRef>
+          <a:fillRef idx="3">
+            <a:schemeClr val="accent1"/>
+          </a:fillRef>
+          <a:effectRef idx="2">
+            <a:schemeClr val="accent1"/>
+          </a:effectRef>
+          <a:fontRef idx="minor">
+            <a:schemeClr val="lt1"/>
+          </a:fontRef>
+        </p:style>
+        <p:txBody>
+          <a:bodyPr rtlCol="0" anchor="ctr"/>
+          <a:lstStyle/>
+          <a:p>
+            <a:pPr algn="ctr"/>
+          </a:p>
+        </p:txBody>
+      </p:sp>
+      <p:sp>
+        <p:nvSpPr>
+          <p:cNvPr id="62" name="TextBox 61"/>
+          <p:cNvSpPr txBox="1"/>
+          <p:nvPr/>
+        </p:nvSpPr>
+        <p:spPr>
+          <a:xfrm>
+            <a:off x="274320" y="4480560"/>
+            <a:ext cx="3657600" cy="201168"/>
+          </a:xfrm>
+          <a:prstGeom prst="rect">
+            <a:avLst/>
+          </a:prstGeom>
+          <a:noFill/>
+        </p:spPr>
+        <p:txBody>
+          <a:bodyPr wrap="square">
+            <a:spAutoFit/>
+          </a:bodyPr>
+          <a:lstStyle/>
+          <a:p>
+            <a:pPr algn="l"/>
+            <a:r>
+              <a:rPr sz="900" b="0" i="1">
+                <a:solidFill>
+                  <a:srgbClr val="AA55DD"/>
+                </a:solidFill>
+              </a:rPr>
+              <a:t>extends  Player ↓</a:t>
+            </a:r>
+          </a:p>
+        </p:txBody>
+      </p:sp>
+      <p:sp>
+        <p:nvSpPr>
+          <p:cNvPr id="63" name="TextBox 62"/>
+          <p:cNvSpPr txBox="1"/>
+          <p:nvPr/>
+        </p:nvSpPr>
+        <p:spPr>
+          <a:xfrm>
+            <a:off x="5029200" y="4480560"/>
+            <a:ext cx="3657600" cy="201168"/>
+          </a:xfrm>
+          <a:prstGeom prst="rect">
+            <a:avLst/>
+          </a:prstGeom>
+          <a:noFill/>
+        </p:spPr>
+        <p:txBody>
+          <a:bodyPr wrap="square">
+            <a:spAutoFit/>
+          </a:bodyPr>
+          <a:lstStyle/>
+          <a:p>
+            <a:pPr algn="l"/>
+            <a:r>
+              <a:rPr sz="900" b="0" i="1">
+                <a:solidFill>
+                  <a:srgbClr val="AA55DD"/>
+                </a:solidFill>
+              </a:rPr>
+              <a:t>extends  EventCard ↓</a:t>
+            </a:r>
+          </a:p>
+        </p:txBody>
+      </p:sp>
+      <p:sp>
+        <p:nvSpPr>
+          <p:cNvPr id="64" name="Rectangle 63"/>
+          <p:cNvSpPr/>
+          <p:nvPr/>
+        </p:nvSpPr>
+        <p:spPr>
+          <a:xfrm>
+            <a:off x="228600" y="4709160"/>
+            <a:ext cx="2011680" cy="1005840"/>
           </a:xfrm>
           <a:prstGeom prst="rect">
             <a:avLst/>
@@ -8359,14 +8536,14 @@
       </p:sp>
       <p:sp>
         <p:nvSpPr>
-          <p:cNvPr id="60" name="Rectangle 59"/>
+          <p:cNvPr id="65" name="Rectangle 64"/>
           <p:cNvSpPr/>
           <p:nvPr/>
         </p:nvSpPr>
         <p:spPr>
           <a:xfrm>
-            <a:off x="2606040" y="3337560"/>
-            <a:ext cx="1691640" cy="301752"/>
+            <a:off x="228600" y="4709160"/>
+            <a:ext cx="2011680" cy="301752"/>
           </a:xfrm>
           <a:prstGeom prst="rect">
             <a:avLst/>
@@ -8402,14 +8579,14 @@
       </p:sp>
       <p:sp>
         <p:nvSpPr>
-          <p:cNvPr id="61" name="TextBox 60"/>
+          <p:cNvPr id="66" name="TextBox 65"/>
           <p:cNvSpPr txBox="1"/>
           <p:nvPr/>
         </p:nvSpPr>
         <p:spPr>
           <a:xfrm>
-            <a:off x="2606040" y="3392424"/>
-            <a:ext cx="1691640" cy="237744"/>
+            <a:off x="228600" y="4764024"/>
+            <a:ext cx="2011680" cy="237744"/>
           </a:xfrm>
           <a:prstGeom prst="rect">
             <a:avLst/>
@@ -8436,14 +8613,14 @@
       </p:sp>
       <p:sp>
         <p:nvSpPr>
-          <p:cNvPr id="62" name="Rectangle 61"/>
+          <p:cNvPr id="67" name="Rectangle 66"/>
           <p:cNvSpPr/>
           <p:nvPr/>
         </p:nvSpPr>
         <p:spPr>
           <a:xfrm>
-            <a:off x="2606040" y="3639312"/>
-            <a:ext cx="1691640" cy="18288"/>
+            <a:off x="228600" y="5010912"/>
+            <a:ext cx="2011680" cy="18288"/>
           </a:xfrm>
           <a:prstGeom prst="rect">
             <a:avLst/>
@@ -8479,14 +8656,14 @@
       </p:sp>
       <p:sp>
         <p:nvSpPr>
-          <p:cNvPr id="63" name="TextBox 62"/>
+          <p:cNvPr id="68" name="TextBox 67"/>
           <p:cNvSpPr txBox="1"/>
           <p:nvPr/>
         </p:nvSpPr>
         <p:spPr>
           <a:xfrm>
-            <a:off x="2651760" y="3685032"/>
-            <a:ext cx="1600200" cy="676655"/>
+            <a:off x="274320" y="5056632"/>
+            <a:ext cx="1920240" cy="630936"/>
           </a:xfrm>
           <a:prstGeom prst="rect">
             <a:avLst/>
@@ -8517,21 +8694,21 @@
                   <a:srgbClr val="D0E4F7"/>
                 </a:solidFill>
               </a:rPr>
-              <a:t>  + trySellToP…()</a:t>
-            </a:r>
-          </a:p>
-        </p:txBody>
-      </p:sp>
-      <p:sp>
-        <p:nvSpPr>
-          <p:cNvPr id="64" name="Rectangle 63"/>
+              <a:t>  + trySell…()</a:t>
+            </a:r>
+          </a:p>
+        </p:txBody>
+      </p:sp>
+      <p:sp>
+        <p:nvSpPr>
+          <p:cNvPr id="69" name="Rectangle 68"/>
           <p:cNvSpPr/>
           <p:nvPr/>
         </p:nvSpPr>
         <p:spPr>
           <a:xfrm>
-            <a:off x="4389120" y="3337560"/>
-            <a:ext cx="1600200" cy="1005840"/>
+            <a:off x="2331720" y="4709160"/>
+            <a:ext cx="1920240" cy="1005840"/>
           </a:xfrm>
           <a:prstGeom prst="rect">
             <a:avLst/>
@@ -8567,14 +8744,14 @@
       </p:sp>
       <p:sp>
         <p:nvSpPr>
-          <p:cNvPr id="65" name="Rectangle 64"/>
+          <p:cNvPr id="70" name="Rectangle 69"/>
           <p:cNvSpPr/>
           <p:nvPr/>
         </p:nvSpPr>
         <p:spPr>
           <a:xfrm>
-            <a:off x="4389120" y="3337560"/>
-            <a:ext cx="1600200" cy="301752"/>
+            <a:off x="2331720" y="4709160"/>
+            <a:ext cx="1920240" cy="301752"/>
           </a:xfrm>
           <a:prstGeom prst="rect">
             <a:avLst/>
@@ -8610,14 +8787,14 @@
       </p:sp>
       <p:sp>
         <p:nvSpPr>
-          <p:cNvPr id="66" name="TextBox 65"/>
+          <p:cNvPr id="71" name="TextBox 70"/>
           <p:cNvSpPr txBox="1"/>
           <p:nvPr/>
         </p:nvSpPr>
         <p:spPr>
           <a:xfrm>
-            <a:off x="4389120" y="3392424"/>
-            <a:ext cx="1600200" cy="237744"/>
+            <a:off x="2331720" y="4764024"/>
+            <a:ext cx="1920240" cy="237744"/>
           </a:xfrm>
           <a:prstGeom prst="rect">
             <a:avLst/>
@@ -8644,14 +8821,14 @@
       </p:sp>
       <p:sp>
         <p:nvSpPr>
-          <p:cNvPr id="67" name="Rectangle 66"/>
+          <p:cNvPr id="72" name="Rectangle 71"/>
           <p:cNvSpPr/>
           <p:nvPr/>
         </p:nvSpPr>
         <p:spPr>
           <a:xfrm>
-            <a:off x="4389120" y="3639312"/>
-            <a:ext cx="1600200" cy="18288"/>
+            <a:off x="2331720" y="5010912"/>
+            <a:ext cx="1920240" cy="18288"/>
           </a:xfrm>
           <a:prstGeom prst="rect">
             <a:avLst/>
@@ -8687,14 +8864,14 @@
       </p:sp>
       <p:sp>
         <p:nvSpPr>
-          <p:cNvPr id="68" name="TextBox 67"/>
+          <p:cNvPr id="73" name="TextBox 72"/>
           <p:cNvSpPr txBox="1"/>
           <p:nvPr/>
         </p:nvSpPr>
         <p:spPr>
           <a:xfrm>
-            <a:off x="4434840" y="3685032"/>
-            <a:ext cx="1508760" cy="630936"/>
+            <a:off x="2377439" y="5056632"/>
+            <a:ext cx="1828800" cy="630936"/>
           </a:xfrm>
           <a:prstGeom prst="rect">
             <a:avLst/>
@@ -8732,14 +8909,14 @@
       </p:sp>
       <p:sp>
         <p:nvSpPr>
-          <p:cNvPr id="69" name="Rectangle 68"/>
+          <p:cNvPr id="74" name="Rectangle 73"/>
           <p:cNvSpPr/>
           <p:nvPr/>
         </p:nvSpPr>
         <p:spPr>
           <a:xfrm>
-            <a:off x="5989320" y="3337560"/>
-            <a:ext cx="1554480" cy="914400"/>
+            <a:off x="4754880" y="4709160"/>
+            <a:ext cx="1828800" cy="1005840"/>
           </a:xfrm>
           <a:prstGeom prst="rect">
             <a:avLst/>
@@ -8775,14 +8952,14 @@
       </p:sp>
       <p:sp>
         <p:nvSpPr>
-          <p:cNvPr id="70" name="Rectangle 69"/>
+          <p:cNvPr id="75" name="Rectangle 74"/>
           <p:cNvSpPr/>
           <p:nvPr/>
         </p:nvSpPr>
         <p:spPr>
           <a:xfrm>
-            <a:off x="5989320" y="3337560"/>
-            <a:ext cx="1554480" cy="301752"/>
+            <a:off x="4754880" y="4709160"/>
+            <a:ext cx="1828800" cy="301752"/>
           </a:xfrm>
           <a:prstGeom prst="rect">
             <a:avLst/>
@@ -8818,14 +8995,14 @@
       </p:sp>
       <p:sp>
         <p:nvSpPr>
-          <p:cNvPr id="71" name="TextBox 70"/>
+          <p:cNvPr id="76" name="TextBox 75"/>
           <p:cNvSpPr txBox="1"/>
           <p:nvPr/>
         </p:nvSpPr>
         <p:spPr>
           <a:xfrm>
-            <a:off x="5989320" y="3392424"/>
-            <a:ext cx="1554480" cy="237744"/>
+            <a:off x="4754880" y="4764024"/>
+            <a:ext cx="1828800" cy="237744"/>
           </a:xfrm>
           <a:prstGeom prst="rect">
             <a:avLst/>
@@ -8852,14 +9029,14 @@
       </p:sp>
       <p:sp>
         <p:nvSpPr>
-          <p:cNvPr id="72" name="Rectangle 71"/>
+          <p:cNvPr id="77" name="Rectangle 76"/>
           <p:cNvSpPr/>
           <p:nvPr/>
         </p:nvSpPr>
         <p:spPr>
           <a:xfrm>
-            <a:off x="5989320" y="3639312"/>
-            <a:ext cx="1554480" cy="18288"/>
+            <a:off x="4754880" y="5010912"/>
+            <a:ext cx="1828800" cy="18288"/>
           </a:xfrm>
           <a:prstGeom prst="rect">
             <a:avLst/>
@@ -8895,14 +9072,14 @@
       </p:sp>
       <p:sp>
         <p:nvSpPr>
-          <p:cNvPr id="73" name="TextBox 72"/>
+          <p:cNvPr id="78" name="TextBox 77"/>
           <p:cNvSpPr txBox="1"/>
           <p:nvPr/>
         </p:nvSpPr>
         <p:spPr>
           <a:xfrm>
-            <a:off x="6035040" y="3685032"/>
-            <a:ext cx="1463039" cy="539496"/>
+            <a:off x="4800600" y="5056632"/>
+            <a:ext cx="1737360" cy="630936"/>
           </a:xfrm>
           <a:prstGeom prst="rect">
             <a:avLst/>
@@ -8940,14 +9117,14 @@
       </p:sp>
       <p:sp>
         <p:nvSpPr>
-          <p:cNvPr id="74" name="Rectangle 73"/>
+          <p:cNvPr id="79" name="Rectangle 78"/>
           <p:cNvSpPr/>
           <p:nvPr/>
         </p:nvSpPr>
         <p:spPr>
           <a:xfrm>
-            <a:off x="7635240" y="3337560"/>
-            <a:ext cx="1645920" cy="914400"/>
+            <a:off x="6675120" y="4709160"/>
+            <a:ext cx="1920240" cy="1005840"/>
           </a:xfrm>
           <a:prstGeom prst="rect">
             <a:avLst/>
@@ -8983,14 +9160,14 @@
       </p:sp>
       <p:sp>
         <p:nvSpPr>
-          <p:cNvPr id="75" name="Rectangle 74"/>
+          <p:cNvPr id="80" name="Rectangle 79"/>
           <p:cNvSpPr/>
           <p:nvPr/>
         </p:nvSpPr>
         <p:spPr>
           <a:xfrm>
-            <a:off x="7635240" y="3337560"/>
-            <a:ext cx="1645920" cy="301752"/>
+            <a:off x="6675120" y="4709160"/>
+            <a:ext cx="1920240" cy="301752"/>
           </a:xfrm>
           <a:prstGeom prst="rect">
             <a:avLst/>
@@ -9026,14 +9203,14 @@
       </p:sp>
       <p:sp>
         <p:nvSpPr>
-          <p:cNvPr id="76" name="TextBox 75"/>
+          <p:cNvPr id="81" name="TextBox 80"/>
           <p:cNvSpPr txBox="1"/>
           <p:nvPr/>
         </p:nvSpPr>
         <p:spPr>
           <a:xfrm>
-            <a:off x="7635240" y="3392424"/>
-            <a:ext cx="1645920" cy="237744"/>
+            <a:off x="6675120" y="4764024"/>
+            <a:ext cx="1920240" cy="237744"/>
           </a:xfrm>
           <a:prstGeom prst="rect">
             <a:avLst/>
@@ -9060,14 +9237,14 @@
       </p:sp>
       <p:sp>
         <p:nvSpPr>
-          <p:cNvPr id="77" name="Rectangle 76"/>
+          <p:cNvPr id="82" name="Rectangle 81"/>
           <p:cNvSpPr/>
           <p:nvPr/>
         </p:nvSpPr>
         <p:spPr>
           <a:xfrm>
-            <a:off x="7635240" y="3639312"/>
-            <a:ext cx="1645920" cy="18288"/>
+            <a:off x="6675120" y="5010912"/>
+            <a:ext cx="1920240" cy="18288"/>
           </a:xfrm>
           <a:prstGeom prst="rect">
             <a:avLst/>
@@ -9103,14 +9280,14 @@
       </p:sp>
       <p:sp>
         <p:nvSpPr>
-          <p:cNvPr id="78" name="TextBox 77"/>
+          <p:cNvPr id="83" name="TextBox 82"/>
           <p:cNvSpPr txBox="1"/>
           <p:nvPr/>
         </p:nvSpPr>
         <p:spPr>
           <a:xfrm>
-            <a:off x="7680960" y="3685032"/>
-            <a:ext cx="1554480" cy="539496"/>
+            <a:off x="6720840" y="5056632"/>
+            <a:ext cx="1828800" cy="630936"/>
           </a:xfrm>
           <a:prstGeom prst="rect">
             <a:avLst/>
@@ -9148,14 +9325,14 @@
       </p:sp>
       <p:sp>
         <p:nvSpPr>
-          <p:cNvPr id="79" name="Rectangle 78"/>
+          <p:cNvPr id="84" name="Rectangle 83"/>
           <p:cNvSpPr/>
           <p:nvPr/>
         </p:nvSpPr>
         <p:spPr>
           <a:xfrm>
-            <a:off x="2606040" y="4800600"/>
-            <a:ext cx="2560320" cy="804672"/>
+            <a:off x="8869680" y="4709160"/>
+            <a:ext cx="3108960" cy="1005840"/>
           </a:xfrm>
           <a:prstGeom prst="rect">
             <a:avLst/>
@@ -9191,14 +9368,233 @@
       </p:sp>
       <p:sp>
         <p:nvSpPr>
-          <p:cNvPr id="80" name="Rectangle 79"/>
+          <p:cNvPr id="85" name="Rectangle 84"/>
           <p:cNvSpPr/>
           <p:nvPr/>
         </p:nvSpPr>
         <p:spPr>
           <a:xfrm>
-            <a:off x="2606040" y="4800600"/>
-            <a:ext cx="2560320" cy="301752"/>
+            <a:off x="8869680" y="4709160"/>
+            <a:ext cx="3108960" cy="301752"/>
+          </a:xfrm>
+          <a:prstGeom prst="rect">
+            <a:avLst/>
+          </a:prstGeom>
+          <a:solidFill>
+            <a:srgbClr val="1B6CA8"/>
+          </a:solidFill>
+          <a:ln>
+            <a:noFill/>
+          </a:ln>
+        </p:spPr>
+        <p:style>
+          <a:lnRef idx="1">
+            <a:schemeClr val="accent1"/>
+          </a:lnRef>
+          <a:fillRef idx="3">
+            <a:schemeClr val="accent1"/>
+          </a:fillRef>
+          <a:effectRef idx="2">
+            <a:schemeClr val="accent1"/>
+          </a:effectRef>
+          <a:fontRef idx="minor">
+            <a:schemeClr val="lt1"/>
+          </a:fontRef>
+        </p:style>
+        <p:txBody>
+          <a:bodyPr rtlCol="0" anchor="ctr"/>
+          <a:lstStyle/>
+          <a:p>
+            <a:pPr algn="ctr"/>
+          </a:p>
+        </p:txBody>
+      </p:sp>
+      <p:sp>
+        <p:nvSpPr>
+          <p:cNvPr id="86" name="TextBox 85"/>
+          <p:cNvSpPr txBox="1"/>
+          <p:nvPr/>
+        </p:nvSpPr>
+        <p:spPr>
+          <a:xfrm>
+            <a:off x="8869680" y="4764024"/>
+            <a:ext cx="3108960" cy="237744"/>
+          </a:xfrm>
+          <a:prstGeom prst="rect">
+            <a:avLst/>
+          </a:prstGeom>
+          <a:noFill/>
+        </p:spPr>
+        <p:txBody>
+          <a:bodyPr wrap="square">
+            <a:spAutoFit/>
+          </a:bodyPr>
+          <a:lstStyle/>
+          <a:p>
+            <a:pPr algn="ctr"/>
+            <a:r>
+              <a:rPr sz="1100" b="1" i="0">
+                <a:solidFill>
+                  <a:srgbClr val="FFFFFF"/>
+                </a:solidFill>
+              </a:rPr>
+              <a:t>Board</a:t>
+            </a:r>
+          </a:p>
+        </p:txBody>
+      </p:sp>
+      <p:sp>
+        <p:nvSpPr>
+          <p:cNvPr id="87" name="Rectangle 86"/>
+          <p:cNvSpPr/>
+          <p:nvPr/>
+        </p:nvSpPr>
+        <p:spPr>
+          <a:xfrm>
+            <a:off x="8869680" y="5010912"/>
+            <a:ext cx="3108960" cy="18288"/>
+          </a:xfrm>
+          <a:prstGeom prst="rect">
+            <a:avLst/>
+          </a:prstGeom>
+          <a:solidFill>
+            <a:srgbClr val="8A9BAD"/>
+          </a:solidFill>
+          <a:ln>
+            <a:noFill/>
+          </a:ln>
+        </p:spPr>
+        <p:style>
+          <a:lnRef idx="1">
+            <a:schemeClr val="accent1"/>
+          </a:lnRef>
+          <a:fillRef idx="3">
+            <a:schemeClr val="accent1"/>
+          </a:fillRef>
+          <a:effectRef idx="2">
+            <a:schemeClr val="accent1"/>
+          </a:effectRef>
+          <a:fontRef idx="minor">
+            <a:schemeClr val="lt1"/>
+          </a:fontRef>
+        </p:style>
+        <p:txBody>
+          <a:bodyPr rtlCol="0" anchor="ctr"/>
+          <a:lstStyle/>
+          <a:p>
+            <a:pPr algn="ctr"/>
+          </a:p>
+        </p:txBody>
+      </p:sp>
+      <p:sp>
+        <p:nvSpPr>
+          <p:cNvPr id="88" name="TextBox 87"/>
+          <p:cNvSpPr txBox="1"/>
+          <p:nvPr/>
+        </p:nvSpPr>
+        <p:spPr>
+          <a:xfrm>
+            <a:off x="8915400" y="5056632"/>
+            <a:ext cx="3017520" cy="630936"/>
+          </a:xfrm>
+          <a:prstGeom prst="rect">
+            <a:avLst/>
+          </a:prstGeom>
+          <a:noFill/>
+        </p:spPr>
+        <p:txBody>
+          <a:bodyPr wrap="square">
+            <a:spAutoFit/>
+          </a:bodyPr>
+          <a:lstStyle/>
+          <a:p>
+            <a:pPr algn="l"/>
+            <a:r>
+              <a:rPr sz="900">
+                <a:solidFill>
+                  <a:srgbClr val="D0E4F7"/>
+                </a:solidFill>
+              </a:rPr>
+              <a:t>  ArrayList&lt;Tile&gt; (36)</a:t>
+            </a:r>
+          </a:p>
+          <a:p>
+            <a:pPr algn="l"/>
+            <a:r>
+              <a:rPr sz="900">
+                <a:solidFill>
+                  <a:srgbClr val="D0E4F7"/>
+                </a:solidFill>
+              </a:rPr>
+              <a:t>  + getTile(pos)</a:t>
+            </a:r>
+          </a:p>
+          <a:p>
+            <a:pPr algn="l"/>
+            <a:r>
+              <a:rPr sz="900">
+                <a:solidFill>
+                  <a:srgbClr val="D0E4F7"/>
+                </a:solidFill>
+              </a:rPr>
+              <a:t>  + getSize()</a:t>
+            </a:r>
+          </a:p>
+        </p:txBody>
+      </p:sp>
+      <p:sp>
+        <p:nvSpPr>
+          <p:cNvPr id="89" name="Rectangle 88"/>
+          <p:cNvSpPr/>
+          <p:nvPr/>
+        </p:nvSpPr>
+        <p:spPr>
+          <a:xfrm>
+            <a:off x="228600" y="5833872"/>
+            <a:ext cx="2834640" cy="749808"/>
+          </a:xfrm>
+          <a:prstGeom prst="rect">
+            <a:avLst/>
+          </a:prstGeom>
+          <a:solidFill>
+            <a:srgbClr val="081222"/>
+          </a:solidFill>
+          <a:ln>
+            <a:noFill/>
+          </a:ln>
+        </p:spPr>
+        <p:style>
+          <a:lnRef idx="1">
+            <a:schemeClr val="accent1"/>
+          </a:lnRef>
+          <a:fillRef idx="3">
+            <a:schemeClr val="accent1"/>
+          </a:fillRef>
+          <a:effectRef idx="2">
+            <a:schemeClr val="accent1"/>
+          </a:effectRef>
+          <a:fontRef idx="minor">
+            <a:schemeClr val="lt1"/>
+          </a:fontRef>
+        </p:style>
+        <p:txBody>
+          <a:bodyPr rtlCol="0" anchor="ctr"/>
+          <a:lstStyle/>
+          <a:p>
+            <a:pPr algn="ctr"/>
+          </a:p>
+        </p:txBody>
+      </p:sp>
+      <p:sp>
+        <p:nvSpPr>
+          <p:cNvPr id="90" name="Rectangle 89"/>
+          <p:cNvSpPr/>
+          <p:nvPr/>
+        </p:nvSpPr>
+        <p:spPr>
+          <a:xfrm>
+            <a:off x="228600" y="5833872"/>
+            <a:ext cx="2834640" cy="301752"/>
           </a:xfrm>
           <a:prstGeom prst="rect">
             <a:avLst/>
@@ -9234,14 +9630,14 @@
       </p:sp>
       <p:sp>
         <p:nvSpPr>
-          <p:cNvPr id="81" name="TextBox 80"/>
+          <p:cNvPr id="91" name="TextBox 90"/>
           <p:cNvSpPr txBox="1"/>
           <p:nvPr/>
         </p:nvSpPr>
         <p:spPr>
           <a:xfrm>
-            <a:off x="2606040" y="4855464"/>
-            <a:ext cx="2560320" cy="237744"/>
+            <a:off x="228600" y="5888736"/>
+            <a:ext cx="2834640" cy="237744"/>
           </a:xfrm>
           <a:prstGeom prst="rect">
             <a:avLst/>
@@ -9268,14 +9664,14 @@
       </p:sp>
       <p:sp>
         <p:nvSpPr>
-          <p:cNvPr id="82" name="Rectangle 81"/>
+          <p:cNvPr id="92" name="Rectangle 91"/>
           <p:cNvSpPr/>
           <p:nvPr/>
         </p:nvSpPr>
         <p:spPr>
           <a:xfrm>
-            <a:off x="2606040" y="5102352"/>
-            <a:ext cx="2560320" cy="18288"/>
+            <a:off x="228600" y="6135624"/>
+            <a:ext cx="2834640" cy="18288"/>
           </a:xfrm>
           <a:prstGeom prst="rect">
             <a:avLst/>
@@ -9311,14 +9707,14 @@
       </p:sp>
       <p:sp>
         <p:nvSpPr>
-          <p:cNvPr id="83" name="TextBox 82"/>
+          <p:cNvPr id="93" name="TextBox 92"/>
           <p:cNvSpPr txBox="1"/>
           <p:nvPr/>
         </p:nvSpPr>
         <p:spPr>
           <a:xfrm>
-            <a:off x="2651760" y="5148072"/>
-            <a:ext cx="2468879" cy="429768"/>
+            <a:off x="274320" y="6181344"/>
+            <a:ext cx="2743200" cy="374903"/>
           </a:xfrm>
           <a:prstGeom prst="rect">
             <a:avLst/>
@@ -9345,14 +9741,14 @@
       </p:sp>
       <p:sp>
         <p:nvSpPr>
-          <p:cNvPr id="84" name="Rectangle 83"/>
+          <p:cNvPr id="94" name="Rectangle 93"/>
           <p:cNvSpPr/>
           <p:nvPr/>
         </p:nvSpPr>
         <p:spPr>
           <a:xfrm>
-            <a:off x="5349240" y="4800600"/>
-            <a:ext cx="2651760" cy="804672"/>
+            <a:off x="3154680" y="5833872"/>
+            <a:ext cx="2926080" cy="749808"/>
           </a:xfrm>
           <a:prstGeom prst="rect">
             <a:avLst/>
@@ -9388,14 +9784,14 @@
       </p:sp>
       <p:sp>
         <p:nvSpPr>
-          <p:cNvPr id="85" name="Rectangle 84"/>
+          <p:cNvPr id="95" name="Rectangle 94"/>
           <p:cNvSpPr/>
           <p:nvPr/>
         </p:nvSpPr>
         <p:spPr>
           <a:xfrm>
-            <a:off x="5349240" y="4800600"/>
-            <a:ext cx="2651760" cy="301752"/>
+            <a:off x="3154680" y="5833872"/>
+            <a:ext cx="2926080" cy="301752"/>
           </a:xfrm>
           <a:prstGeom prst="rect">
             <a:avLst/>
@@ -9431,14 +9827,14 @@
       </p:sp>
       <p:sp>
         <p:nvSpPr>
-          <p:cNvPr id="86" name="TextBox 85"/>
+          <p:cNvPr id="96" name="TextBox 95"/>
           <p:cNvSpPr txBox="1"/>
           <p:nvPr/>
         </p:nvSpPr>
         <p:spPr>
           <a:xfrm>
-            <a:off x="5349240" y="4855464"/>
-            <a:ext cx="2651760" cy="237744"/>
+            <a:off x="3154680" y="5888736"/>
+            <a:ext cx="2926080" cy="237744"/>
           </a:xfrm>
           <a:prstGeom prst="rect">
             <a:avLst/>
@@ -9465,14 +9861,14 @@
       </p:sp>
       <p:sp>
         <p:nvSpPr>
-          <p:cNvPr id="87" name="Rectangle 86"/>
+          <p:cNvPr id="97" name="Rectangle 96"/>
           <p:cNvSpPr/>
           <p:nvPr/>
         </p:nvSpPr>
         <p:spPr>
           <a:xfrm>
-            <a:off x="5349240" y="5102352"/>
-            <a:ext cx="2651760" cy="18288"/>
+            <a:off x="3154680" y="6135624"/>
+            <a:ext cx="2926080" cy="18288"/>
           </a:xfrm>
           <a:prstGeom prst="rect">
             <a:avLst/>
@@ -9508,14 +9904,14 @@
       </p:sp>
       <p:sp>
         <p:nvSpPr>
-          <p:cNvPr id="88" name="TextBox 87"/>
+          <p:cNvPr id="98" name="TextBox 97"/>
           <p:cNvSpPr txBox="1"/>
           <p:nvPr/>
         </p:nvSpPr>
         <p:spPr>
           <a:xfrm>
-            <a:off x="5394959" y="5148072"/>
-            <a:ext cx="2560320" cy="429768"/>
+            <a:off x="3200400" y="6181344"/>
+            <a:ext cx="2834640" cy="374903"/>
           </a:xfrm>
           <a:prstGeom prst="rect">
             <a:avLst/>
@@ -9542,344 +9938,14 @@
       </p:sp>
       <p:sp>
         <p:nvSpPr>
-          <p:cNvPr id="89" name="Rectangle 88"/>
+          <p:cNvPr id="99" name="Rectangle 98"/>
           <p:cNvSpPr/>
           <p:nvPr/>
         </p:nvSpPr>
         <p:spPr>
           <a:xfrm>
-            <a:off x="228600" y="2926080"/>
-            <a:ext cx="11247120" cy="201168"/>
-          </a:xfrm>
-          <a:prstGeom prst="rect">
-            <a:avLst/>
-          </a:prstGeom>
-          <a:solidFill>
-            <a:srgbClr val="081222"/>
-          </a:solidFill>
-          <a:ln>
-            <a:noFill/>
-          </a:ln>
-        </p:spPr>
-        <p:style>
-          <a:lnRef idx="1">
-            <a:schemeClr val="accent1"/>
-          </a:lnRef>
-          <a:fillRef idx="3">
-            <a:schemeClr val="accent1"/>
-          </a:fillRef>
-          <a:effectRef idx="2">
-            <a:schemeClr val="accent1"/>
-          </a:effectRef>
-          <a:fontRef idx="minor">
-            <a:schemeClr val="lt1"/>
-          </a:fontRef>
-        </p:style>
-        <p:txBody>
-          <a:bodyPr rtlCol="0" anchor="ctr"/>
-          <a:lstStyle/>
-          <a:p>
-            <a:pPr algn="ctr"/>
-          </a:p>
-        </p:txBody>
-      </p:sp>
-      <p:sp>
-        <p:nvSpPr>
-          <p:cNvPr id="90" name="TextBox 89"/>
-          <p:cNvSpPr txBox="1"/>
-          <p:nvPr/>
-        </p:nvSpPr>
-        <p:spPr>
-          <a:xfrm>
-            <a:off x="274320" y="2944368"/>
-            <a:ext cx="11155680" cy="182880"/>
-          </a:xfrm>
-          <a:prstGeom prst="rect">
-            <a:avLst/>
-          </a:prstGeom>
-          <a:noFill/>
-        </p:spPr>
-        <p:txBody>
-          <a:bodyPr wrap="square">
-            <a:spAutoFit/>
-          </a:bodyPr>
-          <a:lstStyle/>
-          <a:p>
-            <a:pPr algn="l"/>
-            <a:r>
-              <a:rPr sz="800" b="0" i="0">
-                <a:solidFill>
-                  <a:srgbClr val="27AE60"/>
-                </a:solidFill>
-              </a:rPr>
-              <a:t>PropertyTile, ShuttleStation, StartTile, JailTile, AirportTile, WorldChamp.   implements →  Tile</a:t>
-            </a:r>
-          </a:p>
-        </p:txBody>
-      </p:sp>
-      <p:sp>
-        <p:nvSpPr>
-          <p:cNvPr id="91" name="Rectangle 90"/>
-          <p:cNvSpPr/>
-          <p:nvPr/>
-        </p:nvSpPr>
-        <p:spPr>
-          <a:xfrm>
-            <a:off x="228600" y="3154680"/>
-            <a:ext cx="11247120" cy="164592"/>
-          </a:xfrm>
-          <a:prstGeom prst="rect">
-            <a:avLst/>
-          </a:prstGeom>
-          <a:solidFill>
-            <a:srgbClr val="081222"/>
-          </a:solidFill>
-          <a:ln>
-            <a:noFill/>
-          </a:ln>
-        </p:spPr>
-        <p:style>
-          <a:lnRef idx="1">
-            <a:schemeClr val="accent1"/>
-          </a:lnRef>
-          <a:fillRef idx="3">
-            <a:schemeClr val="accent1"/>
-          </a:fillRef>
-          <a:effectRef idx="2">
-            <a:schemeClr val="accent1"/>
-          </a:effectRef>
-          <a:fontRef idx="minor">
-            <a:schemeClr val="lt1"/>
-          </a:fontRef>
-        </p:style>
-        <p:txBody>
-          <a:bodyPr rtlCol="0" anchor="ctr"/>
-          <a:lstStyle/>
-          <a:p>
-            <a:pPr algn="ctr"/>
-          </a:p>
-        </p:txBody>
-      </p:sp>
-      <p:sp>
-        <p:nvSpPr>
-          <p:cNvPr id="92" name="TextBox 91"/>
-          <p:cNvSpPr txBox="1"/>
-          <p:nvPr/>
-        </p:nvSpPr>
-        <p:spPr>
-          <a:xfrm>
-            <a:off x="274320" y="3163824"/>
-            <a:ext cx="11155680" cy="164592"/>
-          </a:xfrm>
-          <a:prstGeom prst="rect">
-            <a:avLst/>
-          </a:prstGeom>
-          <a:noFill/>
-        </p:spPr>
-        <p:txBody>
-          <a:bodyPr wrap="square">
-            <a:spAutoFit/>
-          </a:bodyPr>
-          <a:lstStyle/>
-          <a:p>
-            <a:pPr algn="l"/>
-            <a:r>
-              <a:rPr sz="800" b="0" i="0">
-                <a:solidFill>
-                  <a:srgbClr val="AA55DD"/>
-                </a:solidFill>
-              </a:rPr>
-              <a:t>HumanPlayer, BotPlayer   extends →  Player          |          BonusCard, PenaltyCard   extends →  EventCard</a:t>
-            </a:r>
-          </a:p>
-        </p:txBody>
-      </p:sp>
-      <p:sp>
-        <p:nvSpPr>
-          <p:cNvPr id="93" name="Rectangle 92"/>
-          <p:cNvSpPr/>
-          <p:nvPr/>
-        </p:nvSpPr>
-        <p:spPr>
-          <a:xfrm>
-            <a:off x="8549640" y="3337560"/>
-            <a:ext cx="3337560" cy="1325880"/>
-          </a:xfrm>
-          <a:prstGeom prst="rect">
-            <a:avLst/>
-          </a:prstGeom>
-          <a:solidFill>
-            <a:srgbClr val="081222"/>
-          </a:solidFill>
-          <a:ln>
-            <a:noFill/>
-          </a:ln>
-        </p:spPr>
-        <p:style>
-          <a:lnRef idx="1">
-            <a:schemeClr val="accent1"/>
-          </a:lnRef>
-          <a:fillRef idx="3">
-            <a:schemeClr val="accent1"/>
-          </a:fillRef>
-          <a:effectRef idx="2">
-            <a:schemeClr val="accent1"/>
-          </a:effectRef>
-          <a:fontRef idx="minor">
-            <a:schemeClr val="lt1"/>
-          </a:fontRef>
-        </p:style>
-        <p:txBody>
-          <a:bodyPr rtlCol="0" anchor="ctr"/>
-          <a:lstStyle/>
-          <a:p>
-            <a:pPr algn="ctr"/>
-          </a:p>
-        </p:txBody>
-      </p:sp>
-      <p:sp>
-        <p:nvSpPr>
-          <p:cNvPr id="94" name="Rectangle 93"/>
-          <p:cNvSpPr/>
-          <p:nvPr/>
-        </p:nvSpPr>
-        <p:spPr>
-          <a:xfrm>
-            <a:off x="8549640" y="3337560"/>
-            <a:ext cx="3337560" cy="301752"/>
-          </a:xfrm>
-          <a:prstGeom prst="rect">
-            <a:avLst/>
-          </a:prstGeom>
-          <a:solidFill>
-            <a:srgbClr val="1B6CA8"/>
-          </a:solidFill>
-          <a:ln>
-            <a:noFill/>
-          </a:ln>
-        </p:spPr>
-        <p:style>
-          <a:lnRef idx="1">
-            <a:schemeClr val="accent1"/>
-          </a:lnRef>
-          <a:fillRef idx="3">
-            <a:schemeClr val="accent1"/>
-          </a:fillRef>
-          <a:effectRef idx="2">
-            <a:schemeClr val="accent1"/>
-          </a:effectRef>
-          <a:fontRef idx="minor">
-            <a:schemeClr val="lt1"/>
-          </a:fontRef>
-        </p:style>
-        <p:txBody>
-          <a:bodyPr rtlCol="0" anchor="ctr"/>
-          <a:lstStyle/>
-          <a:p>
-            <a:pPr algn="ctr"/>
-          </a:p>
-        </p:txBody>
-      </p:sp>
-      <p:sp>
-        <p:nvSpPr>
-          <p:cNvPr id="95" name="TextBox 94"/>
-          <p:cNvSpPr txBox="1"/>
-          <p:nvPr/>
-        </p:nvSpPr>
-        <p:spPr>
-          <a:xfrm>
-            <a:off x="8549640" y="3364992"/>
-            <a:ext cx="3337560" cy="256032"/>
-          </a:xfrm>
-          <a:prstGeom prst="rect">
-            <a:avLst/>
-          </a:prstGeom>
-          <a:noFill/>
-        </p:spPr>
-        <p:txBody>
-          <a:bodyPr wrap="square">
-            <a:spAutoFit/>
-          </a:bodyPr>
-          <a:lstStyle/>
-          <a:p>
-            <a:pPr algn="ctr"/>
-            <a:r>
-              <a:rPr sz="1100" b="1" i="0">
-                <a:solidFill>
-                  <a:srgbClr val="FFFFFF"/>
-                </a:solidFill>
-              </a:rPr>
-              <a:t>Board</a:t>
-            </a:r>
-          </a:p>
-        </p:txBody>
-      </p:sp>
-      <p:sp>
-        <p:nvSpPr>
-          <p:cNvPr id="96" name="TextBox 95"/>
-          <p:cNvSpPr txBox="1"/>
-          <p:nvPr/>
-        </p:nvSpPr>
-        <p:spPr>
-          <a:xfrm>
-            <a:off x="8595360" y="3703320"/>
-            <a:ext cx="3246120" cy="868680"/>
-          </a:xfrm>
-          <a:prstGeom prst="rect">
-            <a:avLst/>
-          </a:prstGeom>
-          <a:noFill/>
-        </p:spPr>
-        <p:txBody>
-          <a:bodyPr wrap="square">
-            <a:spAutoFit/>
-          </a:bodyPr>
-          <a:lstStyle/>
-          <a:p>
-            <a:pPr algn="l"/>
-            <a:r>
-              <a:rPr sz="1000">
-                <a:solidFill>
-                  <a:srgbClr val="D0E4F7"/>
-                </a:solidFill>
-              </a:rPr>
-              <a:t>  ArrayList&lt;Tile&gt;  (36 tiles)</a:t>
-            </a:r>
-          </a:p>
-          <a:p>
-            <a:pPr algn="l"/>
-            <a:r>
-              <a:rPr sz="1000">
-                <a:solidFill>
-                  <a:srgbClr val="D0E4F7"/>
-                </a:solidFill>
-              </a:rPr>
-              <a:t>  getTile(position)</a:t>
-            </a:r>
-          </a:p>
-          <a:p>
-            <a:pPr algn="l"/>
-            <a:r>
-              <a:rPr sz="1000">
-                <a:solidFill>
-                  <a:srgbClr val="D0E4F7"/>
-                </a:solidFill>
-              </a:rPr>
-              <a:t>  getSize()</a:t>
-            </a:r>
-          </a:p>
-        </p:txBody>
-      </p:sp>
-      <p:sp>
-        <p:nvSpPr>
-          <p:cNvPr id="97" name="Rectangle 96"/>
-          <p:cNvSpPr/>
-          <p:nvPr/>
-        </p:nvSpPr>
-        <p:spPr>
-          <a:xfrm>
-            <a:off x="228600" y="6144768"/>
-            <a:ext cx="11750040" cy="530352"/>
+            <a:off x="6583680" y="5833872"/>
+            <a:ext cx="5394960" cy="749808"/>
           </a:xfrm>
           <a:prstGeom prst="rect">
             <a:avLst/>
@@ -9915,14 +9981,14 @@
       </p:sp>
       <p:sp>
         <p:nvSpPr>
-          <p:cNvPr id="98" name="TextBox 97"/>
+          <p:cNvPr id="100" name="TextBox 99"/>
           <p:cNvSpPr txBox="1"/>
           <p:nvPr/>
         </p:nvSpPr>
         <p:spPr>
           <a:xfrm>
-            <a:off x="365760" y="6181344"/>
-            <a:ext cx="11430000" cy="228600"/>
+            <a:off x="6675120" y="5852160"/>
+            <a:ext cx="5212080" cy="713232"/>
           </a:xfrm>
           <a:prstGeom prst="rect">
             <a:avLst/>
@@ -9942,41 +10008,8 @@
                   <a:srgbClr val="8A9BAD"/>
                 </a:solidFill>
               </a:rPr>
-              <a:t>■ Interface (green)   ■ Abstract (purple)   ■ Concrete class (blue/green)   ■ Exception (red)</a:t>
-            </a:r>
-          </a:p>
-        </p:txBody>
-      </p:sp>
-      <p:sp>
-        <p:nvSpPr>
-          <p:cNvPr id="99" name="TextBox 98"/>
-          <p:cNvSpPr txBox="1"/>
-          <p:nvPr/>
-        </p:nvSpPr>
-        <p:spPr>
-          <a:xfrm>
-            <a:off x="365760" y="6382512"/>
-            <a:ext cx="11430000" cy="228600"/>
-          </a:xfrm>
-          <a:prstGeom prst="rect">
-            <a:avLst/>
-          </a:prstGeom>
-          <a:noFill/>
-        </p:spPr>
-        <p:txBody>
-          <a:bodyPr wrap="square">
-            <a:spAutoFit/>
-          </a:bodyPr>
-          <a:lstStyle/>
-          <a:p>
-            <a:pPr algn="l"/>
-            <a:r>
-              <a:rPr sz="900" b="0" i="1">
-                <a:solidFill>
-                  <a:srgbClr val="8A9BAD"/>
-                </a:solidFill>
-              </a:rPr>
-              <a:t>Relationships shown as text labels above each row to avoid layout issues</a:t>
+              <a:t>■ Interface (green)  ■ Abstract (purple)
+■ Concrete (blue/green)  ■ Exception (red)</a:t>
             </a:r>
           </a:p>
         </p:txBody>

</xml_diff>